<commit_message>
chore: daily sync 2026-08-17
</commit_message>
<xml_diff>
--- a/decks/Balkanea-Mobile-Sandbox-Readiness-Update.pptx
+++ b/decks/Balkanea-Mobile-Sandbox-Readiness-Update.pptx
@@ -311,7 +311,7 @@
           <a:p>
             <a:fld id="{5BCAD085-E8A6-8845-BD4E-CB4CCA059FC4}" type="datetimeFigureOut">
               <a:rPr lang="en-US" smtClean="0"/>
-              <a:t>8/14/2026</a:t>
+              <a:t>8/17/2026</a:t>
             </a:fld>
             <a:endParaRPr lang="en-US"/>
           </a:p>
@@ -479,7 +479,7 @@
           <a:p>
             <a:fld id="{5BCAD085-E8A6-8845-BD4E-CB4CCA059FC4}" type="datetimeFigureOut">
               <a:rPr lang="en-US" smtClean="0"/>
-              <a:t>8/14/2026</a:t>
+              <a:t>8/17/2026</a:t>
             </a:fld>
             <a:endParaRPr lang="en-US"/>
           </a:p>
@@ -657,7 +657,7 @@
           <a:p>
             <a:fld id="{5BCAD085-E8A6-8845-BD4E-CB4CCA059FC4}" type="datetimeFigureOut">
               <a:rPr lang="en-US" smtClean="0"/>
-              <a:t>8/14/2026</a:t>
+              <a:t>8/17/2026</a:t>
             </a:fld>
             <a:endParaRPr lang="en-US"/>
           </a:p>
@@ -825,7 +825,7 @@
           <a:p>
             <a:fld id="{5BCAD085-E8A6-8845-BD4E-CB4CCA059FC4}" type="datetimeFigureOut">
               <a:rPr lang="en-US" smtClean="0"/>
-              <a:t>8/14/2026</a:t>
+              <a:t>8/17/2026</a:t>
             </a:fld>
             <a:endParaRPr lang="en-US"/>
           </a:p>
@@ -1070,7 +1070,7 @@
           <a:p>
             <a:fld id="{5BCAD085-E8A6-8845-BD4E-CB4CCA059FC4}" type="datetimeFigureOut">
               <a:rPr lang="en-US" smtClean="0"/>
-              <a:t>8/14/2026</a:t>
+              <a:t>8/17/2026</a:t>
             </a:fld>
             <a:endParaRPr lang="en-US"/>
           </a:p>
@@ -1355,7 +1355,7 @@
           <a:p>
             <a:fld id="{5BCAD085-E8A6-8845-BD4E-CB4CCA059FC4}" type="datetimeFigureOut">
               <a:rPr lang="en-US" smtClean="0"/>
-              <a:t>8/14/2026</a:t>
+              <a:t>8/17/2026</a:t>
             </a:fld>
             <a:endParaRPr lang="en-US"/>
           </a:p>
@@ -1774,7 +1774,7 @@
           <a:p>
             <a:fld id="{5BCAD085-E8A6-8845-BD4E-CB4CCA059FC4}" type="datetimeFigureOut">
               <a:rPr lang="en-US" smtClean="0"/>
-              <a:t>8/14/2026</a:t>
+              <a:t>8/17/2026</a:t>
             </a:fld>
             <a:endParaRPr lang="en-US"/>
           </a:p>
@@ -1891,7 +1891,7 @@
           <a:p>
             <a:fld id="{5BCAD085-E8A6-8845-BD4E-CB4CCA059FC4}" type="datetimeFigureOut">
               <a:rPr lang="en-US" smtClean="0"/>
-              <a:t>8/14/2026</a:t>
+              <a:t>8/17/2026</a:t>
             </a:fld>
             <a:endParaRPr lang="en-US"/>
           </a:p>
@@ -1986,7 +1986,7 @@
           <a:p>
             <a:fld id="{5BCAD085-E8A6-8845-BD4E-CB4CCA059FC4}" type="datetimeFigureOut">
               <a:rPr lang="en-US" smtClean="0"/>
-              <a:t>8/14/2026</a:t>
+              <a:t>8/17/2026</a:t>
             </a:fld>
             <a:endParaRPr lang="en-US"/>
           </a:p>
@@ -2261,7 +2261,7 @@
           <a:p>
             <a:fld id="{5BCAD085-E8A6-8845-BD4E-CB4CCA059FC4}" type="datetimeFigureOut">
               <a:rPr lang="en-US" smtClean="0"/>
-              <a:t>8/14/2026</a:t>
+              <a:t>8/17/2026</a:t>
             </a:fld>
             <a:endParaRPr lang="en-US"/>
           </a:p>
@@ -2513,7 +2513,7 @@
           <a:p>
             <a:fld id="{5BCAD085-E8A6-8845-BD4E-CB4CCA059FC4}" type="datetimeFigureOut">
               <a:rPr lang="en-US" smtClean="0"/>
-              <a:t>8/14/2026</a:t>
+              <a:t>8/17/2026</a:t>
             </a:fld>
             <a:endParaRPr lang="en-US"/>
           </a:p>
@@ -2724,7 +2724,7 @@
           <a:p>
             <a:fld id="{5BCAD085-E8A6-8845-BD4E-CB4CCA059FC4}" type="datetimeFigureOut">
               <a:rPr lang="en-US" smtClean="0"/>
-              <a:t>8/14/2026</a:t>
+              <a:t>8/17/2026</a:t>
             </a:fld>
             <a:endParaRPr lang="en-US"/>
           </a:p>
@@ -3759,7 +3759,7 @@
                 </a:solidFill>
                 <a:latin typeface="Segoe UI"/>
               </a:rPr>
-              <a:t>Contract slug confirmed (balkanea-mobile, accepted 8/14) — RateHawk is creating the contract now and handing off to their API support team to issue the sandbox key. Next: confirm the key lands, then start the certification checklist.</a:t>
+              <a:t>Key landed 8/17 (ID 954) but first calls return incorrect_credentials — looks like IP whitelisting, not a bad key. Next: get Balkanea's outbound IP whitelisted (checking if Hristijan's existing server IP already is), then start the certification checklist — which also needs 2 test hotels added to our DB first.</a:t>
             </a:r>
           </a:p>
         </p:txBody>
@@ -3883,13 +3883,13 @@
               </a:spcAft>
             </a:pPr>
             <a:r>
-              <a:rPr sz="1150" b="0" dirty="0">
+              <a:rPr sz="1150" b="0">
                 <a:solidFill>
                   <a:srgbClr val="6B6558"/>
                 </a:solidFill>
                 <a:latin typeface="Segoe UI"/>
               </a:rPr>
-              <a:t>Pick one: web's live-search-then-enrich pattern, or the DB-first shortcut — needed before backend work continues.</a:t>
+              <a:t>Resolved by RateHawk's own rules, not a preference: their docs prohibit live Content API calls during search, so DB-first is required. Still needs building.</a:t>
             </a:r>
           </a:p>
         </p:txBody>
@@ -4019,7 +4019,7 @@
                 </a:solidFill>
                 <a:latin typeface="Segoe UI"/>
               </a:rPr>
-              <a:t>Not a WebView-to-existing-checkout question anymore — get the real NLB-direct spec from Hristijan/Ivan and confirm it doesn't require a WooCommerce order behind the scenes. Nothing else on payments moves until that answer lands.</a:t>
+              <a:t>Confirmed 8/14: NLB-direct is real, ~2–3 days to build, Hristijan's top priority — blocked only on NLB whitelisting the server IP. Separately: RateHawk's booking flow draws on its own deposit balance, not the guest's card, so RateHawk build work doesn't have to wait on this.</a:t>
             </a:r>
           </a:p>
         </p:txBody>
@@ -4143,13 +4143,13 @@
               </a:spcAft>
             </a:pPr>
             <a:r>
-              <a:rPr sz="1150" b="0" dirty="0">
+              <a:rPr sz="1150" b="0">
                 <a:solidFill>
                   <a:srgbClr val="6B6558"/>
                 </a:solidFill>
                 <a:latin typeface="Segoe UI"/>
               </a:rPr>
-              <a:t>The real NLB documentation from Hristijan/Ivan</a:t>
+              <a:t>IP-whitelist status for both NLB and RateHawk, from Hristijan</a:t>
             </a:r>
           </a:p>
         </p:txBody>
@@ -5202,7 +5202,7 @@
                 </a:solidFill>
                 <a:latin typeface="Segoe UI Semibold"/>
               </a:rPr>
-              <a:t>Hotel database is live; RateHawk sandbox is provisioning</a:t>
+              <a:t>Hotel database is live; sandbox key issued, blocked on IP whitelist</a:t>
             </a:r>
           </a:p>
         </p:txBody>
@@ -5241,7 +5241,7 @@
                 </a:solidFill>
                 <a:latin typeface="Segoe UI"/>
               </a:rPr>
-              <a:t>The hotel-DB half of this is done. What's left: RateHawk's sandbox key, the search-flow decision, and the booking endpoints.</a:t>
+              <a:t>The hotel-DB half of this is done. The sandbox key landed 8/17 — first live calls are failing on IP whitelisting, not the credentials themselves. Search-flow decision and booking endpoints still ahead.</a:t>
             </a:r>
           </a:p>
         </p:txBody>
@@ -5454,7 +5454,7 @@
                 </a:solidFill>
                 <a:latin typeface="Segoe UI"/>
               </a:rPr>
-              <a:t>IN PROGRESS</a:t>
+              <a:t>BLOCKED</a:t>
             </a:r>
           </a:p>
         </p:txBody>
@@ -5493,7 +5493,7 @@
                 </a:solidFill>
                 <a:latin typeface="Segoe UI Semibold"/>
               </a:rPr>
-              <a:t>RateHawk sandbox — separate contract confirmed, key incoming</a:t>
+              <a:t>Sandbox key issued (ID 954) — first calls blocked, not by bad credentials</a:t>
             </a:r>
           </a:p>
         </p:txBody>
@@ -5535,7 +5535,7 @@
                 </a:solidFill>
                 <a:latin typeface="Segoe UI"/>
               </a:rPr>
-              <a:t>Ivan's proposed contract slug (balkanea-mobile) was accepted by RateHawk today (8/14) — they're creating the contract now and handing off to their API support team to issue the sandbox key. New wrinkle: RateHawk's API Launch team also requires a certification step (demo + checklist) before issuing a production key — a gate not in the original plan.</a:t>
+              <a:t>Received 8/17: Key ID 954 + access token. Live calls return 401 with the key recognized but the token unmatched — consistent with RateHawk's mandatory IP whitelist, not a bad key. Today's ask for Hristijan: does his server already have a RateHawk-whitelisted IP we can reuse?</a:t>
             </a:r>
           </a:p>
         </p:txBody>
@@ -6153,7 +6153,7 @@
                 </a:solidFill>
                 <a:latin typeface="Segoe UI Semibold"/>
               </a:rPr>
-              <a:t>Search-flow design, and booking endpoints still to build</a:t>
+              <a:t>Search-flow now settled by RateHawk's own rules; booking endpoints + 2 missing test hotels still to build</a:t>
             </a:r>
           </a:p>
         </p:txBody>
@@ -6189,13 +6189,49 @@
               </a:spcAft>
             </a:pPr>
             <a:r>
-              <a:rPr sz="1050" b="0">
+              <a:rPr sz="1050" b="0" dirty="0">
                 <a:solidFill>
                   <a:srgbClr val="6B6558"/>
                 </a:solidFill>
                 <a:latin typeface="Segoe UI"/>
               </a:rPr>
-              <a:t>Still undecided: web's live-search-then-enrich pattern vs. the DB-first shortcut (query our own DB first, no price shown until a hotel is opened). Backend also needs RateHawk's mobile-specific SERP/Prebook/Webhook workflow, not just web's lib/ratehawk.js pattern with swapped credentials — none of the room-rate, pre-book, or create-order calls exist yet.</a:t>
+              <a:t>Not actually a choice anymore: </a:t>
+            </a:r>
+            <a:r>
+              <a:rPr sz="1050" b="0" dirty="0" err="1">
+                <a:solidFill>
+                  <a:srgbClr val="6B6558"/>
+                </a:solidFill>
+                <a:latin typeface="Segoe UI"/>
+              </a:rPr>
+              <a:t>RateHawk's</a:t>
+            </a:r>
+            <a:r>
+              <a:rPr sz="1050" b="0" dirty="0">
+                <a:solidFill>
+                  <a:srgbClr val="6B6558"/>
+                </a:solidFill>
+                <a:latin typeface="Segoe UI"/>
+              </a:rPr>
+              <a:t> docs prohibit calling the Content API live during search, so DB-first is required, not just faster. None of the room-rate, pre-book, or create-order calls exist yet. New: certification needs 2 specific test hotels (Conrad LA + one other) that aren't in our DB — confirmed</a:t>
+            </a:r>
+            <a:r>
+              <a:rPr lang="en-US" sz="1050" b="0" dirty="0">
+                <a:solidFill>
+                  <a:srgbClr val="6B6558"/>
+                </a:solidFill>
+                <a:latin typeface="Segoe UI"/>
+              </a:rPr>
+              <a:t>.</a:t>
+            </a:r>
+            <a:r>
+              <a:rPr sz="1050" b="0" dirty="0">
+                <a:solidFill>
+                  <a:srgbClr val="6B6558"/>
+                </a:solidFill>
+                <a:latin typeface="Segoe UI"/>
+              </a:rPr>
+              <a:t> </a:t>
             </a:r>
           </a:p>
         </p:txBody>
@@ -6306,7 +6342,7 @@
                 </a:solidFill>
                 <a:latin typeface="Segoe UI Semibold"/>
               </a:rPr>
-              <a:t>Bank checkout — the WooCommerce path is ruled out</a:t>
+              <a:t>Bank checkout is real; WooCommerce-parity is open</a:t>
             </a:r>
           </a:p>
         </p:txBody>
@@ -6345,7 +6381,7 @@
                 </a:solidFill>
                 <a:latin typeface="Segoe UI"/>
               </a:rPr>
-              <a:t>A working WebView integration got built and verified — then a hard constraint ruled it out. Now waiting on the real alternative.</a:t>
+              <a:t>NLB-direct is confirmed real, buildable in 2–3 days. What's left: can WooCommerce's capabilities be fully recreated outside it?</a:t>
             </a:r>
           </a:p>
         </p:txBody>
@@ -6813,7 +6849,7 @@
                 </a:solidFill>
                 <a:latin typeface="Segoe UI Semibold"/>
               </a:rPr>
-              <a:t>NLB-direct — the only path that fits, not yet built</a:t>
+              <a:t>NLB-direct — confirmed real, Hristijan's top priority, 2–3 days to build</a:t>
             </a:r>
           </a:p>
         </p:txBody>
@@ -6855,7 +6891,7 @@
                 </a:solidFill>
                 <a:latin typeface="Segoe UI"/>
               </a:rPr>
-              <a:t>Hristijan flagged an NLB EPOS route that skips WooCommerce order creation entirely — surfaced in an 8/14 meeting with Ivan, but 'needs to be developed.' No doc or timeline exists yet on either side; it may be what 'Balkanea Payment Links' (bpl-nlb-settings) already does, but that page is access-blocked for Hristijan's account.</a:t>
+              <a:t>Confirmed directly by Hristijan on the 8/14 call: a direct API integration works against NLB, skipping WooCommerce entirely — 'two to three days tops' to build, now his top priority ahead of other work. Only remaining blocker: NLB needs to whitelist the server's IP for direct API access.</a:t>
             </a:r>
           </a:p>
         </p:txBody>
@@ -7023,22 +7059,13 @@
               </a:spcAft>
             </a:pPr>
             <a:r>
-              <a:rPr lang="en-US" sz="1300" b="1" dirty="0">
+              <a:rPr sz="1300" b="1">
                 <a:solidFill>
                   <a:srgbClr val="1A1A2E"/>
                 </a:solidFill>
                 <a:latin typeface="Segoe UI Semibold"/>
               </a:rPr>
-              <a:t>T</a:t>
-            </a:r>
-            <a:r>
-              <a:rPr sz="1300" b="1" dirty="0">
-                <a:solidFill>
-                  <a:srgbClr val="1A1A2E"/>
-                </a:solidFill>
-                <a:latin typeface="Segoe UI Semibold"/>
-              </a:rPr>
-              <a:t>his week</a:t>
+              <a:t>Today’s call</a:t>
             </a:r>
           </a:p>
         </p:txBody>
@@ -7074,22 +7101,13 @@
               </a:spcAft>
             </a:pPr>
             <a:r>
-              <a:rPr lang="en-US" sz="1050" dirty="0">
+              <a:rPr sz="1050">
                 <a:solidFill>
                   <a:srgbClr val="6B6558"/>
                 </a:solidFill>
                 <a:latin typeface="Segoe UI"/>
               </a:rPr>
-              <a:t>A</a:t>
-            </a:r>
-            <a:r>
-              <a:rPr sz="1050" b="0" dirty="0">
-                <a:solidFill>
-                  <a:srgbClr val="6B6558"/>
-                </a:solidFill>
-                <a:latin typeface="Segoe UI"/>
-              </a:rPr>
-              <a:t>ctual NLB documentation, what 'needs to be developed' means concretely, and the key question: does the order-free flow still create a WooCommerce order behind the scenes for reconciliation? That answer decides if the constraint is even satisfiable through this vendor.</a:t>
+              <a:t>Confirm NLB IP-whitelist status/timeline, whether the direct flow still writes a WooCommerce order for reconciliation, and — new — whether Hristijan's server already has a RateHawk-whitelisted IP we could reuse for the mobile sandbox key instead of standing up separate infra.</a:t>
             </a:r>
           </a:p>
         </p:txBody>
@@ -10836,6 +10854,7 @@
           <a:lstStyle/>
           <a:p>
             <a:pPr algn="ctr"/>
+            <a:endParaRPr/>
           </a:p>
         </p:txBody>
       </p:sp>
@@ -10856,7 +10875,7 @@
           <a:noFill/>
         </p:spPr>
         <p:txBody>
-          <a:bodyPr wrap="square" lIns="0" rIns="0" tIns="0" bIns="0">
+          <a:bodyPr wrap="square" lIns="0" tIns="0" rIns="0" bIns="0">
             <a:spAutoFit/>
           </a:bodyPr>
           <a:lstStyle/>
@@ -10891,7 +10910,7 @@
           <a:noFill/>
         </p:spPr>
         <p:txBody>
-          <a:bodyPr wrap="square" lIns="0" rIns="0" tIns="0" bIns="0">
+          <a:bodyPr wrap="square" lIns="0" tIns="0" rIns="0" bIns="0">
             <a:spAutoFit/>
           </a:bodyPr>
           <a:lstStyle/>
@@ -10948,7 +10967,7 @@
           </a:fontRef>
         </p:style>
         <p:txBody>
-          <a:bodyPr rtlCol="0" anchor="ctr" lIns="0" rIns="0" tIns="0" bIns="0"/>
+          <a:bodyPr lIns="0" tIns="0" rIns="0" bIns="0" rtlCol="0" anchor="ctr"/>
           <a:lstStyle/>
           <a:p>
             <a:pPr algn="ctr"/>

</xml_diff>

<commit_message>
chore: daily sync 2026-08-25
</commit_message>
<xml_diff>
--- a/decks/Balkanea-Mobile-Sandbox-Readiness-Update.pptx
+++ b/decks/Balkanea-Mobile-Sandbox-Readiness-Update.pptx
@@ -15,7 +15,9 @@
     <p:sldId id="260" r:id="rId9"/>
     <p:sldId id="264" r:id="rId10"/>
     <p:sldId id="261" r:id="rId11"/>
+    <p:sldId id="270" r:id="rId19"/>
     <p:sldId id="262" r:id="rId12"/>
+    <p:sldId id="269" r:id="rId18"/>
     <p:sldId id="263" r:id="rId13"/>
   </p:sldIdLst>
   <p:sldSz cx="12192000" cy="6858000"/>
@@ -3185,26 +3187,7 @@
                 </a:solidFill>
                 <a:latin typeface="Segoe UI Semibold"/>
               </a:rPr>
-              <a:t>What's changed since the last review</a:t>
-            </a:r>
-          </a:p>
-          <a:p>
-            <a:pPr algn="l">
-              <a:lnSpc>
-                <a:spcPct val="105000"/>
-              </a:lnSpc>
-              <a:spcAft>
-                <a:spcPts val="0"/>
-              </a:spcAft>
-            </a:pPr>
-            <a:r>
-              <a:rPr sz="4000" b="1">
-                <a:solidFill>
-                  <a:srgbClr val="FBF6EE"/>
-                </a:solidFill>
-                <a:latin typeface="Segoe UI Semibold"/>
-              </a:rPr>
-              <a:t>and what still needs a decision</a:t>
+              <a:t>Cost, risk, and the path to submission</a:t>
             </a:r>
           </a:p>
         </p:txBody>
@@ -3246,26 +3229,7 @@
                 </a:solidFill>
                 <a:latin typeface="Segoe UI"/>
               </a:rPr>
-              <a:t>Hotel database is live, RateHawk sandbox is being provisioned, and payments hit a</a:t>
-            </a:r>
-          </a:p>
-          <a:p>
-            <a:pPr algn="l">
-              <a:lnSpc>
-                <a:spcPct val="120000"/>
-              </a:lnSpc>
-              <a:spcAft>
-                <a:spcPts val="0"/>
-              </a:spcAft>
-            </a:pPr>
-            <a:r>
-              <a:rPr sz="1450" b="0">
-                <a:solidFill>
-                  <a:srgbClr val="C9D9D3"/>
-                </a:solidFill>
-                <a:latin typeface="Segoe UI"/>
-              </a:rPr>
-              <a:t>new architecture call — prepared for review with Dragana &amp; Hristijan</a:t>
+              <a:t>RateHawk sandbox booking and payments are now verified live end-to-end -- three real bookings processed today, including a fixed root-cause payment bug. See Risks for what's still genuinely open. Cost model updated, certification and store submission plan attached.</a:t>
             </a:r>
           </a:p>
         </p:txBody>
@@ -3304,52 +3268,7 @@
                 </a:solidFill>
                 <a:latin typeface="Segoe UI"/>
               </a:rPr>
-              <a:t>Stage:  </a:t>
-            </a:r>
-            <a:r>
-              <a:rPr sz="1150" b="0">
-                <a:solidFill>
-                  <a:srgbClr val="E6EFEC"/>
-                </a:solidFill>
-                <a:latin typeface="Segoe UI"/>
-              </a:rPr>
-              <a:t>TestFlight (v1.0.7, build 11)      </a:t>
-            </a:r>
-            <a:r>
-              <a:rPr sz="1150" b="1">
-                <a:solidFill>
-                  <a:srgbClr val="9FB8AE"/>
-                </a:solidFill>
-                <a:latin typeface="Segoe UI"/>
-              </a:rPr>
-              <a:t>Systems:  </a:t>
-            </a:r>
-            <a:r>
-              <a:rPr sz="1150" b="0">
-                <a:solidFill>
-                  <a:srgbClr val="E6EFEC"/>
-                </a:solidFill>
-                <a:latin typeface="Segoe UI"/>
-              </a:rPr>
-              <a:t>RateHawk · Bank checkout (architecture TBD) · Supabase auth      </a:t>
-            </a:r>
-            <a:r>
-              <a:rPr sz="1150" b="1">
-                <a:solidFill>
-                  <a:srgbClr val="9FB8AE"/>
-                </a:solidFill>
-                <a:latin typeface="Segoe UI"/>
-              </a:rPr>
-              <a:t>Prepared:  </a:t>
-            </a:r>
-            <a:r>
-              <a:rPr sz="1150" b="0">
-                <a:solidFill>
-                  <a:srgbClr val="E6EFEC"/>
-                </a:solidFill>
-                <a:latin typeface="Segoe UI"/>
-              </a:rPr>
-              <a:t>August 2026 (update)</a:t>
+              <a:t>Stage:  TestFlight (v1.0.7, build 11)      Systems:  RateHawk (sandbox, cert pending) · Bank checkout (MKD, live) · Supabase auth      Prepared:  August 2026 (update)</a:t>
             </a:r>
           </a:p>
         </p:txBody>
@@ -3451,7 +3370,7 @@
                 </a:solidFill>
                 <a:latin typeface="Segoe UI"/>
               </a:rPr>
-              <a:t>10  —  COST</a:t>
+              <a:t>09  —  COST</a:t>
             </a:r>
           </a:p>
         </p:txBody>
@@ -3607,7 +3526,7 @@
                 </a:solidFill>
                 <a:latin typeface="Segoe UI"/>
               </a:rPr>
-              <a:t>11</a:t>
+              <a:t>10</a:t>
             </a:r>
           </a:p>
         </p:txBody>
@@ -3835,13 +3754,13 @@
               </a:spcAft>
             </a:pPr>
             <a:r>
-              <a:rPr lang="en-US" sz="1050" b="0">
+              <a:rPr sz="1050" b="0">
                 <a:solidFill>
                   <a:srgbClr val="6B6558"/>
                 </a:solidFill>
                 <a:latin typeface="Segoe UI"/>
               </a:rPr>
-              <a:t>Estimated $400 AI Cost</a:t>
+              <a:t>Estimated $1,000 engineering cost (Claude Code, near-zero if on subscription) -- reflects 8/25's payment debugging, reliability fixes, and new document/email features.</a:t>
             </a:r>
             <a:endParaRPr sz="1050" b="0" dirty="0">
               <a:solidFill>
@@ -4744,7 +4663,7 @@
                 </a:solidFill>
                 <a:latin typeface="Segoe UI"/>
               </a:rPr>
-              <a:t>Sandbox running now at ~$25/mo (Pro plan, Medium compute). Production baseline ~$75/mo once live; HA read replica deferred until traffic justifies it. Backups skipped.</a:t>
+              <a:t>Sandbox ~$25/mo, production ~$75/mo (Supabase Pro). Plus the AWS relay for RateHawk certification: ~$8/mo base, ~$22/mo with HA -- in the updated cost model.</a:t>
             </a:r>
             <a:endParaRPr sz="1050" b="0" dirty="0">
               <a:solidFill>
@@ -4764,6 +4683,1469 @@
 </file>
 
 <file path=ppt/slides/slide11.xml><?xml version="1.0" encoding="utf-8"?>
+<p:sld xmlns:a="http://schemas.openxmlformats.org/drawingml/2006/main" xmlns:p="http://schemas.openxmlformats.org/presentationml/2006/main" xmlns:r="http://schemas.openxmlformats.org/officeDocument/2006/relationships">
+  <p:cSld>
+    <p:bg>
+      <p:bgPr>
+        <a:solidFill>
+          <a:srgbClr val="FAF7F2"/>
+        </a:solidFill>
+        <a:effectLst/>
+      </p:bgPr>
+    </p:bg>
+    <p:spTree>
+      <p:nvGrpSpPr>
+        <p:cNvPr id="1" name=""/>
+        <p:cNvGrpSpPr/>
+        <p:nvPr/>
+      </p:nvGrpSpPr>
+      <p:grpSpPr/>
+      <p:sp>
+        <p:nvSpPr>
+          <p:cNvPr id="2" name="TextBox 1"/>
+          <p:cNvSpPr txBox="1"/>
+          <p:nvPr/>
+        </p:nvSpPr>
+        <p:spPr>
+          <a:xfrm>
+            <a:off x="502920" y="457200"/>
+            <a:ext cx="11183112" cy="320040"/>
+          </a:xfrm>
+          <a:prstGeom prst="rect">
+            <a:avLst/>
+          </a:prstGeom>
+          <a:noFill/>
+        </p:spPr>
+        <p:txBody>
+          <a:bodyPr wrap="square" lIns="0" rIns="0" tIns="0" bIns="0">
+            <a:spAutoFit/>
+          </a:bodyPr>
+          <a:lstStyle/>
+          <a:p>
+            <a:pPr algn="l"/>
+            <a:r>
+              <a:rPr sz="1200" b="1">
+                <a:solidFill>
+                  <a:srgbClr val="7A3E0F"/>
+                </a:solidFill>
+                <a:latin typeface="Segoe UI Semibold"/>
+              </a:rPr>
+              <a:t>10  —  WHAT’S BEEN BUILT</a:t>
+            </a:r>
+          </a:p>
+        </p:txBody>
+      </p:sp>
+      <p:sp>
+        <p:nvSpPr>
+          <p:cNvPr id="3" name="TextBox 2"/>
+          <p:cNvSpPr txBox="1"/>
+          <p:nvPr/>
+        </p:nvSpPr>
+        <p:spPr>
+          <a:xfrm>
+            <a:off x="502920" y="749808"/>
+            <a:ext cx="11183112" cy="502920"/>
+          </a:xfrm>
+          <a:prstGeom prst="rect">
+            <a:avLst/>
+          </a:prstGeom>
+          <a:noFill/>
+        </p:spPr>
+        <p:txBody>
+          <a:bodyPr wrap="square" lIns="0" rIns="0" tIns="0" bIns="0">
+            <a:spAutoFit/>
+          </a:bodyPr>
+          <a:lstStyle/>
+          <a:p>
+            <a:pPr algn="l"/>
+            <a:r>
+              <a:rPr sz="2600" b="1" i="0">
+                <a:solidFill>
+                  <a:srgbClr val="1A1A2E"/>
+                </a:solidFill>
+                <a:latin typeface="Segoe UI Semibold"/>
+              </a:rPr>
+              <a:t>Full scope, real codebase size, and what it would have cost elsewhere</a:t>
+            </a:r>
+          </a:p>
+        </p:txBody>
+      </p:sp>
+      <p:sp>
+        <p:nvSpPr>
+          <p:cNvPr id="4" name="TextBox 3"/>
+          <p:cNvSpPr txBox="1"/>
+          <p:nvPr/>
+        </p:nvSpPr>
+        <p:spPr>
+          <a:xfrm>
+            <a:off x="502920" y="1298448"/>
+            <a:ext cx="10799064" cy="384048"/>
+          </a:xfrm>
+          <a:prstGeom prst="rect">
+            <a:avLst/>
+          </a:prstGeom>
+          <a:noFill/>
+        </p:spPr>
+        <p:txBody>
+          <a:bodyPr wrap="square" lIns="0" rIns="0" tIns="0" bIns="0">
+            <a:spAutoFit/>
+          </a:bodyPr>
+          <a:lstStyle/>
+          <a:p>
+            <a:pPr algn="l"/>
+            <a:r>
+              <a:rPr sz="1250" b="0" i="0">
+                <a:solidFill>
+                  <a:srgbClr val="6B6558"/>
+                </a:solidFill>
+                <a:latin typeface="Segoe UI"/>
+              </a:rPr>
+              <a:t>Every feature below is built and verified, not planned. Right: an illustrative traditional-agency cost for the same scope — not a real quote, for contrast only.</a:t>
+            </a:r>
+          </a:p>
+        </p:txBody>
+      </p:sp>
+      <p:sp>
+        <p:nvSpPr>
+          <p:cNvPr id="5" name="TextBox 4"/>
+          <p:cNvSpPr txBox="1"/>
+          <p:nvPr/>
+        </p:nvSpPr>
+        <p:spPr>
+          <a:xfrm>
+            <a:off x="502920" y="6528816"/>
+            <a:ext cx="7315200" cy="274320"/>
+          </a:xfrm>
+          <a:prstGeom prst="rect">
+            <a:avLst/>
+          </a:prstGeom>
+          <a:noFill/>
+        </p:spPr>
+        <p:txBody>
+          <a:bodyPr wrap="square" lIns="0" rIns="0" tIns="0" bIns="0">
+            <a:spAutoFit/>
+          </a:bodyPr>
+          <a:lstStyle/>
+          <a:p>
+            <a:pPr algn="l"/>
+            <a:r>
+              <a:rPr sz="900" b="0" i="0">
+                <a:solidFill>
+                  <a:srgbClr val="9B9384"/>
+                </a:solidFill>
+                <a:latin typeface="Segoe UI"/>
+              </a:rPr>
+              <a:t>BALKANEA MOBILE  —  SANDBOX / TEST READINESS</a:t>
+            </a:r>
+          </a:p>
+        </p:txBody>
+      </p:sp>
+      <p:sp>
+        <p:nvSpPr>
+          <p:cNvPr id="6" name="TextBox 5"/>
+          <p:cNvSpPr txBox="1"/>
+          <p:nvPr/>
+        </p:nvSpPr>
+        <p:spPr>
+          <a:xfrm>
+            <a:off x="10771632" y="6528816"/>
+            <a:ext cx="914400" cy="274320"/>
+          </a:xfrm>
+          <a:prstGeom prst="rect">
+            <a:avLst/>
+          </a:prstGeom>
+          <a:noFill/>
+        </p:spPr>
+        <p:txBody>
+          <a:bodyPr wrap="square" lIns="0" rIns="0" tIns="0" bIns="0">
+            <a:spAutoFit/>
+          </a:bodyPr>
+          <a:lstStyle/>
+          <a:p>
+            <a:pPr algn="r"/>
+            <a:r>
+              <a:rPr sz="900" b="0">
+                <a:solidFill>
+                  <a:srgbClr val="9B9384"/>
+                </a:solidFill>
+                <a:latin typeface="Segoe UI"/>
+              </a:rPr>
+              <a:t>11</a:t>
+            </a:r>
+          </a:p>
+        </p:txBody>
+      </p:sp>
+      <p:sp>
+        <p:nvSpPr>
+          <p:cNvPr id="7" name="TextBox 6"/>
+          <p:cNvSpPr txBox="1"/>
+          <p:nvPr/>
+        </p:nvSpPr>
+        <p:spPr>
+          <a:xfrm>
+            <a:off x="502920" y="1810512"/>
+            <a:ext cx="5349240" cy="201168"/>
+          </a:xfrm>
+          <a:prstGeom prst="rect">
+            <a:avLst/>
+          </a:prstGeom>
+          <a:noFill/>
+        </p:spPr>
+        <p:txBody>
+          <a:bodyPr wrap="square" lIns="0" rIns="0" tIns="0" bIns="0">
+            <a:spAutoFit/>
+          </a:bodyPr>
+          <a:lstStyle/>
+          <a:p>
+            <a:pPr algn="l"/>
+            <a:r>
+              <a:rPr sz="1050" b="1" i="0">
+                <a:solidFill>
+                  <a:srgbClr val="7A3E0F"/>
+                </a:solidFill>
+                <a:latin typeface="Segoe UI Semibold"/>
+              </a:rPr>
+              <a:t>SCOPE BUILT</a:t>
+            </a:r>
+          </a:p>
+        </p:txBody>
+      </p:sp>
+      <p:sp>
+        <p:nvSpPr>
+          <p:cNvPr id="8" name="TextBox 7"/>
+          <p:cNvSpPr txBox="1"/>
+          <p:nvPr/>
+        </p:nvSpPr>
+        <p:spPr>
+          <a:xfrm>
+            <a:off x="502920" y="2084832"/>
+            <a:ext cx="5349240" cy="2331720"/>
+          </a:xfrm>
+          <a:prstGeom prst="rect">
+            <a:avLst/>
+          </a:prstGeom>
+          <a:noFill/>
+        </p:spPr>
+        <p:txBody>
+          <a:bodyPr wrap="square" lIns="0" rIns="0" tIns="0" bIns="0">
+            <a:spAutoFit/>
+          </a:bodyPr>
+          <a:lstStyle/>
+          <a:p>
+            <a:pPr>
+              <a:spcAft>
+                <a:spcPts val="300"/>
+              </a:spcAft>
+            </a:pPr>
+            <a:r>
+              <a:rPr sz="930" b="0">
+                <a:solidFill>
+                  <a:srgbClr val="6B6558"/>
+                </a:solidFill>
+                <a:latin typeface="Segoe UI"/>
+              </a:rPr>
+              <a:t>•  Cross-platform app shell (iOS / Android / Web) + AI concierge (Nea)</a:t>
+            </a:r>
+          </a:p>
+          <a:p>
+            <a:pPr>
+              <a:spcAft>
+                <a:spcPts val="300"/>
+              </a:spcAft>
+            </a:pPr>
+            <a:r>
+              <a:rPr sz="930" b="0">
+                <a:solidFill>
+                  <a:srgbClr val="6B6558"/>
+                </a:solidFill>
+                <a:latin typeface="Segoe UI"/>
+              </a:rPr>
+              <a:t>•  850K-hotel content DB, region-filtered search</a:t>
+            </a:r>
+          </a:p>
+          <a:p>
+            <a:pPr>
+              <a:spcAft>
+                <a:spcPts val="300"/>
+              </a:spcAft>
+            </a:pPr>
+            <a:r>
+              <a:rPr sz="930" b="0">
+                <a:solidFill>
+                  <a:srgbClr val="6B6558"/>
+                </a:solidFill>
+                <a:latin typeface="Segoe UI"/>
+              </a:rPr>
+              <a:t>•  Real RateHawk booking flow — search / prebook / finish / status, all 7 certification scenarios, multi-room (real per-room guest configurator, not the flat-integer gap flagged earlier)</a:t>
+            </a:r>
+          </a:p>
+          <a:p>
+            <a:pPr>
+              <a:spcAft>
+                <a:spcPts val="300"/>
+              </a:spcAft>
+            </a:pPr>
+            <a:r>
+              <a:rPr sz="930" b="0">
+                <a:solidFill>
+                  <a:srgbClr val="6B6558"/>
+                </a:solidFill>
+                <a:latin typeface="Segoe UI"/>
+              </a:rPr>
+              <a:t>•  Real Bankart/NLB payment integration + voucher/invoice PDF retrieval</a:t>
+            </a:r>
+          </a:p>
+          <a:p>
+            <a:pPr>
+              <a:spcAft>
+                <a:spcPts val="300"/>
+              </a:spcAft>
+            </a:pPr>
+            <a:r>
+              <a:rPr sz="930" b="0">
+                <a:solidFill>
+                  <a:srgbClr val="6B6558"/>
+                </a:solidFill>
+                <a:latin typeface="Segoe UI"/>
+              </a:rPr>
+              <a:t>•  Auth: Google OAuth, native Apple Sign-In, guest checkout</a:t>
+            </a:r>
+          </a:p>
+          <a:p>
+            <a:pPr>
+              <a:spcAft>
+                <a:spcPts val="300"/>
+              </a:spcAft>
+            </a:pPr>
+            <a:r>
+              <a:rPr sz="930" b="0">
+                <a:solidFill>
+                  <a:srgbClr val="6B6558"/>
+                </a:solidFill>
+                <a:latin typeface="Segoe UI"/>
+              </a:rPr>
+              <a:t>•  Salesforce CRM sync, admin portal</a:t>
+            </a:r>
+          </a:p>
+          <a:p>
+            <a:pPr>
+              <a:spcAft>
+                <a:spcPts val="300"/>
+              </a:spcAft>
+            </a:pPr>
+            <a:r>
+              <a:rPr sz="930" b="0">
+                <a:solidFill>
+                  <a:srgbClr val="6B6558"/>
+                </a:solidFill>
+                <a:latin typeface="Segoe UI"/>
+              </a:rPr>
+              <a:t>•  Automatic booking emails — guest confirmation + business notification, each with a RateHawk PDF attached (voucher / invoice), shipped today via Resend</a:t>
+            </a:r>
+          </a:p>
+          <a:p>
+            <a:pPr>
+              <a:spcAft>
+                <a:spcPts val="300"/>
+              </a:spcAft>
+            </a:pPr>
+            <a:r>
+              <a:rPr sz="930" b="0">
+                <a:solidFill>
+                  <a:srgbClr val="6B6558"/>
+                </a:solidFill>
+                <a:latin typeface="Segoe UI"/>
+              </a:rPr>
+              <a:t>•  Push notifications</a:t>
+            </a:r>
+          </a:p>
+          <a:p>
+            <a:pPr>
+              <a:spcAft>
+                <a:spcPts val="300"/>
+              </a:spcAft>
+            </a:pPr>
+            <a:r>
+              <a:rPr sz="930" b="0">
+                <a:solidFill>
+                  <a:srgbClr val="6B6558"/>
+                </a:solidFill>
+                <a:latin typeface="Segoe UI"/>
+              </a:rPr>
+              <a:t>•  Voice AI (LiveKit/Retell) — built and working, shelved for a leaner V1</a:t>
+            </a:r>
+          </a:p>
+        </p:txBody>
+      </p:sp>
+      <p:sp>
+        <p:nvSpPr>
+          <p:cNvPr id="9" name="Rounded Rectangle 8"/>
+          <p:cNvSpPr/>
+          <p:nvPr/>
+        </p:nvSpPr>
+        <p:spPr>
+          <a:xfrm>
+            <a:off x="502920" y="4507992"/>
+            <a:ext cx="5349240" cy="868680"/>
+          </a:xfrm>
+          <a:prstGeom prst="roundRect">
+            <a:avLst>
+              <a:gd name="adj" fmla="val 10000"/>
+            </a:avLst>
+          </a:prstGeom>
+          <a:solidFill>
+            <a:srgbClr val="FFFFFF"/>
+          </a:solidFill>
+          <a:ln w="9525">
+            <a:solidFill>
+              <a:srgbClr val="E7E0D3"/>
+            </a:solidFill>
+          </a:ln>
+          <a:effectLst/>
+        </p:spPr>
+        <p:style>
+          <a:lnRef idx="1">
+            <a:schemeClr val="accent1"/>
+          </a:lnRef>
+          <a:fillRef idx="3">
+            <a:schemeClr val="accent1"/>
+          </a:fillRef>
+          <a:effectRef idx="2">
+            <a:schemeClr val="accent1"/>
+          </a:effectRef>
+          <a:fontRef idx="minor">
+            <a:schemeClr val="lt1"/>
+          </a:fontRef>
+        </p:style>
+        <p:txBody>
+          <a:bodyPr rtlCol="0" anchor="ctr"/>
+          <a:lstStyle/>
+          <a:p>
+            <a:pPr algn="ctr"/>
+          </a:p>
+        </p:txBody>
+      </p:sp>
+      <p:sp>
+        <p:nvSpPr>
+          <p:cNvPr id="10" name="TextBox 9"/>
+          <p:cNvSpPr txBox="1"/>
+          <p:nvPr/>
+        </p:nvSpPr>
+        <p:spPr>
+          <a:xfrm>
+            <a:off x="629920" y="4609592"/>
+            <a:ext cx="5095240" cy="749808"/>
+          </a:xfrm>
+          <a:prstGeom prst="rect">
+            <a:avLst/>
+          </a:prstGeom>
+          <a:noFill/>
+        </p:spPr>
+        <p:txBody>
+          <a:bodyPr wrap="square" lIns="0" rIns="0" tIns="0" bIns="0">
+            <a:spAutoFit/>
+          </a:bodyPr>
+          <a:lstStyle/>
+          <a:p>
+            <a:pPr>
+              <a:spcAft>
+                <a:spcPts val="400"/>
+              </a:spcAft>
+            </a:pPr>
+            <a:r>
+              <a:rPr sz="930" b="1">
+                <a:solidFill>
+                  <a:srgbClr val="1A1A2E"/>
+                </a:solidFill>
+                <a:latin typeface="Segoe UI Semibold"/>
+              </a:rPr>
+              <a:t>Languages: 2 — English + Macedonian (Cyrillic), the actual translated UI.</a:t>
+            </a:r>
+          </a:p>
+          <a:p>
+            <a:pPr>
+              <a:spcAft>
+                <a:spcPts val="400"/>
+              </a:spcAft>
+            </a:pPr>
+            <a:r>
+              <a:rPr sz="930" b="0">
+                <a:solidFill>
+                  <a:srgbClr val="6B6558"/>
+                </a:solidFill>
+                <a:latin typeface="Segoe UI"/>
+              </a:rPr>
+              <a:t>Currencies: 9, across 11 countries — a separate locale/pricing display layer, not UI language. (11 countries is the destination-selector count, not a language count.)</a:t>
+            </a:r>
+          </a:p>
+        </p:txBody>
+      </p:sp>
+      <p:sp>
+        <p:nvSpPr>
+          <p:cNvPr id="11" name="TextBox 10"/>
+          <p:cNvSpPr txBox="1"/>
+          <p:nvPr/>
+        </p:nvSpPr>
+        <p:spPr>
+          <a:xfrm>
+            <a:off x="502920" y="5513832"/>
+            <a:ext cx="5349240" cy="182880"/>
+          </a:xfrm>
+          <a:prstGeom prst="rect">
+            <a:avLst/>
+          </a:prstGeom>
+          <a:noFill/>
+        </p:spPr>
+        <p:txBody>
+          <a:bodyPr wrap="square" lIns="0" rIns="0" tIns="0" bIns="0">
+            <a:spAutoFit/>
+          </a:bodyPr>
+          <a:lstStyle/>
+          <a:p>
+            <a:pPr algn="l"/>
+            <a:r>
+              <a:rPr sz="900" b="1" i="0">
+                <a:solidFill>
+                  <a:srgbClr val="7A3E0F"/>
+                </a:solidFill>
+                <a:latin typeface="Segoe UI Semibold"/>
+              </a:rPr>
+              <a:t>ACTUAL CODEBASE, ~10 WEEKS ELAPSED (first commit 6/18 → 8/25)</a:t>
+            </a:r>
+          </a:p>
+        </p:txBody>
+      </p:sp>
+      <p:sp>
+        <p:nvSpPr>
+          <p:cNvPr id="12" name="TextBox 11"/>
+          <p:cNvSpPr txBox="1"/>
+          <p:nvPr/>
+        </p:nvSpPr>
+        <p:spPr>
+          <a:xfrm>
+            <a:off x="502920" y="5751576"/>
+            <a:ext cx="5349240" cy="777240"/>
+          </a:xfrm>
+          <a:prstGeom prst="rect">
+            <a:avLst/>
+          </a:prstGeom>
+          <a:noFill/>
+        </p:spPr>
+        <p:txBody>
+          <a:bodyPr wrap="square" lIns="0" rIns="0" tIns="0" bIns="0">
+            <a:spAutoFit/>
+          </a:bodyPr>
+          <a:lstStyle/>
+          <a:p>
+            <a:pPr>
+              <a:spcAft>
+                <a:spcPts val="400"/>
+              </a:spcAft>
+            </a:pPr>
+            <a:r>
+              <a:rPr sz="930" b="0">
+                <a:solidFill>
+                  <a:srgbClr val="6B6558"/>
+                </a:solidFill>
+                <a:latin typeface="Segoe UI"/>
+              </a:rPr>
+              <a:t>Mobile: 17 screens · 12 components · 27 lib modules · ~14,700 lines TS/TSX · 7 migrations · 86 commits</a:t>
+            </a:r>
+          </a:p>
+          <a:p>
+            <a:pPr>
+              <a:spcAft>
+                <a:spcPts val="400"/>
+              </a:spcAft>
+            </a:pPr>
+            <a:r>
+              <a:rPr sz="930" b="0">
+                <a:solidFill>
+                  <a:srgbClr val="6B6558"/>
+                </a:solidFill>
+                <a:latin typeface="Segoe UI"/>
+              </a:rPr>
+              <a:t>Backend: 12 endpoints · 12 lib modules · ~4,200 lines JS · 73 commits</a:t>
+            </a:r>
+          </a:p>
+        </p:txBody>
+      </p:sp>
+      <p:sp>
+        <p:nvSpPr>
+          <p:cNvPr id="13" name="TextBox 12"/>
+          <p:cNvSpPr txBox="1"/>
+          <p:nvPr/>
+        </p:nvSpPr>
+        <p:spPr>
+          <a:xfrm>
+            <a:off x="6080760" y="1810512"/>
+            <a:ext cx="5605272" cy="201168"/>
+          </a:xfrm>
+          <a:prstGeom prst="rect">
+            <a:avLst/>
+          </a:prstGeom>
+          <a:noFill/>
+        </p:spPr>
+        <p:txBody>
+          <a:bodyPr wrap="square" lIns="0" rIns="0" tIns="0" bIns="0">
+            <a:spAutoFit/>
+          </a:bodyPr>
+          <a:lstStyle/>
+          <a:p>
+            <a:pPr algn="l"/>
+            <a:r>
+              <a:rPr sz="1050" b="1" i="0">
+                <a:solidFill>
+                  <a:srgbClr val="7A3E0F"/>
+                </a:solidFill>
+                <a:latin typeface="Segoe UI Semibold"/>
+              </a:rPr>
+              <a:t>IF BUILT BY A TRADITIONAL AGENCY (ILLUSTRATIVE, NOT A REAL QUOTE)</a:t>
+            </a:r>
+          </a:p>
+        </p:txBody>
+      </p:sp>
+      <p:graphicFrame>
+        <p:nvGraphicFramePr>
+          <p:cNvPr id="14" name="Table 13"/>
+          <p:cNvGraphicFramePr>
+            <a:graphicFrameLocks noGrp="1"/>
+          </p:cNvGraphicFramePr>
+          <p:nvPr/>
+        </p:nvGraphicFramePr>
+        <p:xfrm>
+          <a:off x="6080760" y="2084832"/>
+          <a:ext cx="5605271" cy="2436876"/>
+        </p:xfrm>
+        <a:graphic>
+          <a:graphicData uri="http://schemas.openxmlformats.org/drawingml/2006/table">
+            <a:tbl>
+              <a:tblPr firstRow="0" bandRow="0">
+                <a:tableStyleId>{5C22544A-7EE6-4342-B048-85BDC9FD1C3A}</a:tableStyleId>
+              </a:tblPr>
+              <a:tblGrid>
+                <a:gridCol w="3811584"/>
+                <a:gridCol w="1793687"/>
+              </a:tblGrid>
+              <a:tr h="187452">
+                <a:tc>
+                  <a:txBody>
+                    <a:bodyPr/>
+                    <a:lstStyle/>
+                    <a:p>
+                      <a:pPr algn="l"/>
+                      <a:r>
+                        <a:rPr sz="850" b="1">
+                          <a:solidFill>
+                            <a:srgbClr val="FFFFFF"/>
+                          </a:solidFill>
+                          <a:latin typeface="Segoe UI Semibold"/>
+                        </a:rPr>
+                        <a:t>Component</a:t>
+                      </a:r>
+                    </a:p>
+                  </a:txBody>
+                  <a:tcPr marL="76200" marR="76200" marT="25400" marB="25400">
+                    <a:solidFill>
+                      <a:srgbClr val="1A1A2E"/>
+                    </a:solidFill>
+                  </a:tcPr>
+                </a:tc>
+                <a:tc>
+                  <a:txBody>
+                    <a:bodyPr/>
+                    <a:lstStyle/>
+                    <a:p>
+                      <a:pPr algn="r"/>
+                      <a:r>
+                        <a:rPr sz="850" b="1">
+                          <a:solidFill>
+                            <a:srgbClr val="FFFFFF"/>
+                          </a:solidFill>
+                          <a:latin typeface="Segoe UI Semibold"/>
+                        </a:rPr>
+                        <a:t>Blended $100–180/hr</a:t>
+                      </a:r>
+                    </a:p>
+                  </a:txBody>
+                  <a:tcPr marL="76200" marR="76200" marT="25400" marB="25400">
+                    <a:solidFill>
+                      <a:srgbClr val="1A1A2E"/>
+                    </a:solidFill>
+                  </a:tcPr>
+                </a:tc>
+              </a:tr>
+              <a:tr h="187452">
+                <a:tc>
+                  <a:txBody>
+                    <a:bodyPr/>
+                    <a:lstStyle/>
+                    <a:p>
+                      <a:pPr algn="l"/>
+                      <a:r>
+                        <a:rPr sz="869">
+                          <a:solidFill>
+                            <a:srgbClr val="1A1A2E"/>
+                          </a:solidFill>
+                          <a:latin typeface="Segoe UI"/>
+                        </a:rPr>
+                        <a:t>Discovery &amp; UX</a:t>
+                      </a:r>
+                    </a:p>
+                  </a:txBody>
+                  <a:tcPr marL="76200" marR="76200" marT="12700" marB="12700">
+                    <a:solidFill>
+                      <a:srgbClr val="FFFFFF"/>
+                    </a:solidFill>
+                  </a:tcPr>
+                </a:tc>
+                <a:tc>
+                  <a:txBody>
+                    <a:bodyPr/>
+                    <a:lstStyle/>
+                    <a:p>
+                      <a:pPr algn="r"/>
+                      <a:r>
+                        <a:rPr sz="869">
+                          <a:solidFill>
+                            <a:srgbClr val="6B6558"/>
+                          </a:solidFill>
+                          <a:latin typeface="Segoe UI"/>
+                        </a:rPr>
+                        <a:t>$15–25K</a:t>
+                      </a:r>
+                    </a:p>
+                  </a:txBody>
+                  <a:tcPr marL="76200" marR="76200" marT="12700" marB="12700">
+                    <a:solidFill>
+                      <a:srgbClr val="FFFFFF"/>
+                    </a:solidFill>
+                  </a:tcPr>
+                </a:tc>
+              </a:tr>
+              <a:tr h="187452">
+                <a:tc>
+                  <a:txBody>
+                    <a:bodyPr/>
+                    <a:lstStyle/>
+                    <a:p>
+                      <a:pPr algn="l"/>
+                      <a:r>
+                        <a:rPr sz="869">
+                          <a:solidFill>
+                            <a:srgbClr val="1A1A2E"/>
+                          </a:solidFill>
+                          <a:latin typeface="Segoe UI"/>
+                        </a:rPr>
+                        <a:t>App shell / design system</a:t>
+                      </a:r>
+                    </a:p>
+                  </a:txBody>
+                  <a:tcPr marL="76200" marR="76200" marT="12700" marB="12700">
+                    <a:solidFill>
+                      <a:srgbClr val="FFFFFF"/>
+                    </a:solidFill>
+                  </a:tcPr>
+                </a:tc>
+                <a:tc>
+                  <a:txBody>
+                    <a:bodyPr/>
+                    <a:lstStyle/>
+                    <a:p>
+                      <a:pPr algn="r"/>
+                      <a:r>
+                        <a:rPr sz="869">
+                          <a:solidFill>
+                            <a:srgbClr val="6B6558"/>
+                          </a:solidFill>
+                          <a:latin typeface="Segoe UI"/>
+                        </a:rPr>
+                        <a:t>$10–15K</a:t>
+                      </a:r>
+                    </a:p>
+                  </a:txBody>
+                  <a:tcPr marL="76200" marR="76200" marT="12700" marB="12700">
+                    <a:solidFill>
+                      <a:srgbClr val="FFFFFF"/>
+                    </a:solidFill>
+                  </a:tcPr>
+                </a:tc>
+              </a:tr>
+              <a:tr h="187452">
+                <a:tc>
+                  <a:txBody>
+                    <a:bodyPr/>
+                    <a:lstStyle/>
+                    <a:p>
+                      <a:pPr algn="l"/>
+                      <a:r>
+                        <a:rPr sz="869">
+                          <a:solidFill>
+                            <a:srgbClr val="1A1A2E"/>
+                          </a:solidFill>
+                          <a:latin typeface="Segoe UI"/>
+                        </a:rPr>
+                        <a:t>Auth</a:t>
+                      </a:r>
+                    </a:p>
+                  </a:txBody>
+                  <a:tcPr marL="76200" marR="76200" marT="12700" marB="12700">
+                    <a:solidFill>
+                      <a:srgbClr val="FFFFFF"/>
+                    </a:solidFill>
+                  </a:tcPr>
+                </a:tc>
+                <a:tc>
+                  <a:txBody>
+                    <a:bodyPr/>
+                    <a:lstStyle/>
+                    <a:p>
+                      <a:pPr algn="r"/>
+                      <a:r>
+                        <a:rPr sz="869">
+                          <a:solidFill>
+                            <a:srgbClr val="6B6558"/>
+                          </a:solidFill>
+                          <a:latin typeface="Segoe UI"/>
+                        </a:rPr>
+                        <a:t>$8–12K</a:t>
+                      </a:r>
+                    </a:p>
+                  </a:txBody>
+                  <a:tcPr marL="76200" marR="76200" marT="12700" marB="12700">
+                    <a:solidFill>
+                      <a:srgbClr val="FFFFFF"/>
+                    </a:solidFill>
+                  </a:tcPr>
+                </a:tc>
+              </a:tr>
+              <a:tr h="187452">
+                <a:tc>
+                  <a:txBody>
+                    <a:bodyPr/>
+                    <a:lstStyle/>
+                    <a:p>
+                      <a:pPr algn="l"/>
+                      <a:r>
+                        <a:rPr sz="869">
+                          <a:solidFill>
+                            <a:srgbClr val="1A1A2E"/>
+                          </a:solidFill>
+                          <a:latin typeface="Segoe UI"/>
+                        </a:rPr>
+                        <a:t>Hotel search / content DB</a:t>
+                      </a:r>
+                    </a:p>
+                  </a:txBody>
+                  <a:tcPr marL="76200" marR="76200" marT="12700" marB="12700">
+                    <a:solidFill>
+                      <a:srgbClr val="FFFFFF"/>
+                    </a:solidFill>
+                  </a:tcPr>
+                </a:tc>
+                <a:tc>
+                  <a:txBody>
+                    <a:bodyPr/>
+                    <a:lstStyle/>
+                    <a:p>
+                      <a:pPr algn="r"/>
+                      <a:r>
+                        <a:rPr sz="869">
+                          <a:solidFill>
+                            <a:srgbClr val="6B6558"/>
+                          </a:solidFill>
+                          <a:latin typeface="Segoe UI"/>
+                        </a:rPr>
+                        <a:t>$20–30K</a:t>
+                      </a:r>
+                    </a:p>
+                  </a:txBody>
+                  <a:tcPr marL="76200" marR="76200" marT="12700" marB="12700">
+                    <a:solidFill>
+                      <a:srgbClr val="FFFFFF"/>
+                    </a:solidFill>
+                  </a:tcPr>
+                </a:tc>
+              </a:tr>
+              <a:tr h="187452">
+                <a:tc>
+                  <a:txBody>
+                    <a:bodyPr/>
+                    <a:lstStyle/>
+                    <a:p>
+                      <a:pPr algn="l"/>
+                      <a:r>
+                        <a:rPr sz="869">
+                          <a:solidFill>
+                            <a:srgbClr val="1A1A2E"/>
+                          </a:solidFill>
+                          <a:latin typeface="Segoe UI"/>
+                        </a:rPr>
+                        <a:t>AI concierge chat</a:t>
+                      </a:r>
+                    </a:p>
+                  </a:txBody>
+                  <a:tcPr marL="76200" marR="76200" marT="12700" marB="12700">
+                    <a:solidFill>
+                      <a:srgbClr val="FFFFFF"/>
+                    </a:solidFill>
+                  </a:tcPr>
+                </a:tc>
+                <a:tc>
+                  <a:txBody>
+                    <a:bodyPr/>
+                    <a:lstStyle/>
+                    <a:p>
+                      <a:pPr algn="r"/>
+                      <a:r>
+                        <a:rPr sz="869">
+                          <a:solidFill>
+                            <a:srgbClr val="6B6558"/>
+                          </a:solidFill>
+                          <a:latin typeface="Segoe UI"/>
+                        </a:rPr>
+                        <a:t>$25–40K</a:t>
+                      </a:r>
+                    </a:p>
+                  </a:txBody>
+                  <a:tcPr marL="76200" marR="76200" marT="12700" marB="12700">
+                    <a:solidFill>
+                      <a:srgbClr val="FFFFFF"/>
+                    </a:solidFill>
+                  </a:tcPr>
+                </a:tc>
+              </a:tr>
+              <a:tr h="187452">
+                <a:tc>
+                  <a:txBody>
+                    <a:bodyPr/>
+                    <a:lstStyle/>
+                    <a:p>
+                      <a:pPr algn="l"/>
+                      <a:r>
+                        <a:rPr sz="869">
+                          <a:solidFill>
+                            <a:srgbClr val="1A1A2E"/>
+                          </a:solidFill>
+                          <a:latin typeface="Segoe UI"/>
+                        </a:rPr>
+                        <a:t>Real booking flow (RateHawk)</a:t>
+                      </a:r>
+                    </a:p>
+                  </a:txBody>
+                  <a:tcPr marL="76200" marR="76200" marT="12700" marB="12700">
+                    <a:solidFill>
+                      <a:srgbClr val="FFFFFF"/>
+                    </a:solidFill>
+                  </a:tcPr>
+                </a:tc>
+                <a:tc>
+                  <a:txBody>
+                    <a:bodyPr/>
+                    <a:lstStyle/>
+                    <a:p>
+                      <a:pPr algn="r"/>
+                      <a:r>
+                        <a:rPr sz="869">
+                          <a:solidFill>
+                            <a:srgbClr val="6B6558"/>
+                          </a:solidFill>
+                          <a:latin typeface="Segoe UI"/>
+                        </a:rPr>
+                        <a:t>$35–55K</a:t>
+                      </a:r>
+                    </a:p>
+                  </a:txBody>
+                  <a:tcPr marL="76200" marR="76200" marT="12700" marB="12700">
+                    <a:solidFill>
+                      <a:srgbClr val="FFFFFF"/>
+                    </a:solidFill>
+                  </a:tcPr>
+                </a:tc>
+              </a:tr>
+              <a:tr h="187452">
+                <a:tc>
+                  <a:txBody>
+                    <a:bodyPr/>
+                    <a:lstStyle/>
+                    <a:p>
+                      <a:pPr algn="l"/>
+                      <a:r>
+                        <a:rPr sz="869">
+                          <a:solidFill>
+                            <a:srgbClr val="1A1A2E"/>
+                          </a:solidFill>
+                          <a:latin typeface="Segoe UI"/>
+                        </a:rPr>
+                        <a:t>Payment integration (Bankart)</a:t>
+                      </a:r>
+                    </a:p>
+                  </a:txBody>
+                  <a:tcPr marL="76200" marR="76200" marT="12700" marB="12700">
+                    <a:solidFill>
+                      <a:srgbClr val="FFFFFF"/>
+                    </a:solidFill>
+                  </a:tcPr>
+                </a:tc>
+                <a:tc>
+                  <a:txBody>
+                    <a:bodyPr/>
+                    <a:lstStyle/>
+                    <a:p>
+                      <a:pPr algn="r"/>
+                      <a:r>
+                        <a:rPr sz="869">
+                          <a:solidFill>
+                            <a:srgbClr val="6B6558"/>
+                          </a:solidFill>
+                          <a:latin typeface="Segoe UI"/>
+                        </a:rPr>
+                        <a:t>$25–40K</a:t>
+                      </a:r>
+                    </a:p>
+                  </a:txBody>
+                  <a:tcPr marL="76200" marR="76200" marT="12700" marB="12700">
+                    <a:solidFill>
+                      <a:srgbClr val="FFFFFF"/>
+                    </a:solidFill>
+                  </a:tcPr>
+                </a:tc>
+              </a:tr>
+              <a:tr h="187452">
+                <a:tc>
+                  <a:txBody>
+                    <a:bodyPr/>
+                    <a:lstStyle/>
+                    <a:p>
+                      <a:pPr algn="l"/>
+                      <a:r>
+                        <a:rPr sz="869">
+                          <a:solidFill>
+                            <a:srgbClr val="1A1A2E"/>
+                          </a:solidFill>
+                          <a:latin typeface="Segoe UI"/>
+                        </a:rPr>
+                        <a:t>Admin portal</a:t>
+                      </a:r>
+                    </a:p>
+                  </a:txBody>
+                  <a:tcPr marL="76200" marR="76200" marT="12700" marB="12700">
+                    <a:solidFill>
+                      <a:srgbClr val="FFFFFF"/>
+                    </a:solidFill>
+                  </a:tcPr>
+                </a:tc>
+                <a:tc>
+                  <a:txBody>
+                    <a:bodyPr/>
+                    <a:lstStyle/>
+                    <a:p>
+                      <a:pPr algn="r"/>
+                      <a:r>
+                        <a:rPr sz="869">
+                          <a:solidFill>
+                            <a:srgbClr val="6B6558"/>
+                          </a:solidFill>
+                          <a:latin typeface="Segoe UI"/>
+                        </a:rPr>
+                        <a:t>$8–12K</a:t>
+                      </a:r>
+                    </a:p>
+                  </a:txBody>
+                  <a:tcPr marL="76200" marR="76200" marT="12700" marB="12700">
+                    <a:solidFill>
+                      <a:srgbClr val="FFFFFF"/>
+                    </a:solidFill>
+                  </a:tcPr>
+                </a:tc>
+              </a:tr>
+              <a:tr h="187452">
+                <a:tc>
+                  <a:txBody>
+                    <a:bodyPr/>
+                    <a:lstStyle/>
+                    <a:p>
+                      <a:pPr algn="l"/>
+                      <a:r>
+                        <a:rPr sz="869">
+                          <a:solidFill>
+                            <a:srgbClr val="1A1A2E"/>
+                          </a:solidFill>
+                          <a:latin typeface="Segoe UI"/>
+                        </a:rPr>
+                        <a:t>Salesforce CRM</a:t>
+                      </a:r>
+                    </a:p>
+                  </a:txBody>
+                  <a:tcPr marL="76200" marR="76200" marT="12700" marB="12700">
+                    <a:solidFill>
+                      <a:srgbClr val="FFFFFF"/>
+                    </a:solidFill>
+                  </a:tcPr>
+                </a:tc>
+                <a:tc>
+                  <a:txBody>
+                    <a:bodyPr/>
+                    <a:lstStyle/>
+                    <a:p>
+                      <a:pPr algn="r"/>
+                      <a:r>
+                        <a:rPr sz="869">
+                          <a:solidFill>
+                            <a:srgbClr val="6B6558"/>
+                          </a:solidFill>
+                          <a:latin typeface="Segoe UI"/>
+                        </a:rPr>
+                        <a:t>$8–12K</a:t>
+                      </a:r>
+                    </a:p>
+                  </a:txBody>
+                  <a:tcPr marL="76200" marR="76200" marT="12700" marB="12700">
+                    <a:solidFill>
+                      <a:srgbClr val="FFFFFF"/>
+                    </a:solidFill>
+                  </a:tcPr>
+                </a:tc>
+              </a:tr>
+              <a:tr h="187452">
+                <a:tc>
+                  <a:txBody>
+                    <a:bodyPr/>
+                    <a:lstStyle/>
+                    <a:p>
+                      <a:pPr algn="l"/>
+                      <a:r>
+                        <a:rPr sz="869">
+                          <a:solidFill>
+                            <a:srgbClr val="1A1A2E"/>
+                          </a:solidFill>
+                          <a:latin typeface="Segoe UI"/>
+                        </a:rPr>
+                        <a:t>i18n</a:t>
+                      </a:r>
+                    </a:p>
+                  </a:txBody>
+                  <a:tcPr marL="76200" marR="76200" marT="12700" marB="12700">
+                    <a:solidFill>
+                      <a:srgbClr val="FFFFFF"/>
+                    </a:solidFill>
+                  </a:tcPr>
+                </a:tc>
+                <a:tc>
+                  <a:txBody>
+                    <a:bodyPr/>
+                    <a:lstStyle/>
+                    <a:p>
+                      <a:pPr algn="r"/>
+                      <a:r>
+                        <a:rPr sz="869">
+                          <a:solidFill>
+                            <a:srgbClr val="6B6558"/>
+                          </a:solidFill>
+                          <a:latin typeface="Segoe UI"/>
+                        </a:rPr>
+                        <a:t>$8–12K</a:t>
+                      </a:r>
+                    </a:p>
+                  </a:txBody>
+                  <a:tcPr marL="76200" marR="76200" marT="12700" marB="12700">
+                    <a:solidFill>
+                      <a:srgbClr val="FFFFFF"/>
+                    </a:solidFill>
+                  </a:tcPr>
+                </a:tc>
+              </a:tr>
+              <a:tr h="187452">
+                <a:tc>
+                  <a:txBody>
+                    <a:bodyPr/>
+                    <a:lstStyle/>
+                    <a:p>
+                      <a:pPr algn="l"/>
+                      <a:r>
+                        <a:rPr sz="869">
+                          <a:solidFill>
+                            <a:srgbClr val="1A1A2E"/>
+                          </a:solidFill>
+                          <a:latin typeface="Segoe UI"/>
+                        </a:rPr>
+                        <a:t>Voice AI (shelved)</a:t>
+                      </a:r>
+                    </a:p>
+                  </a:txBody>
+                  <a:tcPr marL="76200" marR="76200" marT="12700" marB="12700">
+                    <a:solidFill>
+                      <a:srgbClr val="FFFFFF"/>
+                    </a:solidFill>
+                  </a:tcPr>
+                </a:tc>
+                <a:tc>
+                  <a:txBody>
+                    <a:bodyPr/>
+                    <a:lstStyle/>
+                    <a:p>
+                      <a:pPr algn="r"/>
+                      <a:r>
+                        <a:rPr sz="869">
+                          <a:solidFill>
+                            <a:srgbClr val="6B6558"/>
+                          </a:solidFill>
+                          <a:latin typeface="Segoe UI"/>
+                        </a:rPr>
+                        <a:t>$15–25K</a:t>
+                      </a:r>
+                    </a:p>
+                  </a:txBody>
+                  <a:tcPr marL="76200" marR="76200" marT="12700" marB="12700">
+                    <a:solidFill>
+                      <a:srgbClr val="FFFFFF"/>
+                    </a:solidFill>
+                  </a:tcPr>
+                </a:tc>
+              </a:tr>
+              <a:tr h="187452">
+                <a:tc>
+                  <a:txBody>
+                    <a:bodyPr/>
+                    <a:lstStyle/>
+                    <a:p>
+                      <a:pPr algn="l"/>
+                      <a:r>
+                        <a:rPr sz="869">
+                          <a:solidFill>
+                            <a:srgbClr val="1A1A2E"/>
+                          </a:solidFill>
+                          <a:latin typeface="Segoe UI"/>
+                        </a:rPr>
+                        <a:t>QA across iOS/Android/Web</a:t>
+                      </a:r>
+                    </a:p>
+                  </a:txBody>
+                  <a:tcPr marL="76200" marR="76200" marT="12700" marB="12700">
+                    <a:solidFill>
+                      <a:srgbClr val="FFFFFF"/>
+                    </a:solidFill>
+                  </a:tcPr>
+                </a:tc>
+                <a:tc>
+                  <a:txBody>
+                    <a:bodyPr/>
+                    <a:lstStyle/>
+                    <a:p>
+                      <a:pPr algn="r"/>
+                      <a:r>
+                        <a:rPr sz="869">
+                          <a:solidFill>
+                            <a:srgbClr val="6B6558"/>
+                          </a:solidFill>
+                          <a:latin typeface="Segoe UI"/>
+                        </a:rPr>
+                        <a:t>$15–25K</a:t>
+                      </a:r>
+                    </a:p>
+                  </a:txBody>
+                  <a:tcPr marL="76200" marR="76200" marT="12700" marB="12700">
+                    <a:solidFill>
+                      <a:srgbClr val="FFFFFF"/>
+                    </a:solidFill>
+                  </a:tcPr>
+                </a:tc>
+              </a:tr>
+            </a:tbl>
+          </a:graphicData>
+        </a:graphic>
+      </p:graphicFrame>
+      <p:sp>
+        <p:nvSpPr>
+          <p:cNvPr id="15" name="Rounded Rectangle 14"/>
+          <p:cNvSpPr/>
+          <p:nvPr/>
+        </p:nvSpPr>
+        <p:spPr>
+          <a:xfrm>
+            <a:off x="6080760" y="4649724"/>
+            <a:ext cx="5605272" cy="1188720"/>
+          </a:xfrm>
+          <a:prstGeom prst="roundRect">
+            <a:avLst>
+              <a:gd name="adj" fmla="val 8000"/>
+            </a:avLst>
+          </a:prstGeom>
+          <a:solidFill>
+            <a:srgbClr val="FBEED9"/>
+          </a:solidFill>
+          <a:ln>
+            <a:noFill/>
+          </a:ln>
+          <a:effectLst/>
+        </p:spPr>
+        <p:style>
+          <a:lnRef idx="1">
+            <a:schemeClr val="accent1"/>
+          </a:lnRef>
+          <a:fillRef idx="3">
+            <a:schemeClr val="accent1"/>
+          </a:fillRef>
+          <a:effectRef idx="2">
+            <a:schemeClr val="accent1"/>
+          </a:effectRef>
+          <a:fontRef idx="minor">
+            <a:schemeClr val="lt1"/>
+          </a:fontRef>
+        </p:style>
+        <p:txBody>
+          <a:bodyPr rtlCol="0" anchor="ctr"/>
+          <a:lstStyle/>
+          <a:p>
+            <a:pPr algn="ctr"/>
+          </a:p>
+        </p:txBody>
+      </p:sp>
+      <p:sp>
+        <p:nvSpPr>
+          <p:cNvPr id="16" name="TextBox 15"/>
+          <p:cNvSpPr txBox="1"/>
+          <p:nvPr/>
+        </p:nvSpPr>
+        <p:spPr>
+          <a:xfrm>
+            <a:off x="6207760" y="4751324"/>
+            <a:ext cx="5351272" cy="1051560"/>
+          </a:xfrm>
+          <a:prstGeom prst="rect">
+            <a:avLst/>
+          </a:prstGeom>
+          <a:noFill/>
+        </p:spPr>
+        <p:txBody>
+          <a:bodyPr wrap="square" lIns="0" rIns="0" tIns="0" bIns="0">
+            <a:spAutoFit/>
+          </a:bodyPr>
+          <a:lstStyle/>
+          <a:p>
+            <a:pPr>
+              <a:spcAft>
+                <a:spcPts val="500"/>
+              </a:spcAft>
+            </a:pPr>
+            <a:r>
+              <a:rPr sz="950" b="1">
+                <a:solidFill>
+                  <a:srgbClr val="1A1A2E"/>
+                </a:solidFill>
+                <a:latin typeface="Segoe UI Semibold"/>
+              </a:rPr>
+              <a:t>Subtotal ~$192K–303K, +15–20% PM/coordination → ~$220K–360K all-in.</a:t>
+            </a:r>
+          </a:p>
+          <a:p>
+            <a:pPr>
+              <a:spcAft>
+                <a:spcPts val="500"/>
+              </a:spcAft>
+            </a:pPr>
+            <a:r>
+              <a:rPr sz="950" b="0">
+                <a:solidFill>
+                  <a:srgbClr val="6B6558"/>
+                </a:solidFill>
+                <a:latin typeface="Segoe UI"/>
+              </a:rPr>
+              <a:t>Typically 4–7+ months with a small team. Nearshore/offshore: ~40–50% of that (~$110K–180K), usually a longer timeline.</a:t>
+            </a:r>
+          </a:p>
+        </p:txBody>
+      </p:sp>
+      <p:sp>
+        <p:nvSpPr>
+          <p:cNvPr id="17" name="Rounded Rectangle 16"/>
+          <p:cNvSpPr/>
+          <p:nvPr/>
+        </p:nvSpPr>
+        <p:spPr>
+          <a:xfrm>
+            <a:off x="6080760" y="5966460"/>
+            <a:ext cx="5605272" cy="566928"/>
+          </a:xfrm>
+          <a:prstGeom prst="roundRect">
+            <a:avLst>
+              <a:gd name="adj" fmla="val 15000"/>
+            </a:avLst>
+          </a:prstGeom>
+          <a:solidFill>
+            <a:srgbClr val="E3EEE9"/>
+          </a:solidFill>
+          <a:ln>
+            <a:noFill/>
+          </a:ln>
+          <a:effectLst/>
+        </p:spPr>
+        <p:style>
+          <a:lnRef idx="1">
+            <a:schemeClr val="accent1"/>
+          </a:lnRef>
+          <a:fillRef idx="3">
+            <a:schemeClr val="accent1"/>
+          </a:fillRef>
+          <a:effectRef idx="2">
+            <a:schemeClr val="accent1"/>
+          </a:effectRef>
+          <a:fontRef idx="minor">
+            <a:schemeClr val="lt1"/>
+          </a:fontRef>
+        </p:style>
+        <p:txBody>
+          <a:bodyPr rtlCol="0" anchor="ctr"/>
+          <a:lstStyle/>
+          <a:p>
+            <a:pPr algn="ctr"/>
+          </a:p>
+        </p:txBody>
+      </p:sp>
+      <p:sp>
+        <p:nvSpPr>
+          <p:cNvPr id="18" name="TextBox 17"/>
+          <p:cNvSpPr txBox="1"/>
+          <p:nvPr/>
+        </p:nvSpPr>
+        <p:spPr>
+          <a:xfrm>
+            <a:off x="6207760" y="6093460"/>
+            <a:ext cx="5351272" cy="384048"/>
+          </a:xfrm>
+          <a:prstGeom prst="rect">
+            <a:avLst/>
+          </a:prstGeom>
+          <a:noFill/>
+        </p:spPr>
+        <p:txBody>
+          <a:bodyPr wrap="square" lIns="0" rIns="0" tIns="0" bIns="0">
+            <a:spAutoFit/>
+          </a:bodyPr>
+          <a:lstStyle/>
+          <a:p>
+            <a:pPr algn="l"/>
+            <a:r>
+              <a:rPr sz="1100" b="1" i="0">
+                <a:solidFill>
+                  <a:srgbClr val="2E6B57"/>
+                </a:solidFill>
+                <a:latin typeface="Segoe UI Semibold"/>
+              </a:rPr>
+              <a:t>This build: ~10 weeks, ~$1,000 estimated engineering cost (see Cost slide).</a:t>
+            </a:r>
+          </a:p>
+        </p:txBody>
+      </p:sp>
+    </p:spTree>
+  </p:cSld>
+  <p:clrMapOvr>
+    <a:masterClrMapping/>
+  </p:clrMapOvr>
+</p:sld>
+</file>
+
+<file path=ppt/slides/slide12.xml><?xml version="1.0" encoding="utf-8"?>
 <p:sld xmlns:a="http://schemas.openxmlformats.org/drawingml/2006/main" xmlns:r="http://schemas.openxmlformats.org/officeDocument/2006/relationships" xmlns:p="http://schemas.openxmlformats.org/presentationml/2006/main" show="0">
   <p:cSld>
     <p:bg>
@@ -5336,7 +6718,7 @@
                 </a:solidFill>
                 <a:latin typeface="Segoe UI Semibold"/>
               </a:rPr>
-              <a:t>$935</a:t>
+              <a:t>$1,018</a:t>
             </a:r>
           </a:p>
         </p:txBody>
@@ -5539,7 +6921,7 @@
                 </a:solidFill>
                 <a:latin typeface="Segoe UI Semibold"/>
               </a:rPr>
-              <a:t>~$6,841</a:t>
+              <a:t>~$6,759</a:t>
             </a:r>
           </a:p>
         </p:txBody>
@@ -5578,7 +6960,7 @@
                 </a:solidFill>
                 <a:latin typeface="Segoe UI"/>
               </a:rPr>
-              <a:t>Running cost = ~12% of margin revenue</a:t>
+              <a:t>Running cost = ~13% of margin revenue</a:t>
             </a:r>
           </a:p>
         </p:txBody>
@@ -5900,7 +7282,7 @@
                 </a:solidFill>
                 <a:latin typeface="Segoe UI Semibold"/>
               </a:rPr>
-              <a:t>$8,472</a:t>
+              <a:t>$8,555</a:t>
             </a:r>
           </a:p>
         </p:txBody>
@@ -6103,7 +7485,7 @@
                 </a:solidFill>
                 <a:latin typeface="Segoe UI Semibold"/>
               </a:rPr>
-              <a:t>~$69,288</a:t>
+              <a:t>~$69,205</a:t>
             </a:r>
           </a:p>
         </p:txBody>
@@ -6184,7 +7566,7 @@
                 </a:solidFill>
                 <a:latin typeface="Segoe UI"/>
               </a:rPr>
-              <a:t>Same story at both scales — compute/infrastructure is a small, roughly flat share of margin (~11–12%). Confirms Luke's own read from July 21: marketing/adoption is the real bottleneck, not running cost. On Haiku 4.5 instead of Sonnet, running cost drops to ~$435/mo (10's) and ~$3,472/mo (100's) — further shrinking that share, at a quality trade-off worth testing before committing.</a:t>
+              <a:t>Same story at both scales -- compute/infrastructure (now including the AWS static-IP relay required for RateHawk certification) is a small, roughly flat share of margin (~11–13%). Confirms Luke's own read from July 21: marketing/adoption is the real bottleneck, not running cost. On Haiku 4.5 instead of Sonnet, running cost drops to ~$518/mo (10's) and ~$3,555/mo (100's) -- further shrinking that share, at a quality trade-off worth testing before committing.</a:t>
             </a:r>
           </a:p>
         </p:txBody>
@@ -6197,7 +7579,900 @@
 </p:sld>
 </file>
 
-<file path=ppt/slides/slide12.xml><?xml version="1.0" encoding="utf-8"?>
+<file path=ppt/slides/slide13.xml><?xml version="1.0" encoding="utf-8"?>
+<p:sld xmlns:a="http://schemas.openxmlformats.org/drawingml/2006/main" xmlns:p="http://schemas.openxmlformats.org/presentationml/2006/main" xmlns:r="http://schemas.openxmlformats.org/officeDocument/2006/relationships">
+  <p:cSld>
+    <p:bg>
+      <p:bgPr>
+        <a:solidFill>
+          <a:srgbClr val="FAF7F2"/>
+        </a:solidFill>
+        <a:effectLst/>
+      </p:bgPr>
+    </p:bg>
+    <p:spTree>
+      <p:nvGrpSpPr>
+        <p:cNvPr id="1" name=""/>
+        <p:cNvGrpSpPr/>
+        <p:nvPr/>
+      </p:nvGrpSpPr>
+      <p:grpSpPr/>
+      <p:sp>
+        <p:nvSpPr>
+          <p:cNvPr id="2" name="TextBox 1"/>
+          <p:cNvSpPr txBox="1"/>
+          <p:nvPr/>
+        </p:nvSpPr>
+        <p:spPr>
+          <a:xfrm>
+            <a:off x="502920" y="457200"/>
+            <a:ext cx="11183112" cy="320040"/>
+          </a:xfrm>
+          <a:prstGeom prst="rect">
+            <a:avLst/>
+          </a:prstGeom>
+          <a:noFill/>
+        </p:spPr>
+        <p:txBody>
+          <a:bodyPr wrap="square" lIns="0" rIns="0" tIns="0" bIns="0">
+            <a:spAutoFit/>
+          </a:bodyPr>
+          <a:lstStyle/>
+          <a:p>
+            <a:pPr algn="l"/>
+            <a:r>
+              <a:rPr sz="1200" b="1">
+                <a:solidFill>
+                  <a:srgbClr val="7A3E0F"/>
+                </a:solidFill>
+                <a:latin typeface="Segoe UI Semibold"/>
+              </a:rPr>
+              <a:t>12  —  RISKS</a:t>
+            </a:r>
+          </a:p>
+        </p:txBody>
+      </p:sp>
+      <p:sp>
+        <p:nvSpPr>
+          <p:cNvPr id="3" name="TextBox 2"/>
+          <p:cNvSpPr txBox="1"/>
+          <p:nvPr/>
+        </p:nvSpPr>
+        <p:spPr>
+          <a:xfrm>
+            <a:off x="502920" y="749808"/>
+            <a:ext cx="11183112" cy="640080"/>
+          </a:xfrm>
+          <a:prstGeom prst="rect">
+            <a:avLst/>
+          </a:prstGeom>
+          <a:noFill/>
+        </p:spPr>
+        <p:txBody>
+          <a:bodyPr wrap="square" lIns="0" rIns="0" tIns="0" bIns="0">
+            <a:spAutoFit/>
+          </a:bodyPr>
+          <a:lstStyle/>
+          <a:p>
+            <a:pPr algn="l"/>
+            <a:r>
+              <a:rPr sz="2700" b="1">
+                <a:solidFill>
+                  <a:srgbClr val="1A1A2E"/>
+                </a:solidFill>
+                <a:latin typeface="Segoe UI Semibold"/>
+              </a:rPr>
+              <a:t>What's still open, now that payments and RateHawk are live</a:t>
+            </a:r>
+          </a:p>
+        </p:txBody>
+      </p:sp>
+      <p:sp>
+        <p:nvSpPr>
+          <p:cNvPr id="4" name="TextBox 3"/>
+          <p:cNvSpPr txBox="1"/>
+          <p:nvPr/>
+        </p:nvSpPr>
+        <p:spPr>
+          <a:xfrm>
+            <a:off x="502920" y="1417320"/>
+            <a:ext cx="10799064" cy="502920"/>
+          </a:xfrm>
+          <a:prstGeom prst="rect">
+            <a:avLst/>
+          </a:prstGeom>
+          <a:noFill/>
+        </p:spPr>
+        <p:txBody>
+          <a:bodyPr wrap="square" lIns="0" rIns="0" tIns="0" bIns="0">
+            <a:spAutoFit/>
+          </a:bodyPr>
+          <a:lstStyle/>
+          <a:p>
+            <a:pPr algn="l"/>
+            <a:r>
+              <a:rPr sz="1350" b="0">
+                <a:solidFill>
+                  <a:srgbClr val="6B6558"/>
+                </a:solidFill>
+                <a:latin typeface="Segoe UI"/>
+              </a:rPr>
+              <a:t>Multi-room booking, real-hotel payments, and RateHawk’s live wiring -- all previously flagged here -- are now built, fixed, and verified as of 8/25. These are the risks that remain.</a:t>
+            </a:r>
+          </a:p>
+        </p:txBody>
+      </p:sp>
+      <p:sp>
+        <p:nvSpPr>
+          <p:cNvPr id="5" name="TextBox 4"/>
+          <p:cNvSpPr txBox="1"/>
+          <p:nvPr/>
+        </p:nvSpPr>
+        <p:spPr>
+          <a:xfrm>
+            <a:off x="502920" y="6528816"/>
+            <a:ext cx="7315200" cy="274320"/>
+          </a:xfrm>
+          <a:prstGeom prst="rect">
+            <a:avLst/>
+          </a:prstGeom>
+          <a:noFill/>
+        </p:spPr>
+        <p:txBody>
+          <a:bodyPr wrap="square" lIns="0" rIns="0" tIns="0" bIns="0">
+            <a:spAutoFit/>
+          </a:bodyPr>
+          <a:lstStyle/>
+          <a:p>
+            <a:pPr algn="l"/>
+            <a:r>
+              <a:rPr sz="900" b="0">
+                <a:solidFill>
+                  <a:srgbClr val="9B9384"/>
+                </a:solidFill>
+                <a:latin typeface="Segoe UI"/>
+              </a:rPr>
+              <a:t>BALKANEA MOBILE  —  SANDBOX / TEST READINESS</a:t>
+            </a:r>
+          </a:p>
+        </p:txBody>
+      </p:sp>
+      <p:sp>
+        <p:nvSpPr>
+          <p:cNvPr id="6" name="TextBox 5"/>
+          <p:cNvSpPr txBox="1"/>
+          <p:nvPr/>
+        </p:nvSpPr>
+        <p:spPr>
+          <a:xfrm>
+            <a:off x="10771632" y="6528816"/>
+            <a:ext cx="914400" cy="274320"/>
+          </a:xfrm>
+          <a:prstGeom prst="rect">
+            <a:avLst/>
+          </a:prstGeom>
+          <a:noFill/>
+        </p:spPr>
+        <p:txBody>
+          <a:bodyPr wrap="square" lIns="0" rIns="0" tIns="0" bIns="0">
+            <a:spAutoFit/>
+          </a:bodyPr>
+          <a:lstStyle/>
+          <a:p>
+            <a:pPr algn="r"/>
+            <a:r>
+              <a:rPr sz="900" b="0">
+                <a:solidFill>
+                  <a:srgbClr val="9B9384"/>
+                </a:solidFill>
+                <a:latin typeface="Segoe UI"/>
+              </a:rPr>
+              <a:t>13</a:t>
+            </a:r>
+          </a:p>
+        </p:txBody>
+      </p:sp>
+      <p:sp>
+        <p:nvSpPr>
+          <p:cNvPr id="7" name="Rounded Rectangle 6"/>
+          <p:cNvSpPr/>
+          <p:nvPr/>
+        </p:nvSpPr>
+        <p:spPr>
+          <a:xfrm>
+            <a:off x="502920" y="2148840"/>
+            <a:ext cx="11183112" cy="932688"/>
+          </a:xfrm>
+          <a:prstGeom prst="roundRect">
+            <a:avLst>
+              <a:gd name="adj" fmla="val 9000"/>
+            </a:avLst>
+          </a:prstGeom>
+          <a:solidFill>
+            <a:srgbClr val="FFFFFF"/>
+          </a:solidFill>
+          <a:ln w="9525">
+            <a:solidFill>
+              <a:srgbClr val="E7E0D3"/>
+            </a:solidFill>
+          </a:ln>
+          <a:effectLst/>
+        </p:spPr>
+        <p:style>
+          <a:lnRef idx="1">
+            <a:schemeClr val="accent1"/>
+          </a:lnRef>
+          <a:fillRef idx="3">
+            <a:schemeClr val="accent1"/>
+          </a:fillRef>
+          <a:effectRef idx="2">
+            <a:schemeClr val="accent1"/>
+          </a:effectRef>
+          <a:fontRef idx="minor">
+            <a:schemeClr val="lt1"/>
+          </a:fontRef>
+        </p:style>
+        <p:txBody>
+          <a:bodyPr rtlCol="0" anchor="ctr"/>
+          <a:lstStyle/>
+          <a:p>
+            <a:pPr algn="ctr"/>
+          </a:p>
+        </p:txBody>
+      </p:sp>
+      <p:sp>
+        <p:nvSpPr>
+          <p:cNvPr id="8" name="TextBox 7"/>
+          <p:cNvSpPr txBox="1"/>
+          <p:nvPr/>
+        </p:nvSpPr>
+        <p:spPr>
+          <a:xfrm>
+            <a:off x="629920" y="2258568"/>
+            <a:ext cx="9466072" cy="201168"/>
+          </a:xfrm>
+          <a:prstGeom prst="rect">
+            <a:avLst/>
+          </a:prstGeom>
+          <a:noFill/>
+        </p:spPr>
+        <p:txBody>
+          <a:bodyPr wrap="square" lIns="0" rIns="0" tIns="0" bIns="0">
+            <a:spAutoFit/>
+          </a:bodyPr>
+          <a:lstStyle/>
+          <a:p>
+            <a:pPr algn="l"/>
+            <a:r>
+              <a:rPr sz="1150" b="1">
+                <a:solidFill>
+                  <a:srgbClr val="1A1A2E"/>
+                </a:solidFill>
+                <a:latin typeface="Segoe UI Semibold"/>
+              </a:rPr>
+              <a:t>RateHawk's sandbox documents (voucher + invoice) return a blank placeholder, not real content</a:t>
+            </a:r>
+          </a:p>
+        </p:txBody>
+      </p:sp>
+      <p:sp>
+        <p:nvSpPr>
+          <p:cNvPr id="9" name="TextBox 8"/>
+          <p:cNvSpPr txBox="1"/>
+          <p:nvPr/>
+        </p:nvSpPr>
+        <p:spPr>
+          <a:xfrm>
+            <a:off x="629920" y="2514600"/>
+            <a:ext cx="10929112" cy="490728"/>
+          </a:xfrm>
+          <a:prstGeom prst="rect">
+            <a:avLst/>
+          </a:prstGeom>
+          <a:noFill/>
+        </p:spPr>
+        <p:txBody>
+          <a:bodyPr wrap="square" lIns="0" rIns="0" tIns="0" bIns="0">
+            <a:spAutoFit/>
+          </a:bodyPr>
+          <a:lstStyle/>
+          <a:p>
+            <a:pPr algn="l"/>
+            <a:r>
+              <a:rPr sz="950" b="0">
+                <a:solidFill>
+                  <a:srgbClr val="6B6558"/>
+                </a:solidFill>
+                <a:latin typeface="Segoe UI"/>
+              </a:rPr>
+              <a:t>Fetching both via RateHawk's real document endpoints returns byte-for-byte identical PDFs -- embedded metadata reads 'Acrobat Distiller 6.0 (Windows)', dated 2006-03-06, clearly a generic template, not a generated document. Not a bug in our integration (request/response plumbing verified correct) -- needs re-verification once production RateHawk credentials are active; sandbox may simply have no real content to render.</a:t>
+            </a:r>
+          </a:p>
+        </p:txBody>
+      </p:sp>
+      <p:sp>
+        <p:nvSpPr>
+          <p:cNvPr id="10" name="Rounded Rectangle 9"/>
+          <p:cNvSpPr/>
+          <p:nvPr/>
+        </p:nvSpPr>
+        <p:spPr>
+          <a:xfrm>
+            <a:off x="10169652" y="2237740"/>
+            <a:ext cx="1414780" cy="182880"/>
+          </a:xfrm>
+          <a:prstGeom prst="roundRect">
+            <a:avLst>
+              <a:gd name="adj" fmla="val 50000"/>
+            </a:avLst>
+          </a:prstGeom>
+          <a:solidFill>
+            <a:srgbClr val="FBEED9"/>
+          </a:solidFill>
+          <a:ln>
+            <a:noFill/>
+          </a:ln>
+          <a:effectLst/>
+        </p:spPr>
+        <p:style>
+          <a:lnRef idx="1">
+            <a:schemeClr val="accent1"/>
+          </a:lnRef>
+          <a:fillRef idx="3">
+            <a:schemeClr val="accent1"/>
+          </a:fillRef>
+          <a:effectRef idx="2">
+            <a:schemeClr val="accent1"/>
+          </a:effectRef>
+          <a:fontRef idx="minor">
+            <a:schemeClr val="lt1"/>
+          </a:fontRef>
+        </p:style>
+        <p:txBody>
+          <a:bodyPr rtlCol="0" anchor="ctr" lIns="0" rIns="0" tIns="0" bIns="0"/>
+          <a:lstStyle/>
+          <a:p>
+            <a:pPr algn="ctr"/>
+            <a:r>
+              <a:rPr sz="750" b="1">
+                <a:solidFill>
+                  <a:srgbClr val="B8790A"/>
+                </a:solidFill>
+                <a:latin typeface="Segoe UI Semibold"/>
+              </a:rPr>
+              <a:t>SANDBOX LIMITATION</a:t>
+            </a:r>
+          </a:p>
+        </p:txBody>
+      </p:sp>
+      <p:sp>
+        <p:nvSpPr>
+          <p:cNvPr id="11" name="Rounded Rectangle 10"/>
+          <p:cNvSpPr/>
+          <p:nvPr/>
+        </p:nvSpPr>
+        <p:spPr>
+          <a:xfrm>
+            <a:off x="502920" y="3218688"/>
+            <a:ext cx="11183112" cy="932688"/>
+          </a:xfrm>
+          <a:prstGeom prst="roundRect">
+            <a:avLst>
+              <a:gd name="adj" fmla="val 9000"/>
+            </a:avLst>
+          </a:prstGeom>
+          <a:solidFill>
+            <a:srgbClr val="FFFFFF"/>
+          </a:solidFill>
+          <a:ln w="9525">
+            <a:solidFill>
+              <a:srgbClr val="E7E0D3"/>
+            </a:solidFill>
+          </a:ln>
+          <a:effectLst/>
+        </p:spPr>
+        <p:style>
+          <a:lnRef idx="1">
+            <a:schemeClr val="accent1"/>
+          </a:lnRef>
+          <a:fillRef idx="3">
+            <a:schemeClr val="accent1"/>
+          </a:fillRef>
+          <a:effectRef idx="2">
+            <a:schemeClr val="accent1"/>
+          </a:effectRef>
+          <a:fontRef idx="minor">
+            <a:schemeClr val="lt1"/>
+          </a:fontRef>
+        </p:style>
+        <p:txBody>
+          <a:bodyPr rtlCol="0" anchor="ctr"/>
+          <a:lstStyle/>
+          <a:p>
+            <a:pPr algn="ctr"/>
+          </a:p>
+        </p:txBody>
+      </p:sp>
+      <p:sp>
+        <p:nvSpPr>
+          <p:cNvPr id="12" name="TextBox 11"/>
+          <p:cNvSpPr txBox="1"/>
+          <p:nvPr/>
+        </p:nvSpPr>
+        <p:spPr>
+          <a:xfrm>
+            <a:off x="629920" y="3328416"/>
+            <a:ext cx="9466072" cy="201168"/>
+          </a:xfrm>
+          <a:prstGeom prst="rect">
+            <a:avLst/>
+          </a:prstGeom>
+          <a:noFill/>
+        </p:spPr>
+        <p:txBody>
+          <a:bodyPr wrap="square" lIns="0" rIns="0" tIns="0" bIns="0">
+            <a:spAutoFit/>
+          </a:bodyPr>
+          <a:lstStyle/>
+          <a:p>
+            <a:pPr algn="l"/>
+            <a:r>
+              <a:rPr sz="1150" b="1">
+                <a:solidFill>
+                  <a:srgbClr val="1A1A2E"/>
+                </a:solidFill>
+                <a:latin typeface="Segoe UI Semibold"/>
+              </a:rPr>
+              <a:t>A reliability bug caused three duplicate real charges today, before being fixed</a:t>
+            </a:r>
+          </a:p>
+        </p:txBody>
+      </p:sp>
+      <p:sp>
+        <p:nvSpPr>
+          <p:cNvPr id="13" name="TextBox 12"/>
+          <p:cNvSpPr txBox="1"/>
+          <p:nvPr/>
+        </p:nvSpPr>
+        <p:spPr>
+          <a:xfrm>
+            <a:off x="629920" y="3584448"/>
+            <a:ext cx="10929112" cy="490728"/>
+          </a:xfrm>
+          <a:prstGeom prst="rect">
+            <a:avLst/>
+          </a:prstGeom>
+          <a:noFill/>
+        </p:spPr>
+        <p:txBody>
+          <a:bodyPr wrap="square" lIns="0" rIns="0" tIns="0" bIns="0">
+            <a:spAutoFit/>
+          </a:bodyPr>
+          <a:lstStyle/>
+          <a:p>
+            <a:pPr algn="l"/>
+            <a:r>
+              <a:rPr sz="950" b="0">
+                <a:solidFill>
+                  <a:srgbClr val="6B6558"/>
+                </a:solidFill>
+                <a:latin typeface="Segoe UI"/>
+              </a:rPr>
+              <a:t>The booking screen could get stuck indefinitely on ‘Confirming with the hotel’ if a step failed after payment had already captured. Because real RateHawk confirmation genuinely takes 90-140+ seconds, this read as frozen; force-quitting and retrying created a brand-new charge each time. Result: three real Bankart charges for one intended test booking -- harmless only because it was a test card. Now fixed (proper error states + a real progress bar); the lesson is this exact bug class is what causes real duplicate charges against a real guest.</a:t>
+            </a:r>
+          </a:p>
+        </p:txBody>
+      </p:sp>
+      <p:sp>
+        <p:nvSpPr>
+          <p:cNvPr id="14" name="Rounded Rectangle 13"/>
+          <p:cNvSpPr/>
+          <p:nvPr/>
+        </p:nvSpPr>
+        <p:spPr>
+          <a:xfrm>
+            <a:off x="10640822" y="3307588"/>
+            <a:ext cx="943610" cy="182880"/>
+          </a:xfrm>
+          <a:prstGeom prst="roundRect">
+            <a:avLst>
+              <a:gd name="adj" fmla="val 50000"/>
+            </a:avLst>
+          </a:prstGeom>
+          <a:solidFill>
+            <a:srgbClr val="E3EEE9"/>
+          </a:solidFill>
+          <a:ln>
+            <a:noFill/>
+          </a:ln>
+          <a:effectLst/>
+        </p:spPr>
+        <p:style>
+          <a:lnRef idx="1">
+            <a:schemeClr val="accent1"/>
+          </a:lnRef>
+          <a:fillRef idx="3">
+            <a:schemeClr val="accent1"/>
+          </a:fillRef>
+          <a:effectRef idx="2">
+            <a:schemeClr val="accent1"/>
+          </a:effectRef>
+          <a:fontRef idx="minor">
+            <a:schemeClr val="lt1"/>
+          </a:fontRef>
+        </p:style>
+        <p:txBody>
+          <a:bodyPr rtlCol="0" anchor="ctr" lIns="0" rIns="0" tIns="0" bIns="0"/>
+          <a:lstStyle/>
+          <a:p>
+            <a:pPr algn="ctr"/>
+            <a:r>
+              <a:rPr sz="750" b="1">
+                <a:solidFill>
+                  <a:srgbClr val="2E6B57"/>
+                </a:solidFill>
+                <a:latin typeface="Segoe UI Semibold"/>
+              </a:rPr>
+              <a:t>FIXED TODAY</a:t>
+            </a:r>
+          </a:p>
+        </p:txBody>
+      </p:sp>
+      <p:sp>
+        <p:nvSpPr>
+          <p:cNvPr id="15" name="Rounded Rectangle 14"/>
+          <p:cNvSpPr/>
+          <p:nvPr/>
+        </p:nvSpPr>
+        <p:spPr>
+          <a:xfrm>
+            <a:off x="502920" y="4288536"/>
+            <a:ext cx="11183112" cy="932688"/>
+          </a:xfrm>
+          <a:prstGeom prst="roundRect">
+            <a:avLst>
+              <a:gd name="adj" fmla="val 9000"/>
+            </a:avLst>
+          </a:prstGeom>
+          <a:solidFill>
+            <a:srgbClr val="FFFFFF"/>
+          </a:solidFill>
+          <a:ln w="9525">
+            <a:solidFill>
+              <a:srgbClr val="E7E0D3"/>
+            </a:solidFill>
+          </a:ln>
+          <a:effectLst/>
+        </p:spPr>
+        <p:style>
+          <a:lnRef idx="1">
+            <a:schemeClr val="accent1"/>
+          </a:lnRef>
+          <a:fillRef idx="3">
+            <a:schemeClr val="accent1"/>
+          </a:fillRef>
+          <a:effectRef idx="2">
+            <a:schemeClr val="accent1"/>
+          </a:effectRef>
+          <a:fontRef idx="minor">
+            <a:schemeClr val="lt1"/>
+          </a:fontRef>
+        </p:style>
+        <p:txBody>
+          <a:bodyPr rtlCol="0" anchor="ctr"/>
+          <a:lstStyle/>
+          <a:p>
+            <a:pPr algn="ctr"/>
+          </a:p>
+        </p:txBody>
+      </p:sp>
+      <p:sp>
+        <p:nvSpPr>
+          <p:cNvPr id="16" name="TextBox 15"/>
+          <p:cNvSpPr txBox="1"/>
+          <p:nvPr/>
+        </p:nvSpPr>
+        <p:spPr>
+          <a:xfrm>
+            <a:off x="629920" y="4398264"/>
+            <a:ext cx="9466072" cy="201168"/>
+          </a:xfrm>
+          <a:prstGeom prst="rect">
+            <a:avLst/>
+          </a:prstGeom>
+          <a:noFill/>
+        </p:spPr>
+        <p:txBody>
+          <a:bodyPr wrap="square" lIns="0" rIns="0" tIns="0" bIns="0">
+            <a:spAutoFit/>
+          </a:bodyPr>
+          <a:lstStyle/>
+          <a:p>
+            <a:pPr algn="l"/>
+            <a:r>
+              <a:rPr sz="1150" b="1">
+                <a:solidFill>
+                  <a:srgbClr val="1A1A2E"/>
+                </a:solidFill>
+                <a:latin typeface="Segoe UI Semibold"/>
+              </a:rPr>
+              <a:t>Bankart's hosted card page still isn't mobile-responsive</a:t>
+            </a:r>
+          </a:p>
+        </p:txBody>
+      </p:sp>
+      <p:sp>
+        <p:nvSpPr>
+          <p:cNvPr id="17" name="TextBox 16"/>
+          <p:cNvSpPr txBox="1"/>
+          <p:nvPr/>
+        </p:nvSpPr>
+        <p:spPr>
+          <a:xfrm>
+            <a:off x="629920" y="4654296"/>
+            <a:ext cx="10929112" cy="490728"/>
+          </a:xfrm>
+          <a:prstGeom prst="rect">
+            <a:avLst/>
+          </a:prstGeom>
+          <a:noFill/>
+        </p:spPr>
+        <p:txBody>
+          <a:bodyPr wrap="square" lIns="0" rIns="0" tIns="0" bIns="0">
+            <a:spAutoFit/>
+          </a:bodyPr>
+          <a:lstStyle/>
+          <a:p>
+            <a:pPr algn="l"/>
+            <a:r>
+              <a:rPr sz="950" b="0">
+                <a:solidFill>
+                  <a:srgbClr val="6B6558"/>
+                </a:solidFill>
+                <a:latin typeface="Segoe UI"/>
+              </a:rPr>
+              <a:t>Input fields still misalign on phone and tablet, and the page has no billing-address or independent 'name on card' field (a guest can pay for someone else's booking). A full written spec -- brand colors, autofill attributes, missing fields -- was sent to Hristijan 8/25. Not yet built on his side.</a:t>
+            </a:r>
+          </a:p>
+        </p:txBody>
+      </p:sp>
+      <p:sp>
+        <p:nvSpPr>
+          <p:cNvPr id="18" name="Rounded Rectangle 17"/>
+          <p:cNvSpPr/>
+          <p:nvPr/>
+        </p:nvSpPr>
+        <p:spPr>
+          <a:xfrm>
+            <a:off x="10304272" y="4377436"/>
+            <a:ext cx="1280160" cy="182880"/>
+          </a:xfrm>
+          <a:prstGeom prst="roundRect">
+            <a:avLst>
+              <a:gd name="adj" fmla="val 50000"/>
+            </a:avLst>
+          </a:prstGeom>
+          <a:solidFill>
+            <a:srgbClr val="FBEED9"/>
+          </a:solidFill>
+          <a:ln>
+            <a:noFill/>
+          </a:ln>
+          <a:effectLst/>
+        </p:spPr>
+        <p:style>
+          <a:lnRef idx="1">
+            <a:schemeClr val="accent1"/>
+          </a:lnRef>
+          <a:fillRef idx="3">
+            <a:schemeClr val="accent1"/>
+          </a:fillRef>
+          <a:effectRef idx="2">
+            <a:schemeClr val="accent1"/>
+          </a:effectRef>
+          <a:fontRef idx="minor">
+            <a:schemeClr val="lt1"/>
+          </a:fontRef>
+        </p:style>
+        <p:txBody>
+          <a:bodyPr rtlCol="0" anchor="ctr" lIns="0" rIns="0" tIns="0" bIns="0"/>
+          <a:lstStyle/>
+          <a:p>
+            <a:pPr algn="ctr"/>
+            <a:r>
+              <a:rPr sz="750" b="1">
+                <a:solidFill>
+                  <a:srgbClr val="B8790A"/>
+                </a:solidFill>
+                <a:latin typeface="Segoe UI Semibold"/>
+              </a:rPr>
+              <a:t>OPEN — HRISTIJAN</a:t>
+            </a:r>
+          </a:p>
+        </p:txBody>
+      </p:sp>
+      <p:sp>
+        <p:nvSpPr>
+          <p:cNvPr id="19" name="Rounded Rectangle 18"/>
+          <p:cNvSpPr/>
+          <p:nvPr/>
+        </p:nvSpPr>
+        <p:spPr>
+          <a:xfrm>
+            <a:off x="502920" y="5358384"/>
+            <a:ext cx="11183112" cy="932688"/>
+          </a:xfrm>
+          <a:prstGeom prst="roundRect">
+            <a:avLst>
+              <a:gd name="adj" fmla="val 9000"/>
+            </a:avLst>
+          </a:prstGeom>
+          <a:solidFill>
+            <a:srgbClr val="FFFFFF"/>
+          </a:solidFill>
+          <a:ln w="9525">
+            <a:solidFill>
+              <a:srgbClr val="E7E0D3"/>
+            </a:solidFill>
+          </a:ln>
+          <a:effectLst/>
+        </p:spPr>
+        <p:style>
+          <a:lnRef idx="1">
+            <a:schemeClr val="accent1"/>
+          </a:lnRef>
+          <a:fillRef idx="3">
+            <a:schemeClr val="accent1"/>
+          </a:fillRef>
+          <a:effectRef idx="2">
+            <a:schemeClr val="accent1"/>
+          </a:effectRef>
+          <a:fontRef idx="minor">
+            <a:schemeClr val="lt1"/>
+          </a:fontRef>
+        </p:style>
+        <p:txBody>
+          <a:bodyPr rtlCol="0" anchor="ctr"/>
+          <a:lstStyle/>
+          <a:p>
+            <a:pPr algn="ctr"/>
+          </a:p>
+        </p:txBody>
+      </p:sp>
+      <p:sp>
+        <p:nvSpPr>
+          <p:cNvPr id="20" name="TextBox 19"/>
+          <p:cNvSpPr txBox="1"/>
+          <p:nvPr/>
+        </p:nvSpPr>
+        <p:spPr>
+          <a:xfrm>
+            <a:off x="629920" y="5468112"/>
+            <a:ext cx="9466072" cy="201168"/>
+          </a:xfrm>
+          <a:prstGeom prst="rect">
+            <a:avLst/>
+          </a:prstGeom>
+          <a:noFill/>
+        </p:spPr>
+        <p:txBody>
+          <a:bodyPr wrap="square" lIns="0" rIns="0" tIns="0" bIns="0">
+            <a:spAutoFit/>
+          </a:bodyPr>
+          <a:lstStyle/>
+          <a:p>
+            <a:pPr algn="l"/>
+            <a:r>
+              <a:rPr sz="1150" b="1">
+                <a:solidFill>
+                  <a:srgbClr val="1A1A2E"/>
+                </a:solidFill>
+                <a:latin typeface="Segoe UI Semibold"/>
+              </a:rPr>
+              <a:t>Business-team booking notification email is hardcoded to a placeholder address</a:t>
+            </a:r>
+          </a:p>
+        </p:txBody>
+      </p:sp>
+      <p:sp>
+        <p:nvSpPr>
+          <p:cNvPr id="21" name="TextBox 20"/>
+          <p:cNvSpPr txBox="1"/>
+          <p:nvPr/>
+        </p:nvSpPr>
+        <p:spPr>
+          <a:xfrm>
+            <a:off x="629920" y="5724144"/>
+            <a:ext cx="10929112" cy="490728"/>
+          </a:xfrm>
+          <a:prstGeom prst="rect">
+            <a:avLst/>
+          </a:prstGeom>
+          <a:noFill/>
+        </p:spPr>
+        <p:txBody>
+          <a:bodyPr wrap="square" lIns="0" rIns="0" tIns="0" bIns="0">
+            <a:spAutoFit/>
+          </a:bodyPr>
+          <a:lstStyle/>
+          <a:p>
+            <a:pPr algn="l"/>
+            <a:r>
+              <a:rPr sz="950" b="0">
+                <a:solidFill>
+                  <a:srgbClr val="6B6558"/>
+                </a:solidFill>
+                <a:latin typeface="Segoe UI"/>
+              </a:rPr>
+              <a:t>New today: confirmed real RateHawk bookings now trigger automated emails -- the guest gets their voucher PDF, the business team gets the invoice PDF (Resend). The business recipient is currently hardcoded to Ray's own address as a placeholder, not a real shared team inbox -- needs to move before this is production-ready.</a:t>
+            </a:r>
+          </a:p>
+        </p:txBody>
+      </p:sp>
+      <p:sp>
+        <p:nvSpPr>
+          <p:cNvPr id="22" name="Rounded Rectangle 21"/>
+          <p:cNvSpPr/>
+          <p:nvPr/>
+        </p:nvSpPr>
+        <p:spPr>
+          <a:xfrm>
+            <a:off x="10640822" y="5447284"/>
+            <a:ext cx="943610" cy="182880"/>
+          </a:xfrm>
+          <a:prstGeom prst="roundRect">
+            <a:avLst>
+              <a:gd name="adj" fmla="val 50000"/>
+            </a:avLst>
+          </a:prstGeom>
+          <a:solidFill>
+            <a:srgbClr val="FBEED9"/>
+          </a:solidFill>
+          <a:ln>
+            <a:noFill/>
+          </a:ln>
+          <a:effectLst/>
+        </p:spPr>
+        <p:style>
+          <a:lnRef idx="1">
+            <a:schemeClr val="accent1"/>
+          </a:lnRef>
+          <a:fillRef idx="3">
+            <a:schemeClr val="accent1"/>
+          </a:fillRef>
+          <a:effectRef idx="2">
+            <a:schemeClr val="accent1"/>
+          </a:effectRef>
+          <a:fontRef idx="minor">
+            <a:schemeClr val="lt1"/>
+          </a:fontRef>
+        </p:style>
+        <p:txBody>
+          <a:bodyPr rtlCol="0" anchor="ctr" lIns="0" rIns="0" tIns="0" bIns="0"/>
+          <a:lstStyle/>
+          <a:p>
+            <a:pPr algn="ctr"/>
+            <a:r>
+              <a:rPr sz="750" b="1">
+                <a:solidFill>
+                  <a:srgbClr val="B8790A"/>
+                </a:solidFill>
+                <a:latin typeface="Segoe UI Semibold"/>
+              </a:rPr>
+              <a:t>PLACEHOLDER</a:t>
+            </a:r>
+          </a:p>
+        </p:txBody>
+      </p:sp>
+    </p:spTree>
+  </p:cSld>
+  <p:clrMapOvr>
+    <a:masterClrMapping/>
+  </p:clrMapOvr>
+</p:sld>
+</file>
+
+<file path=ppt/slides/slide14.xml><?xml version="1.0" encoding="utf-8"?>
 <p:sld xmlns:a="http://schemas.openxmlformats.org/drawingml/2006/main" xmlns:r="http://schemas.openxmlformats.org/officeDocument/2006/relationships" xmlns:p="http://schemas.openxmlformats.org/presentationml/2006/main">
   <p:cSld>
     <p:bg>
@@ -6256,7 +8531,7 @@
                 </a:solidFill>
                 <a:latin typeface="Segoe UI"/>
               </a:rPr>
-              <a:t>12  —  STILL OPEN</a:t>
+              <a:t>13  —  STILL OPEN</a:t>
             </a:r>
           </a:p>
         </p:txBody>
@@ -6289,31 +8564,13 @@
               </a:spcAft>
             </a:pPr>
             <a:r>
-              <a:rPr sz="2700" b="1" dirty="0">
+              <a:rPr sz="2700" b="1">
                 <a:solidFill>
                   <a:srgbClr val="1A1A2E"/>
                 </a:solidFill>
                 <a:latin typeface="Segoe UI Semibold"/>
               </a:rPr>
-              <a:t>What's still open, and </a:t>
-            </a:r>
-            <a:r>
-              <a:rPr sz="2700" b="1">
-                <a:solidFill>
-                  <a:srgbClr val="1A1A2E"/>
-                </a:solidFill>
-                <a:latin typeface="Segoe UI Semibold"/>
-              </a:rPr>
-              <a:t>what's moving</a:t>
-            </a:r>
-            <a:r>
-              <a:rPr lang="en-US" sz="2700" b="1">
-                <a:solidFill>
-                  <a:srgbClr val="1A1A2E"/>
-                </a:solidFill>
-                <a:latin typeface="Segoe UI Semibold"/>
-              </a:rPr>
-              <a:t>.</a:t>
+              <a:t>What's still genuinely open, and who owns it</a:t>
             </a:r>
             <a:endParaRPr sz="2700" b="1" dirty="0">
               <a:solidFill>
@@ -6358,7 +8615,7 @@
                 </a:solidFill>
                 <a:latin typeface="Segoe UI"/>
               </a:rPr>
-              <a:t>Plus one hard scheduling constraint that should anchor any target date.</a:t>
+              <a:t>The strategic risks are on the Risks slide. This is the operational punch list.</a:t>
             </a:r>
           </a:p>
         </p:txBody>
@@ -6436,7 +8693,7 @@
                 </a:solidFill>
                 <a:latin typeface="Segoe UI"/>
               </a:rPr>
-              <a:t>13</a:t>
+              <a:t>14</a:t>
             </a:r>
           </a:p>
         </p:txBody>
@@ -6524,7 +8781,7 @@
                 </a:solidFill>
                 <a:latin typeface="Segoe UI Semibold"/>
               </a:rPr>
-              <a:t>RateHawk sandbox</a:t>
+              <a:t>Apple + Google Play accounts</a:t>
             </a:r>
           </a:p>
         </p:txBody>
@@ -6566,7 +8823,7 @@
                 </a:solidFill>
                 <a:latin typeface="Segoe UI"/>
               </a:rPr>
-              <a:t>Key landed 8/17 under the “balkanea-mobile” Office (ID 954) but calls return incorrect_credentials — checked RateHawk’s docs, looks more like an inactive key than IP whitelisting (that only shows up as a later certification-checklist item). Next: email RateHawk support directly, then start the certification checklist — which also needs 2 test hotels added to our DB first.</a:t>
+              <a:t>Apple: native Sign-in code shipped 8/5, still needs a Services ID + signed JWT from Ray's own Apple Developer account. Google Play: developer account still not created (confirmed not started as of the July 24 call) -- account verification itself takes calendar time independent of app readiness. Both Ray-owned, not build-gated.</a:t>
             </a:r>
           </a:p>
         </p:txBody>
@@ -6654,7 +8911,7 @@
                 </a:solidFill>
                 <a:latin typeface="Segoe UI Semibold"/>
               </a:rPr>
-              <a:t>Search-flow design</a:t>
+              <a:t>Bankart mobile-responsive checkout</a:t>
             </a:r>
           </a:p>
         </p:txBody>
@@ -6696,7 +8953,7 @@
                 </a:solidFill>
                 <a:latin typeface="Segoe UI"/>
               </a:rPr>
-              <a:t>Resolved by RateHawk's own rules, not a preference: their docs prohibit live Content API calls during search, so DB-first is required. Still needs building.</a:t>
+              <a:t>Bankart's hosted card page isn't mobile-responsive today, and is missing billing-address and cardholder-name fields. Written spec sent to Hristijan 8/25 (design tokens, autofill attributes, field list). On his side to build.</a:t>
             </a:r>
           </a:p>
         </p:txBody>
@@ -6784,7 +9041,7 @@
                 </a:solidFill>
                 <a:latin typeface="Segoe UI Semibold"/>
               </a:rPr>
-              <a:t>Payment path</a:t>
+              <a:t>Admin portal WooCommerce-parity gap</a:t>
             </a:r>
           </a:p>
         </p:txBody>
@@ -6826,7 +9083,7 @@
                 </a:solidFill>
                 <a:latin typeface="Segoe UI"/>
               </a:rPr>
-              <a:t>Confirmed 8/20: a real end-to-end payment cleared through NLB via Bankart, from the app's booking flow to a synced Salesforce lead. Only remaining item: Bankart's hosted card page isn't mobile-responsive on phone/tablet — Hristijan-side fix. RateHawk's booking flow draws on its own deposit balance, not the guest's card, so RateHawk build work doesn't wait on this.</a:t>
+              <a:t>admin-payments.html covers bookings + payment state, with Capture/Void stubbed -- but doesn't yet cover WooCommerce's refunds/cancellations/invoicing. Gap inventoried, not yet built.</a:t>
             </a:r>
           </a:p>
         </p:txBody>
@@ -6908,7 +9165,7 @@
               </a:spcAft>
             </a:pPr>
             <a:r>
-              <a:rPr sz="1400" b="1" dirty="0">
+              <a:rPr sz="1400" b="1">
                 <a:solidFill>
                   <a:srgbClr val="1A1A2E"/>
                 </a:solidFill>
@@ -6956,7 +9213,7 @@
                 </a:solidFill>
                 <a:latin typeface="Segoe UI"/>
               </a:rPr>
-              <a:t>Email to RateHawk support on key 954 status; mobile-responsive fix timeline for Bankart's hosted card page, from Hristijan</a:t>
+              <a:t>From Ray: Apple Services ID/JWT, Google Play account. From Hristijan: mobile-responsive fix + billing/cardholder-name fields (spec sent 8/25). From Claude: RateHawk wiring + multi-room build are both done -- next is RateHawk's certification questionnaire.</a:t>
             </a:r>
           </a:p>
         </p:txBody>
@@ -6989,22 +9246,13 @@
               </a:spcAft>
             </a:pPr>
             <a:r>
-              <a:rPr sz="950" b="1" dirty="0">
+              <a:rPr sz="950" b="1">
                 <a:solidFill>
                   <a:srgbClr val="9B9384"/>
                 </a:solidFill>
                 <a:latin typeface="Segoe UI"/>
               </a:rPr>
-              <a:t>Store submission, once ready: </a:t>
-            </a:r>
-            <a:r>
-              <a:rPr sz="950" b="0" dirty="0">
-                <a:solidFill>
-                  <a:srgbClr val="9B9384"/>
-                </a:solidFill>
-                <a:latin typeface="Segoe UI"/>
-              </a:rPr>
-              <a:t>no Google Play account yet · Apple review ~3–5 days · Google's 14-day closed-testing minimum · ~1 month+ total, RateHawk cert now runs in parallel.</a:t>
+              <a:t>Store submission, once ready: no Google Play account yet · Apple review ~3–5 days · Google's 14-day closed-testing minimum · RateHawk cert runs in parallel.</a:t>
             </a:r>
           </a:p>
         </p:txBody>
@@ -8009,7 +10257,7 @@
                 </a:solidFill>
                 <a:latin typeface="Segoe UI Semibold"/>
               </a:rPr>
-              <a:t>Hotel database is live; sandbox key issued, likely needs reactivating</a:t>
+              <a:t>RateHawk sandbox is live; full booking flow proven end-to-end</a:t>
             </a:r>
           </a:p>
         </p:txBody>
@@ -8048,7 +10296,7 @@
                 </a:solidFill>
                 <a:latin typeface="Segoe UI"/>
               </a:rPr>
-              <a:t>The hotel-DB half of this is done. The sandbox key landed 8/17 but calls fail with 401 — checking RateHawk’s own docs points more toward an inactive key than IP whitelisting. Search-flow decision and booking endpoints still ahead.</a:t>
+              <a:t>Sandbox key 973 replaced the blocked key 954 and returns real search results across all sandbox regions. The complete booking sequence -- search, prebook, create order, finish -- has been proven against RateHawk's own certification test hotels, including every mandatory certification scenario.</a:t>
             </a:r>
           </a:p>
         </p:txBody>
@@ -8261,7 +10509,7 @@
                 </a:solidFill>
                 <a:latin typeface="Segoe UI"/>
               </a:rPr>
-              <a:t>BLOCKED</a:t>
+              <a:t>RESOLVED</a:t>
             </a:r>
           </a:p>
         </p:txBody>
@@ -8300,7 +10548,7 @@
                 </a:solidFill>
                 <a:latin typeface="Segoe UI Semibold"/>
               </a:rPr>
-              <a:t>Sandbox key issued (ID 954) — first calls blocked, not by bad credentials</a:t>
+              <a:t>Sandbox key 973 -- issued and verified 8/24, replacing blocked key 954</a:t>
             </a:r>
           </a:p>
         </p:txBody>
@@ -8342,7 +10590,7 @@
                 </a:solidFill>
                 <a:latin typeface="Segoe UI"/>
               </a:rPr>
-              <a:t>Received 8/17 under the “balkanea-mobile” Office (contract slug accepted by RateHawk 8/14): Key ID 954 + access token. Live calls return 401, key recognized but token unmatched — checked RateHawk’s own docs since, whitelisting reads as a certification-stage item, not a sandbox gate, so this looks more like an inactive key. See slide 5.</a:t>
+              <a:t>RateHawk confirmed the 401s on key 954 were a technical issue on their side, not IP whitelisting -- a new key (973) was issued and verified with real search results. Sandbox itself needs no IP whitelisting at all; that only applies at production certification (see Risks).</a:t>
             </a:r>
           </a:p>
         </p:txBody>
@@ -8780,7 +11028,7 @@
                 </a:solidFill>
                 <a:latin typeface="Segoe UI"/>
               </a:rPr>
-              <a:t>850,218 hotels / 3,930,128 rooms imported and indexed across all 10 target countries (0 parse errors). Region-filtered, sorted queries benchmarked at ~0.2ms server-side — round trip is now ~215ms of pure network latency, not DB work. Hristijan already has Developer access to query it directly.</a:t>
+              <a:t>850,218 hotels / 3,930,128 rooms imported and indexed across all 10 target countries (0 parse errors). Region-filtered, sorted queries benchmarked at ~0.2ms server-side. Hristijan already has Developer access to query it directly.</a:t>
             </a:r>
           </a:p>
         </p:txBody>
@@ -8851,7 +11099,7 @@
             </a:avLst>
           </a:prstGeom>
           <a:solidFill>
-            <a:srgbClr val="FBEED9"/>
+            <a:srgbClr val="E3EEE9"/>
           </a:solidFill>
           <a:ln>
             <a:noFill/>
@@ -8909,13 +11157,13 @@
               </a:spcAft>
             </a:pPr>
             <a:r>
-              <a:rPr lang="en-US" sz="750" b="1" dirty="0">
-                <a:solidFill>
-                  <a:srgbClr val="B8790A"/>
+              <a:rPr sz="750" b="1">
+                <a:solidFill>
+                  <a:srgbClr val="2E6B57"/>
                 </a:solidFill>
                 <a:latin typeface="Segoe UI"/>
               </a:rPr>
-              <a:t>Open</a:t>
+              <a:t>CONFIRMED</a:t>
             </a:r>
             <a:endParaRPr sz="750" b="1" dirty="0">
               <a:solidFill>
@@ -8960,7 +11208,7 @@
                 </a:solidFill>
                 <a:latin typeface="Segoe UI Semibold"/>
               </a:rPr>
-              <a:t>Search-flow now settled by RateHawk's own rules; booking endpoints + 2 missing test hotels still to build</a:t>
+              <a:t>Full booking flow proven end-to-end in sandbox, including multi-room</a:t>
             </a:r>
           </a:p>
         </p:txBody>
@@ -8996,49 +11244,13 @@
               </a:spcAft>
             </a:pPr>
             <a:r>
-              <a:rPr sz="1050" b="0" dirty="0">
+              <a:rPr sz="1050" b="0">
                 <a:solidFill>
                   <a:srgbClr val="6B6558"/>
                 </a:solidFill>
                 <a:latin typeface="Segoe UI"/>
               </a:rPr>
-              <a:t>Not actually a choice anymore: </a:t>
-            </a:r>
-            <a:r>
-              <a:rPr sz="1050" b="0" dirty="0" err="1">
-                <a:solidFill>
-                  <a:srgbClr val="6B6558"/>
-                </a:solidFill>
-                <a:latin typeface="Segoe UI"/>
-              </a:rPr>
-              <a:t>RateHawk's</a:t>
-            </a:r>
-            <a:r>
-              <a:rPr sz="1050" b="0" dirty="0">
-                <a:solidFill>
-                  <a:srgbClr val="6B6558"/>
-                </a:solidFill>
-                <a:latin typeface="Segoe UI"/>
-              </a:rPr>
-              <a:t> docs prohibit calling the Content API live during search, so DB-first is required, not just faster. None of the room-rate, pre-book, or create-order calls exist yet. New: certification needs 2 specific test hotels (Conrad LA + one other) that aren't in our DB — confirmed</a:t>
-            </a:r>
-            <a:r>
-              <a:rPr lang="en-US" sz="1050" b="0" dirty="0">
-                <a:solidFill>
-                  <a:srgbClr val="6B6558"/>
-                </a:solidFill>
-                <a:latin typeface="Segoe UI"/>
-              </a:rPr>
-              <a:t>.</a:t>
-            </a:r>
-            <a:r>
-              <a:rPr sz="1050" b="0" dirty="0">
-                <a:solidFill>
-                  <a:srgbClr val="6B6558"/>
-                </a:solidFill>
-                <a:latin typeface="Segoe UI"/>
-              </a:rPr>
-              <a:t> </a:t>
+              <a:t>Search → prebook → create order → finish now runs successfully against RateHawk's certification test hotels (Conrad LA, Rosa Bell Motel) -- all 7 mandatory scenarios passed, real order IDs captured. Live-app wiring and the room-by-room guest picker UI are both built and verified -- three real bookings processed through the actual app today.</a:t>
             </a:r>
           </a:p>
         </p:txBody>
@@ -9149,7 +11361,7 @@
                 </a:solidFill>
                 <a:latin typeface="Segoe UI Semibold"/>
               </a:rPr>
-              <a:t>Bank checkout works end-to-end — confirmed live with NLB</a:t>
+              <a:t>Bank checkout works end-to-end -- confirmed live with NLB, in MKD</a:t>
             </a:r>
           </a:p>
         </p:txBody>
@@ -9188,7 +11400,7 @@
                 </a:solidFill>
                 <a:latin typeface="Segoe UI"/>
               </a:rPr>
-              <a:t>Confirmed 8/20: a real test-card payment cleared through NLB via Bankart, from the app's booking flow to a synced Salesforce lead. What's left: making Bankart's hosted card page render correctly on phones and tablets.</a:t>
+              <a:t>Confirmed 8/20 (demo hotel) and 8/25 (real RateHawk hotel, after fixing a merchantTransactionId length bug): real test-card payments clear through NLB via Bankart, from the app's booking flow to a synced Salesforce lead. Settles in MKD -- see Risks for what's still open.</a:t>
             </a:r>
           </a:p>
         </p:txBody>
@@ -9656,7 +11868,7 @@
                 </a:solidFill>
                 <a:latin typeface="Segoe UI Semibold"/>
               </a:rPr>
-              <a:t>Balkanea Payment Bridge — built and confirmed working end-to-end</a:t>
+              <a:t>Balkanea Payment Bridge -- built and confirmed working end-to-end, MKD settlement</a:t>
             </a:r>
           </a:p>
         </p:txBody>
@@ -9698,7 +11910,7 @@
                 </a:solidFill>
                 <a:latin typeface="Segoe UI"/>
               </a:rPr>
-              <a:t>Hristijan's ‘Balkanea Payment Bridge’ plugin (signed HMAC links, Bankart Gateway V3 hosted card form, async Notify webhook) is live. Confirmed 8/20: a real test-card payment cleared through NLB, initiated from the actual mobile app booking flow — 3DS, async postback, booking auto-confirm, and Salesforce sync all verified working end-to-end.</a:t>
+              <a:t>Hristijan's ‘Balkanea Payment Bridge’ plugin (signed HMAC links, Bankart Gateway V3 hosted card form, async Notify webhook) is live. Confirmed 8/20 and re-confirmed 8/25 against a real RateHawk hotel, settling in MKD (Bankart's only supported currency). 8/25 also found and fixed the root cause of intermittent failures -- Hristijan's plugin was silently exceeding Bankart's 50-character reference limit on real-hotel bookings. Fixed app-side; charges now clear reliably.</a:t>
             </a:r>
           </a:p>
         </p:txBody>
@@ -9914,7 +12126,7 @@
                 </a:solidFill>
                 <a:latin typeface="Segoe UI"/>
               </a:rPr>
-              <a:t>Bankart's hosted card page isn't mobile-responsive today — input fields misalign on phone and tablet, iOS and Android. That's the one open item blocking a clean guest-facing checkout; on Hristijan's side to fix.</a:t>
+              <a:t>Bankart's hosted card page still isn't mobile-responsive, and also doesn't collect billing address or a separate ‘name on card’ field (needed since the payer isn't always the guest). A full written spec -- Balkanea's brand colors, autofill support, and these missing fields -- was sent to Hristijan 8/25. Still his to build.</a:t>
             </a:r>
           </a:p>
         </p:txBody>
@@ -9976,31 +12188,13 @@
           <a:p>
             <a:pPr algn="l"/>
             <a:r>
-              <a:rPr sz="1200" b="1" i="0" dirty="0">
+              <a:rPr sz="1200" b="1">
                 <a:solidFill>
                   <a:srgbClr val="7A3E0F"/>
                 </a:solidFill>
                 <a:latin typeface="Segoe UI Semibold"/>
               </a:rPr>
-              <a:t>05  —  PROXY: </a:t>
-            </a:r>
-            <a:r>
-              <a:rPr lang="en-US" sz="1200" b="1" dirty="0">
-                <a:solidFill>
-                  <a:srgbClr val="7A3E0F"/>
-                </a:solidFill>
-                <a:latin typeface="Segoe UI Semibold"/>
-              </a:rPr>
-              <a:t>Proposal</a:t>
-            </a:r>
-            <a:r>
-              <a:rPr sz="1200" b="1" i="0" dirty="0">
-                <a:solidFill>
-                  <a:srgbClr val="7A3E0F"/>
-                </a:solidFill>
-                <a:latin typeface="Segoe UI Semibold"/>
-              </a:rPr>
-              <a:t> VS AWS</a:t>
+              <a:t>04  —  PROXY: Proposal VS AWS</a:t>
             </a:r>
           </a:p>
         </p:txBody>
@@ -10082,31 +12276,13 @@
           <a:p>
             <a:pPr algn="l"/>
             <a:r>
-              <a:rPr sz="1250" b="0" i="0" dirty="0">
+              <a:rPr sz="1250" b="0">
                 <a:solidFill>
                   <a:srgbClr val="6B6558"/>
                 </a:solidFill>
                 <a:latin typeface="Segoe UI"/>
               </a:rPr>
-              <a:t>Scoped only to the static-IP requirement for </a:t>
-            </a:r>
-            <a:r>
-              <a:rPr sz="1250" b="0" i="0" dirty="0" err="1">
-                <a:solidFill>
-                  <a:srgbClr val="6B6558"/>
-                </a:solidFill>
-                <a:latin typeface="Segoe UI"/>
-              </a:rPr>
-              <a:t>RateHawk</a:t>
-            </a:r>
-            <a:r>
-              <a:rPr sz="1250" b="0" i="0" dirty="0">
-                <a:solidFill>
-                  <a:srgbClr val="6B6558"/>
-                </a:solidFill>
-                <a:latin typeface="Segoe UI"/>
-              </a:rPr>
-              <a:t> ; both columns are real options.</a:t>
+              <a:t>Scoped to the static-IP RateHawk requires for PRODUCTION certification -- sandbox itself needs no whitelisting (confirmed 8/24). Both columns are real options.</a:t>
             </a:r>
           </a:p>
         </p:txBody>
@@ -10170,13 +12346,13 @@
           <a:p>
             <a:pPr algn="r"/>
             <a:r>
-              <a:rPr sz="900" b="0" i="0">
+              <a:rPr sz="900" b="0">
                 <a:solidFill>
                   <a:srgbClr val="9B9384"/>
                 </a:solidFill>
                 <a:latin typeface="Segoe UI"/>
               </a:rPr>
-              <a:t>6</a:t>
+              <a:t>5</a:t>
             </a:r>
           </a:p>
         </p:txBody>
@@ -11369,13 +13545,13 @@
           <a:p>
             <a:pPr algn="l"/>
             <a:r>
-              <a:rPr sz="1200" b="1" i="0">
+              <a:rPr sz="1200" b="1">
                 <a:solidFill>
                   <a:srgbClr val="7A3E0F"/>
                 </a:solidFill>
                 <a:latin typeface="Segoe UI Semibold"/>
               </a:rPr>
-              <a:t>06  —  ALIGNMENT &amp; RECOMMENDATION</a:t>
+              <a:t>05  —  ALIGNMENT &amp; RECOMMENDATION</a:t>
             </a:r>
           </a:p>
         </p:txBody>
@@ -11509,13 +13685,13 @@
           <a:p>
             <a:pPr algn="r"/>
             <a:r>
-              <a:rPr sz="900" b="0" i="0">
+              <a:rPr sz="900" b="0">
                 <a:solidFill>
                   <a:srgbClr val="9B9384"/>
                 </a:solidFill>
                 <a:latin typeface="Segoe UI"/>
               </a:rPr>
-              <a:t>7</a:t>
+              <a:t>6</a:t>
             </a:r>
           </a:p>
         </p:txBody>
@@ -11802,13 +13978,13 @@
           <a:p>
             <a:pPr algn="l"/>
             <a:r>
-              <a:rPr sz="980" b="0" i="0">
+              <a:rPr sz="980" b="0">
                 <a:solidFill>
                   <a:srgbClr val="6B6558"/>
                 </a:solidFill>
                 <a:latin typeface="Segoe UI"/>
               </a:rPr>
-              <a:t>For the actual requirement — a static IP RateHawk will accept — the AWS build is live, verified, and ~$5–8/mo today, with no further engineering or coordination needed. Ivan's fuller proposal is well-designed for a mature, high-traffic system, but adopting it as specified means more infrastructure, more cost, and an unresolved question of who builds and runs it — none of which the actual RateHawk traffic requires right now. Fastest, lowest-risk path to go-live: use what's already built. Revisit Redis/queueing/the full gateway abstraction once real traffic data justifies it — that evolution path stays open either way.</a:t>
+              <a:t>For the actual requirement -- a static IP RateHawk's production certification will accept -- the AWS build is live, verified, and ~$5–8/mo today, with no further engineering needed. Ivan's fuller proposal suits a mature, high-traffic system, but adopting it as specified means more cost and an unresolved question of who runs it -- neither of which certification itself requires. Fastest path: use what's already built and verified.</a:t>
             </a:r>
           </a:p>
         </p:txBody>
@@ -11966,7 +14142,7 @@
                 </a:solidFill>
                 <a:latin typeface="Segoe UI Semibold"/>
               </a:rPr>
-              <a:t>07  —  LIVE DEMO</a:t>
+              <a:t>06  —  LIVE DEMO</a:t>
             </a:r>
           </a:p>
         </p:txBody>
@@ -12106,7 +14282,7 @@
                 </a:solidFill>
                 <a:latin typeface="Segoe UI"/>
               </a:rPr>
-              <a:t>8</a:t>
+              <a:t>7</a:t>
             </a:r>
           </a:p>
         </p:txBody>
@@ -12700,7 +14876,7 @@
                 </a:solidFill>
                 <a:latin typeface="Segoe UI"/>
               </a:rPr>
-              <a:t>08  —  PLANNING</a:t>
+              <a:t>07  —  PLANNING</a:t>
             </a:r>
           </a:p>
         </p:txBody>
@@ -12739,7 +14915,7 @@
                 </a:solidFill>
                 <a:latin typeface="Segoe UI Semibold"/>
               </a:rPr>
-              <a:t>Path to a real sandbox/test build — phased</a:t>
+              <a:t>Certification, build, test, submit -- phased</a:t>
             </a:r>
           </a:p>
         </p:txBody>
@@ -12778,7 +14954,7 @@
                 </a:solidFill>
                 <a:latin typeface="Segoe UI"/>
               </a:rPr>
-              <a:t>Claude does all technical implementation; testing and store-asset design draw on existing team time. Payments and RateHawk are both gated by partners right now, not effort.</a:t>
+              <a:t>Claude does all technical implementation; testing and store-asset design draw on existing team time. RateHawk's certification review and the app store review clocks are the two timelines genuinely outside our control.</a:t>
             </a:r>
           </a:p>
         </p:txBody>
@@ -12856,7 +15032,7 @@
                 </a:solidFill>
                 <a:latin typeface="Segoe UI"/>
               </a:rPr>
-              <a:t>9</a:t>
+              <a:t>8</a:t>
             </a:r>
           </a:p>
         </p:txBody>
@@ -12991,7 +15167,7 @@
                 </a:solidFill>
                 <a:latin typeface="Segoe UI"/>
               </a:rPr>
-              <a:t>PHASE 1 - UNBLOCK</a:t>
+              <a:t>PHASE 1 - CERTIFY</a:t>
             </a:r>
           </a:p>
         </p:txBody>
@@ -13030,7 +15206,7 @@
                 </a:solidFill>
                 <a:latin typeface="Segoe UI Semibold"/>
               </a:rPr>
-              <a:t>Partner-gated, timeline not ours to set</a:t>
+              <a:t>Ours to finish, RateHawk's to review</a:t>
             </a:r>
           </a:p>
         </p:txBody>
@@ -13072,7 +15248,7 @@
                 </a:solidFill>
                 <a:latin typeface="Segoe UI"/>
               </a:rPr>
-              <a:t>NLB-direct payment spec from Hristijan/Ivan (the new critical path — nothing on payments builds further until it lands), RateHawk sandbox key (contract confirmed 8/14, issuance in progress), and Google Play Developer account creation (still not started).</a:t>
+              <a:t>Answer RateHawk's Pre-Certification Checklist in full (payment type, RPM limits, static-data sync, price-parsing field, booking-success signal, full error-handling matrix), submit the AWS static IP for whitelisting, and hand back the real order IDs from the 7 passed test scenarios. RateHawk's own review time after that isn't ours to set.</a:t>
             </a:r>
           </a:p>
         </p:txBody>
@@ -13246,7 +15422,7 @@
                 </a:solidFill>
                 <a:latin typeface="Segoe UI Semibold"/>
               </a:rPr>
-              <a:t>~2–3 weeks once Phase 1 clears  ·  Claude-implemented</a:t>
+              <a:t>~2–3 weeks · Claude-implemented</a:t>
             </a:r>
           </a:p>
         </p:txBody>
@@ -13288,7 +15464,7 @@
                 </a:solidFill>
                 <a:latin typeface="Segoe UI"/>
               </a:rPr>
-              <a:t>Payment gateway built against the NLB-direct spec once it lands (net-new — two earlier attempts were built on wrong assumptions and discarded), RateHawk's mobile-specific room-rate/pre-book/create-order endpoints plus their certification checklist, search-flow wired up, and Apple's OAuth secret configured for the native sign-in code already shipped.</a:t>
+              <a:t>Replace lib/ratehawk.ts's simulated stub with the real prebook → charge → finish sequence, reconciling that RateHawk charges Balkanea's deposit balance while Bankart charges the guest's card. Build the room-by-room guest configurator that search and booking currently lack entirely (multi-file, not small). Apple's OAuth secret + Google Play account (Ray-owned) proceed in parallel.</a:t>
             </a:r>
           </a:p>
         </p:txBody>
@@ -13462,7 +15638,7 @@
                 </a:solidFill>
                 <a:latin typeface="Segoe UI Semibold"/>
               </a:rPr>
-              <a:t>~3–5 days, parallel across existing testers</a:t>
+              <a:t>~1–2 weeks, parallel across existing testers</a:t>
             </a:r>
           </a:p>
         </p:txBody>
@@ -13498,31 +15674,13 @@
               </a:spcAft>
             </a:pPr>
             <a:r>
-              <a:rPr sz="950" b="0" dirty="0">
+              <a:rPr sz="950" b="0">
                 <a:solidFill>
                   <a:srgbClr val="6B6558"/>
                 </a:solidFill>
                 <a:latin typeface="Segoe UI"/>
               </a:rPr>
-              <a:t>Structured QA across auth, search, booking, and payment — spread across the TestFlight testers. Store assets (screenshots, listing copy): ~2–3 days of design time on top of already-</a:t>
-            </a:r>
-            <a:r>
-              <a:rPr sz="950" b="0" dirty="0" err="1">
-                <a:solidFill>
-                  <a:srgbClr val="6B6558"/>
-                </a:solidFill>
-                <a:latin typeface="Segoe UI"/>
-              </a:rPr>
-              <a:t>speced</a:t>
-            </a:r>
-            <a:r>
-              <a:rPr sz="950" b="0" dirty="0">
-                <a:solidFill>
-                  <a:srgbClr val="6B6558"/>
-                </a:solidFill>
-                <a:latin typeface="Segoe UI"/>
-              </a:rPr>
-              <a:t> UI.</a:t>
+              <a:t>Auth, search, and single-room booking + payment are already TestFlight-tested. New coverage once Phase 2 lands: multi-room booking end-to-end, RateHawk's full error-handling matrix (booking_form_expired, rate_not_found, soldout, book_limit, 3ds -- not just the happy path), and a repeat real-money payment run to confirm settlement is clean before certification submission. Store assets (screenshots, listing copy) in parallel -- ~2–3 days on top of already-built UI.</a:t>
             </a:r>
           </a:p>
         </p:txBody>
@@ -13696,7 +15854,7 @@
                 </a:solidFill>
                 <a:latin typeface="Segoe UI Semibold"/>
               </a:rPr>
-              <a:t>~1 month+, both stores + RateHawk cert  ·  estimate</a:t>
+              <a:t>~1 month+, three review clocks running in parallel</a:t>
             </a:r>
           </a:p>
         </p:txBody>
@@ -13738,7 +15896,7 @@
                 </a:solidFill>
                 <a:latin typeface="Segoe UI"/>
               </a:rPr>
-              <a:t>Apple review ~3–5 days (real travel payments = higher scrutiny). Google Play's 14-day mandatory closed-testing period is the long pole. New: RateHawk's own certification (pre-cert checklist + demo access) also gates production API access, running in parallel. Budget at least one rejection-and-resubmit round on each store.</a:t>
+              <a:t>Apple review ~3–5 days (real travel payments = higher scrutiny; budget one rejection-and-resubmit round). Google Play's 14-day mandatory closed-testing period is the long pole, and its clock can't start until the Play Developer account exists. RateHawk moves sandbox → production keys only after certification sign-off, on its own timeline, running alongside store review rather than before it.</a:t>
             </a:r>
           </a:p>
         </p:txBody>
@@ -13806,7 +15964,7 @@
                 </a:solidFill>
                 <a:latin typeface="Segoe UI Semibold"/>
               </a:rPr>
-              <a:t>09  —  ARCHITECTURE</a:t>
+              <a:t>08  —  ARCHITECTURE</a:t>
             </a:r>
           </a:p>
         </p:txBody>
@@ -13876,7 +16034,7 @@
                 </a:solidFill>
                 <a:latin typeface="Segoe UI"/>
               </a:rPr>
-              <a:t>Two boxes are still open — payments, and the admin portal’s WooCommerce-parity gap. The shared static-IP proxy is agreed and shown below, in progress with Ivan.</a:t>
+              <a:t>Payments and RateHawk booking are now verified live, not just treated as such (see Risks for what's still open); the admin portal's WooCommerce-parity gap is the one box still genuinely open below.</a:t>
             </a:r>
           </a:p>
         </p:txBody>
@@ -13946,7 +16104,7 @@
                 </a:solidFill>
                 <a:latin typeface="Segoe UI"/>
               </a:rPr>
-              <a:t>10</a:t>
+              <a:t>9</a:t>
             </a:r>
           </a:p>
         </p:txBody>
@@ -14736,7 +16894,7 @@
                 </a:solidFill>
                 <a:latin typeface="Segoe UI"/>
               </a:rPr>
-              <a:t>Bookings, profiles, payment_reference / payment_state. Migration ready, on hold pending the payment decision.</a:t>
+              <a:t>Bookings, profiles, payment_reference/payment_state (MKD), ratehawk_order_id. Live -- three real bookings written today. New: voucher/invoice PDF fetch + automated confirmation emails via Resend.</a:t>
             </a:r>
           </a:p>
         </p:txBody>
@@ -14855,7 +17013,7 @@
                 </a:solidFill>
                 <a:latin typeface="Segoe UI"/>
               </a:rPr>
-              <a:t>Separate mobile Office (contract "balkanea-mobile", confirmed 8/14). Sandbox key incoming → certification → production key.</a:t>
+              <a:t>Separate mobile Office (contract “balkanea-mobile”). Sandbox key 973 live and verified -- booking mechanics proven end-to-end against certification test hotels. Certification checklist submission is next, then production key.</a:t>
             </a:r>
           </a:p>
         </p:txBody>
@@ -14932,7 +17090,7 @@
             </a:avLst>
           </a:prstGeom>
           <a:solidFill>
-            <a:srgbClr val="FFFFFF"/>
+            <a:srgbClr val="E3EEE9"/>
           </a:solidFill>
           <a:ln w="15875">
             <a:solidFill>
@@ -15029,7 +17187,7 @@
                 </a:solidFill>
                 <a:latin typeface="Segoe UI"/>
               </a:rPr>
-              <a:t>Confirmed 8/14 + 8/18: real debit-via-API works, no WooCommerce order created. Bank-callback bug being fixed (~8/19), then Hristijan delivers the mobile integration spec. Refunds still unbuilt.</a:t>
+              <a:t>Confirmed 8/20: real end-to-end card payment cleared through NLB via Bankart's hosted card form, from the app's own booking flow, settling in MKD. Refunds still unbuilt.</a:t>
             </a:r>
           </a:p>
         </p:txBody>
@@ -15080,11 +17238,11 @@
             <a:r>
               <a:rPr sz="750" b="1">
                 <a:solidFill>
-                  <a:srgbClr val="B8790A"/>
+                  <a:srgbClr val="2E6B57"/>
                 </a:solidFill>
                 <a:latin typeface="Segoe UI Semibold"/>
               </a:rPr>
-              <a:t>IN PROGRESS</a:t>
+              <a:t>LIVE</a:t>
             </a:r>
           </a:p>
         </p:txBody>
@@ -15655,7 +17813,7 @@
             </a:avLst>
           </a:prstGeom>
           <a:solidFill>
-            <a:srgbClr val="FFFFFF"/>
+            <a:srgbClr val="E3EEE9"/>
           </a:solidFill>
           <a:ln w="9525">
             <a:solidFill>
@@ -15717,7 +17875,7 @@
                 </a:solidFill>
                 <a:latin typeface="Segoe UI Semibold"/>
               </a:rPr>
-              <a:t>Stage Server (Proxy)</a:t>
+              <a:t>AWS Relay (static IP)</a:t>
             </a:r>
           </a:p>
         </p:txBody>
@@ -15752,7 +17910,7 @@
                 </a:solidFill>
                 <a:latin typeface="Segoe UI"/>
               </a:rPr>
-              <a:t>Squid/tinyproxy on the existing Linux stage server — shared static IP for RateHawk + NLB outbound calls. Agreed 8/18. Ivan configuring; spec + access request sent.</a:t>
+              <a:t>AWS box in eu-central-1 (Frankfurt) -- static Elastic IP (63.185.27.197), live and verified. Required for RateHawk's production certification; sandbox itself needs no whitelisting.</a:t>
             </a:r>
           </a:p>
         </p:txBody>
@@ -15803,11 +17961,11 @@
             <a:r>
               <a:rPr sz="750" b="1">
                 <a:solidFill>
-                  <a:srgbClr val="B8790A"/>
+                  <a:srgbClr val="2E6B57"/>
                 </a:solidFill>
                 <a:latin typeface="Segoe UI Semibold"/>
               </a:rPr>
-              <a:t>IN PROGRESS</a:t>
+              <a:t>LIVE</a:t>
             </a:r>
           </a:p>
         </p:txBody>

</xml_diff>

<commit_message>
chore: daily sync 2026-08-26
</commit_message>
<xml_diff>
--- a/decks/Balkanea-Mobile-Sandbox-Readiness-Update.pptx
+++ b/decks/Balkanea-Mobile-Sandbox-Readiness-Update.pptx
@@ -17,6 +17,7 @@
     <p:sldId id="261" r:id="rId11"/>
     <p:sldId id="270" r:id="rId19"/>
     <p:sldId id="262" r:id="rId12"/>
+    <p:sldId id="271" r:id="rId20"/>
     <p:sldId id="269" r:id="rId18"/>
     <p:sldId id="263" r:id="rId13"/>
   </p:sldIdLst>
@@ -3229,7 +3230,7 @@
                 </a:solidFill>
                 <a:latin typeface="Segoe UI"/>
               </a:rPr>
-              <a:t>RateHawk sandbox booking and payments are now verified live end-to-end -- three real bookings processed today, including a fixed root-cause payment bug. See Risks for what's still genuinely open. Cost model updated, certification and store submission plan attached.</a:t>
+              <a:t>RateHawk sandbox booking and payments are verified live end-to-end, now with real pricing in the traveler's currency across all three priced regions (LA/Paris/Dubai). See Risks for what's still open. Cost model updated, certification and store submission plan attached.</a:t>
             </a:r>
           </a:p>
         </p:txBody>
@@ -4960,7 +4961,7 @@
                 </a:solidFill>
                 <a:latin typeface="Segoe UI"/>
               </a:rPr>
-              <a:t>•  850K-hotel content DB, region-filtered search</a:t>
+              <a:t>•  850K-hotel content DB + real RateHawk-priced sandbox DB (3 regions), real amenity filtering</a:t>
             </a:r>
           </a:p>
           <a:p>
@@ -4992,7 +4993,7 @@
                 </a:solidFill>
                 <a:latin typeface="Segoe UI"/>
               </a:rPr>
-              <a:t>•  Real Bankart/NLB payment integration + voucher/invoice PDF retrieval</a:t>
+              <a:t>•  Real Bankart/NLB payment integration (correct multi-currency: EUR/USD direct from RateHawk, MKD via peg conversion) + voucher/invoice PDF retrieval</a:t>
             </a:r>
           </a:p>
           <a:p>
@@ -5175,7 +5176,7 @@
                 </a:solidFill>
                 <a:latin typeface="Segoe UI"/>
               </a:rPr>
-              <a:t>Currencies: 9, across 11 countries — a separate locale/pricing display layer, not UI language. (11 countries is the destination-selector count, not a language count.)</a:t>
+              <a:t>Currencies: 9, across 11 countries. For the 3 real-priced regions, EUR/USD come directly from RateHawk (real FX); MKD converts from that real quote via a fixed peg rate.</a:t>
             </a:r>
           </a:p>
         </p:txBody>
@@ -5210,7 +5211,7 @@
                 </a:solidFill>
                 <a:latin typeface="Segoe UI Semibold"/>
               </a:rPr>
-              <a:t>ACTUAL CODEBASE, ~10 WEEKS ELAPSED (first commit 6/18 → 8/25)</a:t>
+              <a:t>ACTUAL CODEBASE, ~10 WEEKS ELAPSED (first commit 6/18 → 8/26)</a:t>
             </a:r>
           </a:p>
         </p:txBody>
@@ -5249,7 +5250,7 @@
                 </a:solidFill>
                 <a:latin typeface="Segoe UI"/>
               </a:rPr>
-              <a:t>Mobile: 17 screens · 12 components · 27 lib modules · ~14,700 lines TS/TSX · 7 migrations · 86 commits</a:t>
+              <a:t>Mobile: 17 screens · 12 components · 27 lib modules · ~14,700 lines TS/TSX · 7 migrations · 92 commits</a:t>
             </a:r>
           </a:p>
           <a:p>
@@ -5265,7 +5266,7 @@
                 </a:solidFill>
                 <a:latin typeface="Segoe UI"/>
               </a:rPr>
-              <a:t>Backend: 12 endpoints · 12 lib modules · ~4,200 lines JS · 73 commits</a:t>
+              <a:t>Backend: 12 endpoints · 12 lib modules · ~4,500 lines JS · 78 commits</a:t>
             </a:r>
           </a:p>
         </p:txBody>
@@ -7627,7 +7628,7 @@
                 </a:solidFill>
                 <a:latin typeface="Segoe UI Semibold"/>
               </a:rPr>
-              <a:t>12  —  RISKS</a:t>
+              <a:t>12  —  PERFORMANCE &amp; SCALE</a:t>
             </a:r>
           </a:p>
         </p:txBody>
@@ -7656,13 +7657,13 @@
           <a:p>
             <a:pPr algn="l"/>
             <a:r>
-              <a:rPr sz="2700" b="1">
+              <a:rPr sz="2700" b="1" i="0">
                 <a:solidFill>
                   <a:srgbClr val="1A1A2E"/>
                 </a:solidFill>
                 <a:latin typeface="Segoe UI Semibold"/>
               </a:rPr>
-              <a:t>What's still open, now that payments and RateHawk are live</a:t>
+              <a:t>The real technical ceiling on today's stack, measured live</a:t>
             </a:r>
           </a:p>
         </p:txBody>
@@ -7691,13 +7692,13 @@
           <a:p>
             <a:pPr algn="l"/>
             <a:r>
-              <a:rPr sz="1350" b="0">
+              <a:rPr sz="1350" b="0" i="0">
                 <a:solidFill>
                   <a:srgbClr val="6B6558"/>
                 </a:solidFill>
                 <a:latin typeface="Segoe UI"/>
               </a:rPr>
-              <a:t>Multi-room booking, real-hotel payments, and RateHawk’s live wiring -- all previously flagged here -- are now built, fixed, and verified as of 8/25. These are the risks that remain.</a:t>
+              <a:t>RateHawk sandbox rate limits measured directly against the live API today. These are SANDBOX limits, not confirmed production ones -- see the note below before treating the ceiling as fixed.</a:t>
             </a:r>
           </a:p>
         </p:txBody>
@@ -7726,7 +7727,7 @@
           <a:p>
             <a:pPr algn="l"/>
             <a:r>
-              <a:rPr sz="900" b="0">
+              <a:rPr sz="900" b="0" i="0">
                 <a:solidFill>
                   <a:srgbClr val="9B9384"/>
                 </a:solidFill>
@@ -7781,7 +7782,7 @@
         <p:spPr>
           <a:xfrm>
             <a:off x="502920" y="2148840"/>
-            <a:ext cx="11183112" cy="932688"/>
+            <a:ext cx="3566160" cy="1417320"/>
           </a:xfrm>
           <a:prstGeom prst="roundRect">
             <a:avLst>
@@ -7828,8 +7829,8 @@
         </p:nvSpPr>
         <p:spPr>
           <a:xfrm>
-            <a:off x="629920" y="2258568"/>
-            <a:ext cx="9466072" cy="201168"/>
+            <a:off x="629920" y="2276856"/>
+            <a:ext cx="3312160" cy="201168"/>
           </a:xfrm>
           <a:prstGeom prst="rect">
             <a:avLst/>
@@ -7844,27 +7845,62 @@
           <a:p>
             <a:pPr algn="l"/>
             <a:r>
-              <a:rPr sz="1150" b="1">
+              <a:rPr sz="1050" b="1" i="0">
+                <a:solidFill>
+                  <a:srgbClr val="7A3E0F"/>
+                </a:solidFill>
+                <a:latin typeface="Segoe UI Semibold"/>
+              </a:rPr>
+              <a:t>search/serp/hotels/</a:t>
+            </a:r>
+          </a:p>
+        </p:txBody>
+      </p:sp>
+      <p:sp>
+        <p:nvSpPr>
+          <p:cNvPr id="9" name="TextBox 8"/>
+          <p:cNvSpPr txBox="1"/>
+          <p:nvPr/>
+        </p:nvSpPr>
+        <p:spPr>
+          <a:xfrm>
+            <a:off x="629920" y="2532888"/>
+            <a:ext cx="3312160" cy="411480"/>
+          </a:xfrm>
+          <a:prstGeom prst="rect">
+            <a:avLst/>
+          </a:prstGeom>
+          <a:noFill/>
+        </p:spPr>
+        <p:txBody>
+          <a:bodyPr wrap="square" lIns="0" rIns="0" tIns="0" bIns="0">
+            <a:spAutoFit/>
+          </a:bodyPr>
+          <a:lstStyle/>
+          <a:p>
+            <a:pPr algn="l"/>
+            <a:r>
+              <a:rPr sz="2600" b="1" i="0">
                 <a:solidFill>
                   <a:srgbClr val="1A1A2E"/>
                 </a:solidFill>
                 <a:latin typeface="Segoe UI Semibold"/>
               </a:rPr>
-              <a:t>RateHawk's sandbox documents (voucher + invoice) return a blank placeholder, not real content</a:t>
-            </a:r>
-          </a:p>
-        </p:txBody>
-      </p:sp>
-      <p:sp>
-        <p:nvSpPr>
-          <p:cNvPr id="9" name="TextBox 8"/>
-          <p:cNvSpPr txBox="1"/>
-          <p:nvPr/>
-        </p:nvSpPr>
-        <p:spPr>
-          <a:xfrm>
-            <a:off x="629920" y="2514600"/>
-            <a:ext cx="10929112" cy="490728"/>
+              <a:t>150 / min</a:t>
+            </a:r>
+          </a:p>
+        </p:txBody>
+      </p:sp>
+      <p:sp>
+        <p:nvSpPr>
+          <p:cNvPr id="10" name="TextBox 9"/>
+          <p:cNvSpPr txBox="1"/>
+          <p:nvPr/>
+        </p:nvSpPr>
+        <p:spPr>
+          <a:xfrm>
+            <a:off x="629920" y="3017520"/>
+            <a:ext cx="3312160" cy="447040"/>
           </a:xfrm>
           <a:prstGeom prst="rect">
             <a:avLst/>
@@ -7879,26 +7915,26 @@
           <a:p>
             <a:pPr algn="l"/>
             <a:r>
-              <a:rPr sz="950" b="0">
+              <a:rPr sz="950" b="0" i="0">
                 <a:solidFill>
                   <a:srgbClr val="6B6558"/>
                 </a:solidFill>
                 <a:latin typeface="Segoe UI"/>
               </a:rPr>
-              <a:t>Fetching both via RateHawk's real document endpoints returns byte-for-byte identical PDFs -- embedded metadata reads 'Acrobat Distiller 6.0 (Windows)', dated 2006-03-06, clearly a generic template, not a generated document. Not a bug in our integration (request/response plumbing verified correct) -- needs re-verification once production RateHawk credentials are active; sandbox may simply have no real content to render.</a:t>
-            </a:r>
-          </a:p>
-        </p:txBody>
-      </p:sp>
-      <p:sp>
-        <p:nvSpPr>
-          <p:cNvPr id="10" name="Rounded Rectangle 9"/>
+              <a:t>Search results list -- ONE call prices a whole region (~250 hotels), not one call per hotel.</a:t>
+            </a:r>
+          </a:p>
+        </p:txBody>
+      </p:sp>
+      <p:sp>
+        <p:nvSpPr>
+          <p:cNvPr id="11" name="Rounded Rectangle 10"/>
           <p:cNvSpPr/>
           <p:nvPr/>
         </p:nvSpPr>
         <p:spPr>
           <a:xfrm>
-            <a:off x="10169652" y="2237740"/>
+            <a:off x="2552700" y="2237740"/>
             <a:ext cx="1414780" cy="182880"/>
           </a:xfrm>
           <a:prstGeom prst="roundRect">
@@ -7907,7 +7943,7 @@
             </a:avLst>
           </a:prstGeom>
           <a:solidFill>
-            <a:srgbClr val="FBEED9"/>
+            <a:srgbClr val="E3EEE9"/>
           </a:solidFill>
           <a:ln>
             <a:noFill/>
@@ -7936,25 +7972,25 @@
             <a:r>
               <a:rPr sz="750" b="1">
                 <a:solidFill>
-                  <a:srgbClr val="B8790A"/>
+                  <a:srgbClr val="2E6B57"/>
                 </a:solidFill>
                 <a:latin typeface="Segoe UI Semibold"/>
               </a:rPr>
-              <a:t>SANDBOX LIMITATION</a:t>
-            </a:r>
-          </a:p>
-        </p:txBody>
-      </p:sp>
-      <p:sp>
-        <p:nvSpPr>
-          <p:cNvPr id="11" name="Rounded Rectangle 10"/>
+              <a:t>HEADROOM</a:t>
+            </a:r>
+          </a:p>
+        </p:txBody>
+      </p:sp>
+      <p:sp>
+        <p:nvSpPr>
+          <p:cNvPr id="12" name="Rounded Rectangle 11"/>
           <p:cNvSpPr/>
           <p:nvPr/>
         </p:nvSpPr>
         <p:spPr>
           <a:xfrm>
-            <a:off x="502920" y="3218688"/>
-            <a:ext cx="11183112" cy="932688"/>
+            <a:off x="4206240" y="2148840"/>
+            <a:ext cx="3566160" cy="1417320"/>
           </a:xfrm>
           <a:prstGeom prst="roundRect">
             <a:avLst>
@@ -7995,14 +8031,14 @@
       </p:sp>
       <p:sp>
         <p:nvSpPr>
-          <p:cNvPr id="12" name="TextBox 11"/>
-          <p:cNvSpPr txBox="1"/>
-          <p:nvPr/>
-        </p:nvSpPr>
-        <p:spPr>
-          <a:xfrm>
-            <a:off x="629920" y="3328416"/>
-            <a:ext cx="9466072" cy="201168"/>
+          <p:cNvPr id="13" name="TextBox 12"/>
+          <p:cNvSpPr txBox="1"/>
+          <p:nvPr/>
+        </p:nvSpPr>
+        <p:spPr>
+          <a:xfrm>
+            <a:off x="4333240" y="2276856"/>
+            <a:ext cx="3312160" cy="201168"/>
           </a:xfrm>
           <a:prstGeom prst="rect">
             <a:avLst/>
@@ -8017,27 +8053,62 @@
           <a:p>
             <a:pPr algn="l"/>
             <a:r>
-              <a:rPr sz="1150" b="1">
+              <a:rPr sz="1050" b="1" i="0">
+                <a:solidFill>
+                  <a:srgbClr val="7A3E0F"/>
+                </a:solidFill>
+                <a:latin typeface="Segoe UI Semibold"/>
+              </a:rPr>
+              <a:t>hotel/prebook/</a:t>
+            </a:r>
+          </a:p>
+        </p:txBody>
+      </p:sp>
+      <p:sp>
+        <p:nvSpPr>
+          <p:cNvPr id="14" name="TextBox 13"/>
+          <p:cNvSpPr txBox="1"/>
+          <p:nvPr/>
+        </p:nvSpPr>
+        <p:spPr>
+          <a:xfrm>
+            <a:off x="4333240" y="2532888"/>
+            <a:ext cx="3312160" cy="411480"/>
+          </a:xfrm>
+          <a:prstGeom prst="rect">
+            <a:avLst/>
+          </a:prstGeom>
+          <a:noFill/>
+        </p:spPr>
+        <p:txBody>
+          <a:bodyPr wrap="square" lIns="0" rIns="0" tIns="0" bIns="0">
+            <a:spAutoFit/>
+          </a:bodyPr>
+          <a:lstStyle/>
+          <a:p>
+            <a:pPr algn="l"/>
+            <a:r>
+              <a:rPr sz="2600" b="1" i="0">
                 <a:solidFill>
                   <a:srgbClr val="1A1A2E"/>
                 </a:solidFill>
                 <a:latin typeface="Segoe UI Semibold"/>
               </a:rPr>
-              <a:t>A reliability bug caused three duplicate real charges today, before being fixed</a:t>
-            </a:r>
-          </a:p>
-        </p:txBody>
-      </p:sp>
-      <p:sp>
-        <p:nvSpPr>
-          <p:cNvPr id="13" name="TextBox 12"/>
-          <p:cNvSpPr txBox="1"/>
-          <p:nvPr/>
-        </p:nvSpPr>
-        <p:spPr>
-          <a:xfrm>
-            <a:off x="629920" y="3584448"/>
-            <a:ext cx="10929112" cy="490728"/>
+              <a:t>30 / min</a:t>
+            </a:r>
+          </a:p>
+        </p:txBody>
+      </p:sp>
+      <p:sp>
+        <p:nvSpPr>
+          <p:cNvPr id="15" name="TextBox 14"/>
+          <p:cNvSpPr txBox="1"/>
+          <p:nvPr/>
+        </p:nvSpPr>
+        <p:spPr>
+          <a:xfrm>
+            <a:off x="4333240" y="3017520"/>
+            <a:ext cx="3312160" cy="447040"/>
           </a:xfrm>
           <a:prstGeom prst="rect">
             <a:avLst/>
@@ -8052,27 +8123,27 @@
           <a:p>
             <a:pPr algn="l"/>
             <a:r>
-              <a:rPr sz="950" b="0">
+              <a:rPr sz="950" b="0" i="0">
                 <a:solidFill>
                   <a:srgbClr val="6B6558"/>
                 </a:solidFill>
                 <a:latin typeface="Segoe UI"/>
               </a:rPr>
-              <a:t>The booking screen could get stuck indefinitely on ‘Confirming with the hotel’ if a step failed after payment had already captured. Because real RateHawk confirmation genuinely takes 90-140+ seconds, this read as frozen; force-quitting and retrying created a brand-new charge each time. Result: three real Bankart charges for one intended test booking -- harmless only because it was a test card. Now fixed (proper error states + a real progress bar); the lesson is this exact bug class is what causes real duplicate charges against a real guest.</a:t>
-            </a:r>
-          </a:p>
-        </p:txBody>
-      </p:sp>
-      <p:sp>
-        <p:nvSpPr>
-          <p:cNvPr id="14" name="Rounded Rectangle 13"/>
+              <a:t>Room lock, right before payment. Comfortable headroom above the booking-flow bottleneck.</a:t>
+            </a:r>
+          </a:p>
+        </p:txBody>
+      </p:sp>
+      <p:sp>
+        <p:nvSpPr>
+          <p:cNvPr id="16" name="Rounded Rectangle 15"/>
           <p:cNvSpPr/>
           <p:nvPr/>
         </p:nvSpPr>
         <p:spPr>
           <a:xfrm>
-            <a:off x="10640822" y="3307588"/>
-            <a:ext cx="943610" cy="182880"/>
+            <a:off x="6256020" y="2237740"/>
+            <a:ext cx="1414780" cy="182880"/>
           </a:xfrm>
           <a:prstGeom prst="roundRect">
             <a:avLst>
@@ -8113,21 +8184,21 @@
                 </a:solidFill>
                 <a:latin typeface="Segoe UI Semibold"/>
               </a:rPr>
-              <a:t>FIXED TODAY</a:t>
-            </a:r>
-          </a:p>
-        </p:txBody>
-      </p:sp>
-      <p:sp>
-        <p:nvSpPr>
-          <p:cNvPr id="15" name="Rounded Rectangle 14"/>
+              <a:t>HEADROOM</a:t>
+            </a:r>
+          </a:p>
+        </p:txBody>
+      </p:sp>
+      <p:sp>
+        <p:nvSpPr>
+          <p:cNvPr id="17" name="Rounded Rectangle 16"/>
           <p:cNvSpPr/>
           <p:nvPr/>
         </p:nvSpPr>
         <p:spPr>
           <a:xfrm>
-            <a:off x="502920" y="4288536"/>
-            <a:ext cx="11183112" cy="932688"/>
+            <a:off x="7909560" y="2148840"/>
+            <a:ext cx="3566160" cy="1417320"/>
           </a:xfrm>
           <a:prstGeom prst="roundRect">
             <a:avLst>
@@ -8168,14 +8239,14 @@
       </p:sp>
       <p:sp>
         <p:nvSpPr>
-          <p:cNvPr id="16" name="TextBox 15"/>
-          <p:cNvSpPr txBox="1"/>
-          <p:nvPr/>
-        </p:nvSpPr>
-        <p:spPr>
-          <a:xfrm>
-            <a:off x="629920" y="4398264"/>
-            <a:ext cx="9466072" cy="201168"/>
+          <p:cNvPr id="18" name="TextBox 17"/>
+          <p:cNvSpPr txBox="1"/>
+          <p:nvPr/>
+        </p:nvSpPr>
+        <p:spPr>
+          <a:xfrm>
+            <a:off x="8036560" y="2276856"/>
+            <a:ext cx="3312160" cy="201168"/>
           </a:xfrm>
           <a:prstGeom prst="rect">
             <a:avLst/>
@@ -8190,27 +8261,62 @@
           <a:p>
             <a:pPr algn="l"/>
             <a:r>
-              <a:rPr sz="1150" b="1">
+              <a:rPr sz="1050" b="1" i="0">
+                <a:solidFill>
+                  <a:srgbClr val="7A3E0F"/>
+                </a:solidFill>
+                <a:latin typeface="Segoe UI Semibold"/>
+              </a:rPr>
+              <a:t>search/hp/</a:t>
+            </a:r>
+          </a:p>
+        </p:txBody>
+      </p:sp>
+      <p:sp>
+        <p:nvSpPr>
+          <p:cNvPr id="19" name="TextBox 18"/>
+          <p:cNvSpPr txBox="1"/>
+          <p:nvPr/>
+        </p:nvSpPr>
+        <p:spPr>
+          <a:xfrm>
+            <a:off x="8036560" y="2532888"/>
+            <a:ext cx="3312160" cy="411480"/>
+          </a:xfrm>
+          <a:prstGeom prst="rect">
+            <a:avLst/>
+          </a:prstGeom>
+          <a:noFill/>
+        </p:spPr>
+        <p:txBody>
+          <a:bodyPr wrap="square" lIns="0" rIns="0" tIns="0" bIns="0">
+            <a:spAutoFit/>
+          </a:bodyPr>
+          <a:lstStyle/>
+          <a:p>
+            <a:pPr algn="l"/>
+            <a:r>
+              <a:rPr sz="2600" b="1" i="0">
                 <a:solidFill>
                   <a:srgbClr val="1A1A2E"/>
                 </a:solidFill>
                 <a:latin typeface="Segoe UI Semibold"/>
               </a:rPr>
-              <a:t>Bankart's hosted card page still isn't mobile-responsive</a:t>
-            </a:r>
-          </a:p>
-        </p:txBody>
-      </p:sp>
-      <p:sp>
-        <p:nvSpPr>
-          <p:cNvPr id="17" name="TextBox 16"/>
-          <p:cNvSpPr txBox="1"/>
-          <p:nvPr/>
-        </p:nvSpPr>
-        <p:spPr>
-          <a:xfrm>
-            <a:off x="629920" y="4654296"/>
-            <a:ext cx="10929112" cy="490728"/>
+              <a:t>10 / min</a:t>
+            </a:r>
+          </a:p>
+        </p:txBody>
+      </p:sp>
+      <p:sp>
+        <p:nvSpPr>
+          <p:cNvPr id="20" name="TextBox 19"/>
+          <p:cNvSpPr txBox="1"/>
+          <p:nvPr/>
+        </p:nvSpPr>
+        <p:spPr>
+          <a:xfrm>
+            <a:off x="8036560" y="3017520"/>
+            <a:ext cx="3312160" cy="447040"/>
           </a:xfrm>
           <a:prstGeom prst="rect">
             <a:avLst/>
@@ -8225,27 +8331,27 @@
           <a:p>
             <a:pPr algn="l"/>
             <a:r>
-              <a:rPr sz="950" b="0">
+              <a:rPr sz="950" b="0" i="0">
                 <a:solidFill>
                   <a:srgbClr val="6B6558"/>
                 </a:solidFill>
                 <a:latin typeface="Segoe UI"/>
               </a:rPr>
-              <a:t>Input fields still misalign on phone and tablet, and the page has no billing-address or independent 'name on card' field (a guest can pay for someone else's booking). A full written spec -- brand colors, autofill attributes, missing fields -- was sent to Hristijan 8/25. Not yet built on his side.</a:t>
-            </a:r>
-          </a:p>
-        </p:txBody>
-      </p:sp>
-      <p:sp>
-        <p:nvSpPr>
-          <p:cNvPr id="18" name="Rounded Rectangle 17"/>
+              <a:t>Single-hotel room rates -- required on room selection AND before every booking. This is the binding constraint.</a:t>
+            </a:r>
+          </a:p>
+        </p:txBody>
+      </p:sp>
+      <p:sp>
+        <p:nvSpPr>
+          <p:cNvPr id="21" name="Rounded Rectangle 20"/>
           <p:cNvSpPr/>
           <p:nvPr/>
         </p:nvSpPr>
         <p:spPr>
           <a:xfrm>
-            <a:off x="10304272" y="4377436"/>
-            <a:ext cx="1280160" cy="182880"/>
+            <a:off x="9959340" y="2237740"/>
+            <a:ext cx="1414780" cy="182880"/>
           </a:xfrm>
           <a:prstGeom prst="roundRect">
             <a:avLst>
@@ -8286,21 +8392,137 @@
                 </a:solidFill>
                 <a:latin typeface="Segoe UI Semibold"/>
               </a:rPr>
-              <a:t>OPEN — HRISTIJAN</a:t>
-            </a:r>
-          </a:p>
-        </p:txBody>
-      </p:sp>
-      <p:sp>
-        <p:nvSpPr>
-          <p:cNvPr id="19" name="Rounded Rectangle 18"/>
+              <a:t>BOTTLENECK</a:t>
+            </a:r>
+          </a:p>
+        </p:txBody>
+      </p:sp>
+      <p:sp>
+        <p:nvSpPr>
+          <p:cNvPr id="22" name="Rounded Rectangle 21"/>
           <p:cNvSpPr/>
           <p:nvPr/>
         </p:nvSpPr>
         <p:spPr>
           <a:xfrm>
-            <a:off x="502920" y="5358384"/>
-            <a:ext cx="11183112" cy="932688"/>
+            <a:off x="502920" y="3749040"/>
+            <a:ext cx="11183112" cy="868680"/>
+          </a:xfrm>
+          <a:prstGeom prst="roundRect">
+            <a:avLst>
+              <a:gd name="adj" fmla="val 12000"/>
+            </a:avLst>
+          </a:prstGeom>
+          <a:solidFill>
+            <a:srgbClr val="FBEED9"/>
+          </a:solidFill>
+          <a:ln>
+            <a:noFill/>
+          </a:ln>
+          <a:effectLst/>
+        </p:spPr>
+        <p:style>
+          <a:lnRef idx="1">
+            <a:schemeClr val="accent1"/>
+          </a:lnRef>
+          <a:fillRef idx="3">
+            <a:schemeClr val="accent1"/>
+          </a:fillRef>
+          <a:effectRef idx="2">
+            <a:schemeClr val="accent1"/>
+          </a:effectRef>
+          <a:fontRef idx="minor">
+            <a:schemeClr val="lt1"/>
+          </a:fontRef>
+        </p:style>
+        <p:txBody>
+          <a:bodyPr rtlCol="0" anchor="ctr"/>
+          <a:lstStyle/>
+          <a:p>
+            <a:pPr algn="ctr"/>
+          </a:p>
+        </p:txBody>
+      </p:sp>
+      <p:sp>
+        <p:nvSpPr>
+          <p:cNvPr id="23" name="TextBox 22"/>
+          <p:cNvSpPr txBox="1"/>
+          <p:nvPr/>
+        </p:nvSpPr>
+        <p:spPr>
+          <a:xfrm>
+            <a:off x="680720" y="3876040"/>
+            <a:ext cx="10789920" cy="274320"/>
+          </a:xfrm>
+          <a:prstGeom prst="rect">
+            <a:avLst/>
+          </a:prstGeom>
+          <a:noFill/>
+        </p:spPr>
+        <p:txBody>
+          <a:bodyPr wrap="square" lIns="0" rIns="0" tIns="0" bIns="0">
+            <a:spAutoFit/>
+          </a:bodyPr>
+          <a:lstStyle/>
+          <a:p>
+            <a:pPr algn="l"/>
+            <a:r>
+              <a:rPr sz="1400" b="1" i="0">
+                <a:solidFill>
+                  <a:srgbClr val="7A3E0F"/>
+                </a:solidFill>
+                <a:latin typeface="Segoe UI Semibold"/>
+              </a:rPr>
+              <a:t>10/min on search/hp/ → 600/hour → ~14,400/day ceiling on real room-rate views, and therefore on bookings, under today's sandbox limits.</a:t>
+            </a:r>
+          </a:p>
+        </p:txBody>
+      </p:sp>
+      <p:sp>
+        <p:nvSpPr>
+          <p:cNvPr id="24" name="TextBox 23"/>
+          <p:cNvSpPr txBox="1"/>
+          <p:nvPr/>
+        </p:nvSpPr>
+        <p:spPr>
+          <a:xfrm>
+            <a:off x="680720" y="4282440"/>
+            <a:ext cx="10789920" cy="365760"/>
+          </a:xfrm>
+          <a:prstGeom prst="rect">
+            <a:avLst/>
+          </a:prstGeom>
+          <a:noFill/>
+        </p:spPr>
+        <p:txBody>
+          <a:bodyPr wrap="square" lIns="0" rIns="0" tIns="0" bIns="0">
+            <a:spAutoFit/>
+          </a:bodyPr>
+          <a:lstStyle/>
+          <a:p>
+            <a:pPr algn="l"/>
+            <a:r>
+              <a:rPr sz="1050" b="0" i="1">
+                <a:solidFill>
+                  <a:srgbClr val="6B6558"/>
+                </a:solidFill>
+                <a:latin typeface="Segoe UI"/>
+              </a:rPr>
+              <a:t>This is a technical ceiling, not a target or a forecast — real booking volume will be governed by guest demand, far below any of these limits.</a:t>
+            </a:r>
+          </a:p>
+        </p:txBody>
+      </p:sp>
+      <p:sp>
+        <p:nvSpPr>
+          <p:cNvPr id="25" name="Rounded Rectangle 24"/>
+          <p:cNvSpPr/>
+          <p:nvPr/>
+        </p:nvSpPr>
+        <p:spPr>
+          <a:xfrm>
+            <a:off x="502920" y="4782312"/>
+            <a:ext cx="5468112" cy="1234440"/>
           </a:xfrm>
           <a:prstGeom prst="roundRect">
             <a:avLst>
@@ -8341,14 +8563,14 @@
       </p:sp>
       <p:sp>
         <p:nvSpPr>
-          <p:cNvPr id="20" name="TextBox 19"/>
-          <p:cNvSpPr txBox="1"/>
-          <p:nvPr/>
-        </p:nvSpPr>
-        <p:spPr>
-          <a:xfrm>
-            <a:off x="629920" y="5468112"/>
-            <a:ext cx="9466072" cy="201168"/>
+          <p:cNvPr id="26" name="TextBox 25"/>
+          <p:cNvSpPr txBox="1"/>
+          <p:nvPr/>
+        </p:nvSpPr>
+        <p:spPr>
+          <a:xfrm>
+            <a:off x="629920" y="4892040"/>
+            <a:ext cx="3751072" cy="219456"/>
           </a:xfrm>
           <a:prstGeom prst="rect">
             <a:avLst/>
@@ -8363,27 +8585,27 @@
           <a:p>
             <a:pPr algn="l"/>
             <a:r>
-              <a:rPr sz="1150" b="1">
+              <a:rPr sz="1250" b="1" i="0">
                 <a:solidFill>
                   <a:srgbClr val="1A1A2E"/>
                 </a:solidFill>
                 <a:latin typeface="Segoe UI Semibold"/>
               </a:rPr>
-              <a:t>Business-team booking notification email is hardcoded to a placeholder address</a:t>
-            </a:r>
-          </a:p>
-        </p:txBody>
-      </p:sp>
-      <p:sp>
-        <p:nvSpPr>
-          <p:cNvPr id="21" name="TextBox 20"/>
-          <p:cNvSpPr txBox="1"/>
-          <p:nvPr/>
-        </p:nvSpPr>
-        <p:spPr>
-          <a:xfrm>
-            <a:off x="629920" y="5724144"/>
-            <a:ext cx="10929112" cy="490728"/>
+              <a:t>Database: comfortable headroom</a:t>
+            </a:r>
+          </a:p>
+        </p:txBody>
+      </p:sp>
+      <p:sp>
+        <p:nvSpPr>
+          <p:cNvPr id="27" name="TextBox 26"/>
+          <p:cNvSpPr txBox="1"/>
+          <p:nvPr/>
+        </p:nvSpPr>
+        <p:spPr>
+          <a:xfrm>
+            <a:off x="629920" y="5166360"/>
+            <a:ext cx="5214112" cy="774192"/>
           </a:xfrm>
           <a:prstGeom prst="rect">
             <a:avLst/>
@@ -8398,27 +8620,200 @@
           <a:p>
             <a:pPr algn="l"/>
             <a:r>
-              <a:rPr sz="950" b="0">
+              <a:rPr sz="1000" b="0" i="0">
                 <a:solidFill>
                   <a:srgbClr val="6B6558"/>
                 </a:solidFill>
                 <a:latin typeface="Segoe UI"/>
               </a:rPr>
-              <a:t>New today: confirmed real RateHawk bookings now trigger automated emails -- the guest gets their voucher PDF, the business team gets the invoice PDF (Resend). The business recipient is currently hardcoded to Ray's own address as a placeholder, not a real shared team inbox -- needs to move before this is production-ready.</a:t>
-            </a:r>
-          </a:p>
-        </p:txBody>
-      </p:sp>
-      <p:sp>
-        <p:nvSpPr>
-          <p:cNvPr id="22" name="Rounded Rectangle 21"/>
+              <a:t>Supabase Postgres allows 120 concurrent connections; each Vercel function instance currently pools at most 3. Not a near-term constraint at any traffic level discussed here.</a:t>
+            </a:r>
+          </a:p>
+        </p:txBody>
+      </p:sp>
+      <p:sp>
+        <p:nvSpPr>
+          <p:cNvPr id="28" name="Rounded Rectangle 27"/>
           <p:cNvSpPr/>
           <p:nvPr/>
         </p:nvSpPr>
         <p:spPr>
           <a:xfrm>
-            <a:off x="10640822" y="5447284"/>
-            <a:ext cx="943610" cy="182880"/>
+            <a:off x="4589272" y="4871212"/>
+            <a:ext cx="1280160" cy="182880"/>
+          </a:xfrm>
+          <a:prstGeom prst="roundRect">
+            <a:avLst>
+              <a:gd name="adj" fmla="val 50000"/>
+            </a:avLst>
+          </a:prstGeom>
+          <a:solidFill>
+            <a:srgbClr val="E3EEE9"/>
+          </a:solidFill>
+          <a:ln>
+            <a:noFill/>
+          </a:ln>
+          <a:effectLst/>
+        </p:spPr>
+        <p:style>
+          <a:lnRef idx="1">
+            <a:schemeClr val="accent1"/>
+          </a:lnRef>
+          <a:fillRef idx="3">
+            <a:schemeClr val="accent1"/>
+          </a:fillRef>
+          <a:effectRef idx="2">
+            <a:schemeClr val="accent1"/>
+          </a:effectRef>
+          <a:fontRef idx="minor">
+            <a:schemeClr val="lt1"/>
+          </a:fontRef>
+        </p:style>
+        <p:txBody>
+          <a:bodyPr rtlCol="0" anchor="ctr" lIns="0" rIns="0" tIns="0" bIns="0"/>
+          <a:lstStyle/>
+          <a:p>
+            <a:pPr algn="ctr"/>
+            <a:r>
+              <a:rPr sz="750" b="1">
+                <a:solidFill>
+                  <a:srgbClr val="2E6B57"/>
+                </a:solidFill>
+                <a:latin typeface="Segoe UI Semibold"/>
+              </a:rPr>
+              <a:t>NOT A CONSTRAINT</a:t>
+            </a:r>
+          </a:p>
+        </p:txBody>
+      </p:sp>
+      <p:sp>
+        <p:nvSpPr>
+          <p:cNvPr id="29" name="Rounded Rectangle 28"/>
+          <p:cNvSpPr/>
+          <p:nvPr/>
+        </p:nvSpPr>
+        <p:spPr>
+          <a:xfrm>
+            <a:off x="6217920" y="4782312"/>
+            <a:ext cx="5468112" cy="1234440"/>
+          </a:xfrm>
+          <a:prstGeom prst="roundRect">
+            <a:avLst>
+              <a:gd name="adj" fmla="val 9000"/>
+            </a:avLst>
+          </a:prstGeom>
+          <a:solidFill>
+            <a:srgbClr val="FFFFFF"/>
+          </a:solidFill>
+          <a:ln w="9525">
+            <a:solidFill>
+              <a:srgbClr val="E7E0D3"/>
+            </a:solidFill>
+          </a:ln>
+          <a:effectLst/>
+        </p:spPr>
+        <p:style>
+          <a:lnRef idx="1">
+            <a:schemeClr val="accent1"/>
+          </a:lnRef>
+          <a:fillRef idx="3">
+            <a:schemeClr val="accent1"/>
+          </a:fillRef>
+          <a:effectRef idx="2">
+            <a:schemeClr val="accent1"/>
+          </a:effectRef>
+          <a:fontRef idx="minor">
+            <a:schemeClr val="lt1"/>
+          </a:fontRef>
+        </p:style>
+        <p:txBody>
+          <a:bodyPr rtlCol="0" anchor="ctr"/>
+          <a:lstStyle/>
+          <a:p>
+            <a:pPr algn="ctr"/>
+          </a:p>
+        </p:txBody>
+      </p:sp>
+      <p:sp>
+        <p:nvSpPr>
+          <p:cNvPr id="30" name="TextBox 29"/>
+          <p:cNvSpPr txBox="1"/>
+          <p:nvPr/>
+        </p:nvSpPr>
+        <p:spPr>
+          <a:xfrm>
+            <a:off x="6344920" y="4892040"/>
+            <a:ext cx="3751072" cy="219456"/>
+          </a:xfrm>
+          <a:prstGeom prst="rect">
+            <a:avLst/>
+          </a:prstGeom>
+          <a:noFill/>
+        </p:spPr>
+        <p:txBody>
+          <a:bodyPr wrap="square" lIns="0" rIns="0" tIns="0" bIns="0">
+            <a:spAutoFit/>
+          </a:bodyPr>
+          <a:lstStyle/>
+          <a:p>
+            <a:pPr algn="l"/>
+            <a:r>
+              <a:rPr sz="1250" b="1" i="0">
+                <a:solidFill>
+                  <a:srgbClr val="1A1A2E"/>
+                </a:solidFill>
+                <a:latin typeface="Segoe UI Semibold"/>
+              </a:rPr>
+              <a:t>Infra tier: Vercel Hobby plan</a:t>
+            </a:r>
+          </a:p>
+        </p:txBody>
+      </p:sp>
+      <p:sp>
+        <p:nvSpPr>
+          <p:cNvPr id="31" name="TextBox 30"/>
+          <p:cNvSpPr txBox="1"/>
+          <p:nvPr/>
+        </p:nvSpPr>
+        <p:spPr>
+          <a:xfrm>
+            <a:off x="6344920" y="5166360"/>
+            <a:ext cx="5214112" cy="774192"/>
+          </a:xfrm>
+          <a:prstGeom prst="rect">
+            <a:avLst/>
+          </a:prstGeom>
+          <a:noFill/>
+        </p:spPr>
+        <p:txBody>
+          <a:bodyPr wrap="square" lIns="0" rIns="0" tIns="0" bIns="0">
+            <a:spAutoFit/>
+          </a:bodyPr>
+          <a:lstStyle/>
+          <a:p>
+            <a:pPr algn="l"/>
+            <a:r>
+              <a:rPr sz="1000" b="0" i="0">
+                <a:solidFill>
+                  <a:srgbClr val="6B6558"/>
+                </a:solidFill>
+                <a:latin typeface="Segoe UI"/>
+              </a:rPr>
+              <a:t>Fine for the current testing phase -- no verified request/day figure exists for it, so none is claimed here. Real pre-launch item: Hobby has no SLA and stricter usage limits than Pro; upgrade before real production traffic.</a:t>
+            </a:r>
+          </a:p>
+        </p:txBody>
+      </p:sp>
+      <p:sp>
+        <p:nvSpPr>
+          <p:cNvPr id="32" name="Rounded Rectangle 31"/>
+          <p:cNvSpPr/>
+          <p:nvPr/>
+        </p:nvSpPr>
+        <p:spPr>
+          <a:xfrm>
+            <a:off x="10371582" y="4871212"/>
+            <a:ext cx="1212850" cy="182880"/>
           </a:xfrm>
           <a:prstGeom prst="roundRect">
             <a:avLst>
@@ -8459,7 +8854,7 @@
                 </a:solidFill>
                 <a:latin typeface="Segoe UI Semibold"/>
               </a:rPr>
-              <a:t>PLACEHOLDER</a:t>
+              <a:t>PRE-LAUNCH ITEM</a:t>
             </a:r>
           </a:p>
         </p:txBody>
@@ -8473,6 +8868,899 @@
 </file>
 
 <file path=ppt/slides/slide14.xml><?xml version="1.0" encoding="utf-8"?>
+<p:sld xmlns:a="http://schemas.openxmlformats.org/drawingml/2006/main" xmlns:p="http://schemas.openxmlformats.org/presentationml/2006/main" xmlns:r="http://schemas.openxmlformats.org/officeDocument/2006/relationships">
+  <p:cSld>
+    <p:bg>
+      <p:bgPr>
+        <a:solidFill>
+          <a:srgbClr val="FAF7F2"/>
+        </a:solidFill>
+        <a:effectLst/>
+      </p:bgPr>
+    </p:bg>
+    <p:spTree>
+      <p:nvGrpSpPr>
+        <p:cNvPr id="1" name=""/>
+        <p:cNvGrpSpPr/>
+        <p:nvPr/>
+      </p:nvGrpSpPr>
+      <p:grpSpPr/>
+      <p:sp>
+        <p:nvSpPr>
+          <p:cNvPr id="2" name="TextBox 1"/>
+          <p:cNvSpPr txBox="1"/>
+          <p:nvPr/>
+        </p:nvSpPr>
+        <p:spPr>
+          <a:xfrm>
+            <a:off x="502920" y="457200"/>
+            <a:ext cx="11183112" cy="320040"/>
+          </a:xfrm>
+          <a:prstGeom prst="rect">
+            <a:avLst/>
+          </a:prstGeom>
+          <a:noFill/>
+        </p:spPr>
+        <p:txBody>
+          <a:bodyPr wrap="square" lIns="0" rIns="0" tIns="0" bIns="0">
+            <a:spAutoFit/>
+          </a:bodyPr>
+          <a:lstStyle/>
+          <a:p>
+            <a:pPr algn="l"/>
+            <a:r>
+              <a:rPr sz="1200" b="1">
+                <a:solidFill>
+                  <a:srgbClr val="7A3E0F"/>
+                </a:solidFill>
+                <a:latin typeface="Segoe UI Semibold"/>
+              </a:rPr>
+              <a:t>13  —  RISKS</a:t>
+            </a:r>
+          </a:p>
+        </p:txBody>
+      </p:sp>
+      <p:sp>
+        <p:nvSpPr>
+          <p:cNvPr id="3" name="TextBox 2"/>
+          <p:cNvSpPr txBox="1"/>
+          <p:nvPr/>
+        </p:nvSpPr>
+        <p:spPr>
+          <a:xfrm>
+            <a:off x="502920" y="749808"/>
+            <a:ext cx="11183112" cy="640080"/>
+          </a:xfrm>
+          <a:prstGeom prst="rect">
+            <a:avLst/>
+          </a:prstGeom>
+          <a:noFill/>
+        </p:spPr>
+        <p:txBody>
+          <a:bodyPr wrap="square" lIns="0" rIns="0" tIns="0" bIns="0">
+            <a:spAutoFit/>
+          </a:bodyPr>
+          <a:lstStyle/>
+          <a:p>
+            <a:pPr algn="l"/>
+            <a:r>
+              <a:rPr sz="2700" b="1">
+                <a:solidFill>
+                  <a:srgbClr val="1A1A2E"/>
+                </a:solidFill>
+                <a:latin typeface="Segoe UI Semibold"/>
+              </a:rPr>
+              <a:t>What's still open, now that payments and RateHawk are live</a:t>
+            </a:r>
+          </a:p>
+        </p:txBody>
+      </p:sp>
+      <p:sp>
+        <p:nvSpPr>
+          <p:cNvPr id="4" name="TextBox 3"/>
+          <p:cNvSpPr txBox="1"/>
+          <p:nvPr/>
+        </p:nvSpPr>
+        <p:spPr>
+          <a:xfrm>
+            <a:off x="502920" y="1417320"/>
+            <a:ext cx="10799064" cy="502920"/>
+          </a:xfrm>
+          <a:prstGeom prst="rect">
+            <a:avLst/>
+          </a:prstGeom>
+          <a:noFill/>
+        </p:spPr>
+        <p:txBody>
+          <a:bodyPr wrap="square" lIns="0" rIns="0" tIns="0" bIns="0">
+            <a:spAutoFit/>
+          </a:bodyPr>
+          <a:lstStyle/>
+          <a:p>
+            <a:pPr algn="l"/>
+            <a:r>
+              <a:rPr sz="1350" b="0">
+                <a:solidFill>
+                  <a:srgbClr val="6B6558"/>
+                </a:solidFill>
+                <a:latin typeface="Segoe UI"/>
+              </a:rPr>
+              <a:t>Multi-room booking, real-hotel payments, and RateHawk’s live wiring -- all previously flagged here -- are now built, fixed, and verified as of 8/25. These are the risks that remain.</a:t>
+            </a:r>
+          </a:p>
+        </p:txBody>
+      </p:sp>
+      <p:sp>
+        <p:nvSpPr>
+          <p:cNvPr id="5" name="TextBox 4"/>
+          <p:cNvSpPr txBox="1"/>
+          <p:nvPr/>
+        </p:nvSpPr>
+        <p:spPr>
+          <a:xfrm>
+            <a:off x="502920" y="6528816"/>
+            <a:ext cx="7315200" cy="274320"/>
+          </a:xfrm>
+          <a:prstGeom prst="rect">
+            <a:avLst/>
+          </a:prstGeom>
+          <a:noFill/>
+        </p:spPr>
+        <p:txBody>
+          <a:bodyPr wrap="square" lIns="0" rIns="0" tIns="0" bIns="0">
+            <a:spAutoFit/>
+          </a:bodyPr>
+          <a:lstStyle/>
+          <a:p>
+            <a:pPr algn="l"/>
+            <a:r>
+              <a:rPr sz="900" b="0">
+                <a:solidFill>
+                  <a:srgbClr val="9B9384"/>
+                </a:solidFill>
+                <a:latin typeface="Segoe UI"/>
+              </a:rPr>
+              <a:t>BALKANEA MOBILE  —  SANDBOX / TEST READINESS</a:t>
+            </a:r>
+          </a:p>
+        </p:txBody>
+      </p:sp>
+      <p:sp>
+        <p:nvSpPr>
+          <p:cNvPr id="6" name="TextBox 5"/>
+          <p:cNvSpPr txBox="1"/>
+          <p:nvPr/>
+        </p:nvSpPr>
+        <p:spPr>
+          <a:xfrm>
+            <a:off x="10771632" y="6528816"/>
+            <a:ext cx="914400" cy="274320"/>
+          </a:xfrm>
+          <a:prstGeom prst="rect">
+            <a:avLst/>
+          </a:prstGeom>
+          <a:noFill/>
+        </p:spPr>
+        <p:txBody>
+          <a:bodyPr wrap="square" lIns="0" rIns="0" tIns="0" bIns="0">
+            <a:spAutoFit/>
+          </a:bodyPr>
+          <a:lstStyle/>
+          <a:p>
+            <a:pPr algn="r"/>
+            <a:r>
+              <a:rPr sz="900" b="0">
+                <a:solidFill>
+                  <a:srgbClr val="9B9384"/>
+                </a:solidFill>
+                <a:latin typeface="Segoe UI"/>
+              </a:rPr>
+              <a:t>14</a:t>
+            </a:r>
+          </a:p>
+        </p:txBody>
+      </p:sp>
+      <p:sp>
+        <p:nvSpPr>
+          <p:cNvPr id="7" name="Rounded Rectangle 6"/>
+          <p:cNvSpPr/>
+          <p:nvPr/>
+        </p:nvSpPr>
+        <p:spPr>
+          <a:xfrm>
+            <a:off x="502920" y="2148840"/>
+            <a:ext cx="11183112" cy="932688"/>
+          </a:xfrm>
+          <a:prstGeom prst="roundRect">
+            <a:avLst>
+              <a:gd name="adj" fmla="val 9000"/>
+            </a:avLst>
+          </a:prstGeom>
+          <a:solidFill>
+            <a:srgbClr val="FFFFFF"/>
+          </a:solidFill>
+          <a:ln w="9525">
+            <a:solidFill>
+              <a:srgbClr val="E7E0D3"/>
+            </a:solidFill>
+          </a:ln>
+          <a:effectLst/>
+        </p:spPr>
+        <p:style>
+          <a:lnRef idx="1">
+            <a:schemeClr val="accent1"/>
+          </a:lnRef>
+          <a:fillRef idx="3">
+            <a:schemeClr val="accent1"/>
+          </a:fillRef>
+          <a:effectRef idx="2">
+            <a:schemeClr val="accent1"/>
+          </a:effectRef>
+          <a:fontRef idx="minor">
+            <a:schemeClr val="lt1"/>
+          </a:fontRef>
+        </p:style>
+        <p:txBody>
+          <a:bodyPr rtlCol="0" anchor="ctr"/>
+          <a:lstStyle/>
+          <a:p>
+            <a:pPr algn="ctr"/>
+          </a:p>
+        </p:txBody>
+      </p:sp>
+      <p:sp>
+        <p:nvSpPr>
+          <p:cNvPr id="8" name="TextBox 7"/>
+          <p:cNvSpPr txBox="1"/>
+          <p:nvPr/>
+        </p:nvSpPr>
+        <p:spPr>
+          <a:xfrm>
+            <a:off x="629920" y="2258568"/>
+            <a:ext cx="9466072" cy="201168"/>
+          </a:xfrm>
+          <a:prstGeom prst="rect">
+            <a:avLst/>
+          </a:prstGeom>
+          <a:noFill/>
+        </p:spPr>
+        <p:txBody>
+          <a:bodyPr wrap="square" lIns="0" rIns="0" tIns="0" bIns="0">
+            <a:spAutoFit/>
+          </a:bodyPr>
+          <a:lstStyle/>
+          <a:p>
+            <a:pPr algn="l"/>
+            <a:r>
+              <a:rPr sz="1150" b="1">
+                <a:solidFill>
+                  <a:srgbClr val="1A1A2E"/>
+                </a:solidFill>
+                <a:latin typeface="Segoe UI Semibold"/>
+              </a:rPr>
+              <a:t>RateHawk's sandbox documents (voucher + invoice) return a blank placeholder, not real content</a:t>
+            </a:r>
+          </a:p>
+        </p:txBody>
+      </p:sp>
+      <p:sp>
+        <p:nvSpPr>
+          <p:cNvPr id="9" name="TextBox 8"/>
+          <p:cNvSpPr txBox="1"/>
+          <p:nvPr/>
+        </p:nvSpPr>
+        <p:spPr>
+          <a:xfrm>
+            <a:off x="629920" y="2514600"/>
+            <a:ext cx="10929112" cy="490728"/>
+          </a:xfrm>
+          <a:prstGeom prst="rect">
+            <a:avLst/>
+          </a:prstGeom>
+          <a:noFill/>
+        </p:spPr>
+        <p:txBody>
+          <a:bodyPr wrap="square" lIns="0" rIns="0" tIns="0" bIns="0">
+            <a:spAutoFit/>
+          </a:bodyPr>
+          <a:lstStyle/>
+          <a:p>
+            <a:pPr algn="l"/>
+            <a:r>
+              <a:rPr sz="950" b="0">
+                <a:solidFill>
+                  <a:srgbClr val="6B6558"/>
+                </a:solidFill>
+                <a:latin typeface="Segoe UI"/>
+              </a:rPr>
+              <a:t>Fetching both via RateHawk's real document endpoints returns byte-for-byte identical PDFs -- embedded metadata reads 'Acrobat Distiller 6.0 (Windows)', dated 2006-03-06, clearly a generic template, not a generated document. Not a bug in our integration (request/response plumbing verified correct) -- needs re-verification once production RateHawk credentials are active; sandbox may simply have no real content to render.</a:t>
+            </a:r>
+          </a:p>
+        </p:txBody>
+      </p:sp>
+      <p:sp>
+        <p:nvSpPr>
+          <p:cNvPr id="10" name="Rounded Rectangle 9"/>
+          <p:cNvSpPr/>
+          <p:nvPr/>
+        </p:nvSpPr>
+        <p:spPr>
+          <a:xfrm>
+            <a:off x="10169652" y="2237740"/>
+            <a:ext cx="1414780" cy="182880"/>
+          </a:xfrm>
+          <a:prstGeom prst="roundRect">
+            <a:avLst>
+              <a:gd name="adj" fmla="val 50000"/>
+            </a:avLst>
+          </a:prstGeom>
+          <a:solidFill>
+            <a:srgbClr val="FBEED9"/>
+          </a:solidFill>
+          <a:ln>
+            <a:noFill/>
+          </a:ln>
+          <a:effectLst/>
+        </p:spPr>
+        <p:style>
+          <a:lnRef idx="1">
+            <a:schemeClr val="accent1"/>
+          </a:lnRef>
+          <a:fillRef idx="3">
+            <a:schemeClr val="accent1"/>
+          </a:fillRef>
+          <a:effectRef idx="2">
+            <a:schemeClr val="accent1"/>
+          </a:effectRef>
+          <a:fontRef idx="minor">
+            <a:schemeClr val="lt1"/>
+          </a:fontRef>
+        </p:style>
+        <p:txBody>
+          <a:bodyPr rtlCol="0" anchor="ctr" lIns="0" rIns="0" tIns="0" bIns="0"/>
+          <a:lstStyle/>
+          <a:p>
+            <a:pPr algn="ctr"/>
+            <a:r>
+              <a:rPr sz="750" b="1">
+                <a:solidFill>
+                  <a:srgbClr val="B8790A"/>
+                </a:solidFill>
+                <a:latin typeface="Segoe UI Semibold"/>
+              </a:rPr>
+              <a:t>SANDBOX LIMITATION</a:t>
+            </a:r>
+          </a:p>
+        </p:txBody>
+      </p:sp>
+      <p:sp>
+        <p:nvSpPr>
+          <p:cNvPr id="11" name="Rounded Rectangle 10"/>
+          <p:cNvSpPr/>
+          <p:nvPr/>
+        </p:nvSpPr>
+        <p:spPr>
+          <a:xfrm>
+            <a:off x="502920" y="3218688"/>
+            <a:ext cx="11183112" cy="932688"/>
+          </a:xfrm>
+          <a:prstGeom prst="roundRect">
+            <a:avLst>
+              <a:gd name="adj" fmla="val 9000"/>
+            </a:avLst>
+          </a:prstGeom>
+          <a:solidFill>
+            <a:srgbClr val="FFFFFF"/>
+          </a:solidFill>
+          <a:ln w="9525">
+            <a:solidFill>
+              <a:srgbClr val="E7E0D3"/>
+            </a:solidFill>
+          </a:ln>
+          <a:effectLst/>
+        </p:spPr>
+        <p:style>
+          <a:lnRef idx="1">
+            <a:schemeClr val="accent1"/>
+          </a:lnRef>
+          <a:fillRef idx="3">
+            <a:schemeClr val="accent1"/>
+          </a:fillRef>
+          <a:effectRef idx="2">
+            <a:schemeClr val="accent1"/>
+          </a:effectRef>
+          <a:fontRef idx="minor">
+            <a:schemeClr val="lt1"/>
+          </a:fontRef>
+        </p:style>
+        <p:txBody>
+          <a:bodyPr rtlCol="0" anchor="ctr"/>
+          <a:lstStyle/>
+          <a:p>
+            <a:pPr algn="ctr"/>
+          </a:p>
+        </p:txBody>
+      </p:sp>
+      <p:sp>
+        <p:nvSpPr>
+          <p:cNvPr id="12" name="TextBox 11"/>
+          <p:cNvSpPr txBox="1"/>
+          <p:nvPr/>
+        </p:nvSpPr>
+        <p:spPr>
+          <a:xfrm>
+            <a:off x="629920" y="3328416"/>
+            <a:ext cx="9466072" cy="201168"/>
+          </a:xfrm>
+          <a:prstGeom prst="rect">
+            <a:avLst/>
+          </a:prstGeom>
+          <a:noFill/>
+        </p:spPr>
+        <p:txBody>
+          <a:bodyPr wrap="square" lIns="0" rIns="0" tIns="0" bIns="0">
+            <a:spAutoFit/>
+          </a:bodyPr>
+          <a:lstStyle/>
+          <a:p>
+            <a:pPr algn="l"/>
+            <a:r>
+              <a:rPr sz="1150" b="1">
+                <a:solidFill>
+                  <a:srgbClr val="1A1A2E"/>
+                </a:solidFill>
+                <a:latin typeface="Segoe UI Semibold"/>
+              </a:rPr>
+              <a:t>A reliability bug caused three duplicate real charges today, before being fixed</a:t>
+            </a:r>
+          </a:p>
+        </p:txBody>
+      </p:sp>
+      <p:sp>
+        <p:nvSpPr>
+          <p:cNvPr id="13" name="TextBox 12"/>
+          <p:cNvSpPr txBox="1"/>
+          <p:nvPr/>
+        </p:nvSpPr>
+        <p:spPr>
+          <a:xfrm>
+            <a:off x="629920" y="3584448"/>
+            <a:ext cx="10929112" cy="490728"/>
+          </a:xfrm>
+          <a:prstGeom prst="rect">
+            <a:avLst/>
+          </a:prstGeom>
+          <a:noFill/>
+        </p:spPr>
+        <p:txBody>
+          <a:bodyPr wrap="square" lIns="0" rIns="0" tIns="0" bIns="0">
+            <a:spAutoFit/>
+          </a:bodyPr>
+          <a:lstStyle/>
+          <a:p>
+            <a:pPr algn="l"/>
+            <a:r>
+              <a:rPr sz="950" b="0">
+                <a:solidFill>
+                  <a:srgbClr val="6B6558"/>
+                </a:solidFill>
+                <a:latin typeface="Segoe UI"/>
+              </a:rPr>
+              <a:t>The booking screen could get stuck indefinitely on ‘Confirming with the hotel’ if a step failed after payment had already captured. Because real RateHawk confirmation genuinely takes 90-140+ seconds, this read as frozen; force-quitting and retrying created a brand-new charge each time. Result: three real Bankart charges for one intended test booking -- harmless only because it was a test card. Now fixed (proper error states + a real progress bar); the lesson is this exact bug class is what causes real duplicate charges against a real guest.</a:t>
+            </a:r>
+          </a:p>
+        </p:txBody>
+      </p:sp>
+      <p:sp>
+        <p:nvSpPr>
+          <p:cNvPr id="14" name="Rounded Rectangle 13"/>
+          <p:cNvSpPr/>
+          <p:nvPr/>
+        </p:nvSpPr>
+        <p:spPr>
+          <a:xfrm>
+            <a:off x="10640822" y="3307588"/>
+            <a:ext cx="943610" cy="182880"/>
+          </a:xfrm>
+          <a:prstGeom prst="roundRect">
+            <a:avLst>
+              <a:gd name="adj" fmla="val 50000"/>
+            </a:avLst>
+          </a:prstGeom>
+          <a:solidFill>
+            <a:srgbClr val="E3EEE9"/>
+          </a:solidFill>
+          <a:ln>
+            <a:noFill/>
+          </a:ln>
+          <a:effectLst/>
+        </p:spPr>
+        <p:style>
+          <a:lnRef idx="1">
+            <a:schemeClr val="accent1"/>
+          </a:lnRef>
+          <a:fillRef idx="3">
+            <a:schemeClr val="accent1"/>
+          </a:fillRef>
+          <a:effectRef idx="2">
+            <a:schemeClr val="accent1"/>
+          </a:effectRef>
+          <a:fontRef idx="minor">
+            <a:schemeClr val="lt1"/>
+          </a:fontRef>
+        </p:style>
+        <p:txBody>
+          <a:bodyPr rtlCol="0" anchor="ctr" lIns="0" rIns="0" tIns="0" bIns="0"/>
+          <a:lstStyle/>
+          <a:p>
+            <a:pPr algn="ctr"/>
+            <a:r>
+              <a:rPr sz="750" b="1">
+                <a:solidFill>
+                  <a:srgbClr val="2E6B57"/>
+                </a:solidFill>
+                <a:latin typeface="Segoe UI Semibold"/>
+              </a:rPr>
+              <a:t>FIXED TODAY</a:t>
+            </a:r>
+          </a:p>
+        </p:txBody>
+      </p:sp>
+      <p:sp>
+        <p:nvSpPr>
+          <p:cNvPr id="15" name="Rounded Rectangle 14"/>
+          <p:cNvSpPr/>
+          <p:nvPr/>
+        </p:nvSpPr>
+        <p:spPr>
+          <a:xfrm>
+            <a:off x="502920" y="4288536"/>
+            <a:ext cx="11183112" cy="932688"/>
+          </a:xfrm>
+          <a:prstGeom prst="roundRect">
+            <a:avLst>
+              <a:gd name="adj" fmla="val 9000"/>
+            </a:avLst>
+          </a:prstGeom>
+          <a:solidFill>
+            <a:srgbClr val="FFFFFF"/>
+          </a:solidFill>
+          <a:ln w="9525">
+            <a:solidFill>
+              <a:srgbClr val="E7E0D3"/>
+            </a:solidFill>
+          </a:ln>
+          <a:effectLst/>
+        </p:spPr>
+        <p:style>
+          <a:lnRef idx="1">
+            <a:schemeClr val="accent1"/>
+          </a:lnRef>
+          <a:fillRef idx="3">
+            <a:schemeClr val="accent1"/>
+          </a:fillRef>
+          <a:effectRef idx="2">
+            <a:schemeClr val="accent1"/>
+          </a:effectRef>
+          <a:fontRef idx="minor">
+            <a:schemeClr val="lt1"/>
+          </a:fontRef>
+        </p:style>
+        <p:txBody>
+          <a:bodyPr rtlCol="0" anchor="ctr"/>
+          <a:lstStyle/>
+          <a:p>
+            <a:pPr algn="ctr"/>
+          </a:p>
+        </p:txBody>
+      </p:sp>
+      <p:sp>
+        <p:nvSpPr>
+          <p:cNvPr id="16" name="TextBox 15"/>
+          <p:cNvSpPr txBox="1"/>
+          <p:nvPr/>
+        </p:nvSpPr>
+        <p:spPr>
+          <a:xfrm>
+            <a:off x="629920" y="4398264"/>
+            <a:ext cx="9466072" cy="201168"/>
+          </a:xfrm>
+          <a:prstGeom prst="rect">
+            <a:avLst/>
+          </a:prstGeom>
+          <a:noFill/>
+        </p:spPr>
+        <p:txBody>
+          <a:bodyPr wrap="square" lIns="0" rIns="0" tIns="0" bIns="0">
+            <a:spAutoFit/>
+          </a:bodyPr>
+          <a:lstStyle/>
+          <a:p>
+            <a:pPr algn="l"/>
+            <a:r>
+              <a:rPr sz="1150" b="1">
+                <a:solidFill>
+                  <a:srgbClr val="1A1A2E"/>
+                </a:solidFill>
+                <a:latin typeface="Segoe UI Semibold"/>
+              </a:rPr>
+              <a:t>Bankart's hosted card page still isn't mobile-responsive</a:t>
+            </a:r>
+          </a:p>
+        </p:txBody>
+      </p:sp>
+      <p:sp>
+        <p:nvSpPr>
+          <p:cNvPr id="17" name="TextBox 16"/>
+          <p:cNvSpPr txBox="1"/>
+          <p:nvPr/>
+        </p:nvSpPr>
+        <p:spPr>
+          <a:xfrm>
+            <a:off x="629920" y="4654296"/>
+            <a:ext cx="10929112" cy="490728"/>
+          </a:xfrm>
+          <a:prstGeom prst="rect">
+            <a:avLst/>
+          </a:prstGeom>
+          <a:noFill/>
+        </p:spPr>
+        <p:txBody>
+          <a:bodyPr wrap="square" lIns="0" rIns="0" tIns="0" bIns="0">
+            <a:spAutoFit/>
+          </a:bodyPr>
+          <a:lstStyle/>
+          <a:p>
+            <a:pPr algn="l"/>
+            <a:r>
+              <a:rPr sz="950" b="0">
+                <a:solidFill>
+                  <a:srgbClr val="6B6558"/>
+                </a:solidFill>
+                <a:latin typeface="Segoe UI"/>
+              </a:rPr>
+              <a:t>Input fields still misalign on phone and tablet, and the page has no billing-address or independent 'name on card' field (a guest can pay for someone else's booking). A full written spec -- brand colors, autofill attributes, missing fields -- was sent to Hristijan 8/25. Not yet built on his side.</a:t>
+            </a:r>
+          </a:p>
+        </p:txBody>
+      </p:sp>
+      <p:sp>
+        <p:nvSpPr>
+          <p:cNvPr id="18" name="Rounded Rectangle 17"/>
+          <p:cNvSpPr/>
+          <p:nvPr/>
+        </p:nvSpPr>
+        <p:spPr>
+          <a:xfrm>
+            <a:off x="10304272" y="4377436"/>
+            <a:ext cx="1280160" cy="182880"/>
+          </a:xfrm>
+          <a:prstGeom prst="roundRect">
+            <a:avLst>
+              <a:gd name="adj" fmla="val 50000"/>
+            </a:avLst>
+          </a:prstGeom>
+          <a:solidFill>
+            <a:srgbClr val="FBEED9"/>
+          </a:solidFill>
+          <a:ln>
+            <a:noFill/>
+          </a:ln>
+          <a:effectLst/>
+        </p:spPr>
+        <p:style>
+          <a:lnRef idx="1">
+            <a:schemeClr val="accent1"/>
+          </a:lnRef>
+          <a:fillRef idx="3">
+            <a:schemeClr val="accent1"/>
+          </a:fillRef>
+          <a:effectRef idx="2">
+            <a:schemeClr val="accent1"/>
+          </a:effectRef>
+          <a:fontRef idx="minor">
+            <a:schemeClr val="lt1"/>
+          </a:fontRef>
+        </p:style>
+        <p:txBody>
+          <a:bodyPr rtlCol="0" anchor="ctr" lIns="0" rIns="0" tIns="0" bIns="0"/>
+          <a:lstStyle/>
+          <a:p>
+            <a:pPr algn="ctr"/>
+            <a:r>
+              <a:rPr sz="750" b="1">
+                <a:solidFill>
+                  <a:srgbClr val="B8790A"/>
+                </a:solidFill>
+                <a:latin typeface="Segoe UI Semibold"/>
+              </a:rPr>
+              <a:t>OPEN — HRISTIJAN</a:t>
+            </a:r>
+          </a:p>
+        </p:txBody>
+      </p:sp>
+      <p:sp>
+        <p:nvSpPr>
+          <p:cNvPr id="19" name="Rounded Rectangle 18"/>
+          <p:cNvSpPr/>
+          <p:nvPr/>
+        </p:nvSpPr>
+        <p:spPr>
+          <a:xfrm>
+            <a:off x="502920" y="5358384"/>
+            <a:ext cx="11183112" cy="932688"/>
+          </a:xfrm>
+          <a:prstGeom prst="roundRect">
+            <a:avLst>
+              <a:gd name="adj" fmla="val 9000"/>
+            </a:avLst>
+          </a:prstGeom>
+          <a:solidFill>
+            <a:srgbClr val="FFFFFF"/>
+          </a:solidFill>
+          <a:ln w="9525">
+            <a:solidFill>
+              <a:srgbClr val="E7E0D3"/>
+            </a:solidFill>
+          </a:ln>
+          <a:effectLst/>
+        </p:spPr>
+        <p:style>
+          <a:lnRef idx="1">
+            <a:schemeClr val="accent1"/>
+          </a:lnRef>
+          <a:fillRef idx="3">
+            <a:schemeClr val="accent1"/>
+          </a:fillRef>
+          <a:effectRef idx="2">
+            <a:schemeClr val="accent1"/>
+          </a:effectRef>
+          <a:fontRef idx="minor">
+            <a:schemeClr val="lt1"/>
+          </a:fontRef>
+        </p:style>
+        <p:txBody>
+          <a:bodyPr rtlCol="0" anchor="ctr"/>
+          <a:lstStyle/>
+          <a:p>
+            <a:pPr algn="ctr"/>
+          </a:p>
+        </p:txBody>
+      </p:sp>
+      <p:sp>
+        <p:nvSpPr>
+          <p:cNvPr id="20" name="TextBox 19"/>
+          <p:cNvSpPr txBox="1"/>
+          <p:nvPr/>
+        </p:nvSpPr>
+        <p:spPr>
+          <a:xfrm>
+            <a:off x="629920" y="5468112"/>
+            <a:ext cx="9466072" cy="201168"/>
+          </a:xfrm>
+          <a:prstGeom prst="rect">
+            <a:avLst/>
+          </a:prstGeom>
+          <a:noFill/>
+        </p:spPr>
+        <p:txBody>
+          <a:bodyPr wrap="square" lIns="0" rIns="0" tIns="0" bIns="0">
+            <a:spAutoFit/>
+          </a:bodyPr>
+          <a:lstStyle/>
+          <a:p>
+            <a:pPr algn="l"/>
+            <a:r>
+              <a:rPr sz="1150" b="1">
+                <a:solidFill>
+                  <a:srgbClr val="1A1A2E"/>
+                </a:solidFill>
+                <a:latin typeface="Segoe UI Semibold"/>
+              </a:rPr>
+              <a:t>Business-team booking notification email is hardcoded to a placeholder address</a:t>
+            </a:r>
+          </a:p>
+        </p:txBody>
+      </p:sp>
+      <p:sp>
+        <p:nvSpPr>
+          <p:cNvPr id="21" name="TextBox 20"/>
+          <p:cNvSpPr txBox="1"/>
+          <p:nvPr/>
+        </p:nvSpPr>
+        <p:spPr>
+          <a:xfrm>
+            <a:off x="629920" y="5724144"/>
+            <a:ext cx="10929112" cy="490728"/>
+          </a:xfrm>
+          <a:prstGeom prst="rect">
+            <a:avLst/>
+          </a:prstGeom>
+          <a:noFill/>
+        </p:spPr>
+        <p:txBody>
+          <a:bodyPr wrap="square" lIns="0" rIns="0" tIns="0" bIns="0">
+            <a:spAutoFit/>
+          </a:bodyPr>
+          <a:lstStyle/>
+          <a:p>
+            <a:pPr algn="l"/>
+            <a:r>
+              <a:rPr sz="950" b="0">
+                <a:solidFill>
+                  <a:srgbClr val="6B6558"/>
+                </a:solidFill>
+                <a:latin typeface="Segoe UI"/>
+              </a:rPr>
+              <a:t>New today: confirmed real RateHawk bookings now trigger automated emails -- the guest gets their voucher PDF, the business team gets the invoice PDF (Resend). The business recipient is currently hardcoded to Ray's own address as a placeholder, not a real shared team inbox -- needs to move before this is production-ready.</a:t>
+            </a:r>
+          </a:p>
+        </p:txBody>
+      </p:sp>
+      <p:sp>
+        <p:nvSpPr>
+          <p:cNvPr id="22" name="Rounded Rectangle 21"/>
+          <p:cNvSpPr/>
+          <p:nvPr/>
+        </p:nvSpPr>
+        <p:spPr>
+          <a:xfrm>
+            <a:off x="10640822" y="5447284"/>
+            <a:ext cx="943610" cy="182880"/>
+          </a:xfrm>
+          <a:prstGeom prst="roundRect">
+            <a:avLst>
+              <a:gd name="adj" fmla="val 50000"/>
+            </a:avLst>
+          </a:prstGeom>
+          <a:solidFill>
+            <a:srgbClr val="FBEED9"/>
+          </a:solidFill>
+          <a:ln>
+            <a:noFill/>
+          </a:ln>
+          <a:effectLst/>
+        </p:spPr>
+        <p:style>
+          <a:lnRef idx="1">
+            <a:schemeClr val="accent1"/>
+          </a:lnRef>
+          <a:fillRef idx="3">
+            <a:schemeClr val="accent1"/>
+          </a:fillRef>
+          <a:effectRef idx="2">
+            <a:schemeClr val="accent1"/>
+          </a:effectRef>
+          <a:fontRef idx="minor">
+            <a:schemeClr val="lt1"/>
+          </a:fontRef>
+        </p:style>
+        <p:txBody>
+          <a:bodyPr rtlCol="0" anchor="ctr" lIns="0" rIns="0" tIns="0" bIns="0"/>
+          <a:lstStyle/>
+          <a:p>
+            <a:pPr algn="ctr"/>
+            <a:r>
+              <a:rPr sz="750" b="1">
+                <a:solidFill>
+                  <a:srgbClr val="B8790A"/>
+                </a:solidFill>
+                <a:latin typeface="Segoe UI Semibold"/>
+              </a:rPr>
+              <a:t>PLACEHOLDER</a:t>
+            </a:r>
+          </a:p>
+        </p:txBody>
+      </p:sp>
+    </p:spTree>
+  </p:cSld>
+  <p:clrMapOvr>
+    <a:masterClrMapping/>
+  </p:clrMapOvr>
+</p:sld>
+</file>
+
+<file path=ppt/slides/slide15.xml><?xml version="1.0" encoding="utf-8"?>
 <p:sld xmlns:a="http://schemas.openxmlformats.org/drawingml/2006/main" xmlns:r="http://schemas.openxmlformats.org/officeDocument/2006/relationships" xmlns:p="http://schemas.openxmlformats.org/presentationml/2006/main">
   <p:cSld>
     <p:bg>
@@ -8531,7 +9819,7 @@
                 </a:solidFill>
                 <a:latin typeface="Segoe UI"/>
               </a:rPr>
-              <a:t>13  —  STILL OPEN</a:t>
+              <a:t>14  —  STILL OPEN</a:t>
             </a:r>
           </a:p>
         </p:txBody>
@@ -8693,7 +9981,7 @@
                 </a:solidFill>
                 <a:latin typeface="Segoe UI"/>
               </a:rPr>
-              <a:t>14</a:t>
+              <a:t>15</a:t>
             </a:r>
           </a:p>
         </p:txBody>
@@ -11250,7 +12538,7 @@
                 </a:solidFill>
                 <a:latin typeface="Segoe UI"/>
               </a:rPr>
-              <a:t>Search → prebook → create order → finish now runs successfully against RateHawk's certification test hotels (Conrad LA, Rosa Bell Motel) -- all 7 mandatory scenarios passed, real order IDs captured. Live-app wiring and the room-by-room guest picker UI are both built and verified -- three real bookings processed through the actual app today.</a:t>
+              <a:t>Search → prebook → create order → finish now runs successfully against RateHawk's certification test hotels (Conrad LA, Rosa Bell Motel) -- all 7 mandatory scenarios passed, real order IDs captured. Now fully real-priced (search and room selection) across all 3 regions, in the traveler's real currency.</a:t>
             </a:r>
           </a:p>
         </p:txBody>
@@ -16601,7 +17889,7 @@
                 </a:solidFill>
                 <a:latin typeface="Segoe UI"/>
               </a:rPr>
-              <a:t>Vercel serverless (Node.js). Hotel search proxy, RateHawk mobile workflow (SERP / Prebook / create-order), payment gateway, Salesforce sync.</a:t>
+              <a:t>Vercel serverless (Node.js). Hotel search proxy (real amenity filtering, real multi-currency), RateHawk mobile workflow (SERP / Prebook / create-order), payment gateway, Salesforce sync. CORS gap found and fixed today -- every endpoint had none, silently breaking the whole flow on the web build.</a:t>
             </a:r>
           </a:p>
         </p:txBody>
@@ -16720,7 +18008,7 @@
                 </a:solidFill>
                 <a:latin typeface="Segoe UI"/>
               </a:rPr>
-              <a:t>850,218 hotels / 3.9M rooms, all 10 countries. Region-filtered search, daily refresh from RateHawk dump.</a:t>
+              <a:t>850,218 hotels / 3.9M rooms, all 10 countries. Plus a sibling sandbox schema (same instance): 742 hotels across the 3 regions RateHawk's own sandbox dump actually prices -- real search and room rates, not simulated, as of today.</a:t>
             </a:r>
           </a:p>
         </p:txBody>

</xml_diff>